<commit_message>
Say lesson 3's notes and handout plainly, and fix five slips
The speaker notes lose their compressed phrasing ("the answer was garbage",
"let them drive", "a pattern is a message"), and the handout explains the
terms it used bare: Lagrange duality, a generic contact point, a
linear-algebra backend.

Fixed on the way: the handout's Section 6.1 still called the penalty alpha,
and notebook 3's prose did so seven times; the stability threshold alpha < 2/c
was credited to lesson 2 in a note and in the quiz, though only this handout
derives it; the handout and the closing note spoke of examinable derivations,
which the exam no longer has; a note mentioned students' own projects, which
the course does not set; and a path ran past the margin on page 2.

Co-Authored-By: Claude Opus 5.5 <noreply@anthropic.com>
</commit_message>
<xml_diff>
--- a/Lessons/03_regression/Slides/regression_slides.pptx
+++ b/Lessons/03_regression/Slides/regression_slides.pptx
@@ -576,7 +576,7 @@
             </a:pPr>
             <a:r>
               <a:rPr/>
-              <a:t>Nothing to collect - ask two or three people what they built, and name the recurring mistake if it came up. The recurring mistake to name, if it appeared: fitting the scaler or the imputer before splitting. It is the exact thing lesson 2 warned about, and seeing it in their own work is more instructive than any slide.</a:t>
+              <a:t>Nothing is collected. Ask two or three people what they built. If the common mistake appeared, name it: fitting the scaler or the imputer before splitting the data. It is the exact thing lesson 2 warned about, and seeing it in their own work is more instructive than any slide.</a:t>
             </a:r>
           </a:p>
           <a:p>
@@ -744,7 +744,7 @@
             </a:pPr>
             <a:r>
               <a:rPr/>
-              <a:t>Ask what would change if we minimised absolute error instead. Answer: the fit would follow the bulk of the data and shrug at the outlier - which is what robust regression does, and why it exists.</a:t>
+              <a:t>Ask what would change if we minimised absolute error instead. Answer: the fit would follow the bulk of the data and pay much less attention to the outlier - which is what robust regression (a family of methods built to resist outliers) does, and why it exists.</a:t>
             </a:r>
           </a:p>
         </p:txBody>
@@ -826,7 +826,7 @@
             </a:pPr>
             <a:r>
               <a:rPr/>
-              <a:t>Lesson 1’s habit, applied to regression for the first time. A classifier gets a majority-class baseline before it is allowed to speak; a regression gets the mean.</a:t>
+              <a:t>Lesson 1’s habit, applied to regression for the first time. A classifier gets a majority-class baseline before its score is taken seriously; a regression gets the mean.</a:t>
             </a:r>
           </a:p>
           <a:p>
@@ -1198,7 +1198,7 @@
             </a:pPr>
             <a:r>
               <a:rPr/>
-              <a:t>Also mention the second derivative is X transpose X, which is positive semi-definite, so the cost is convex and any stationary point is global. That is the formal version of “the bowl has one bottom”.</a:t>
+              <a:t>Also mention that the second derivative is X transpose X, which is positive semi-definite (it is never negative in any direction), so the cost is convex and any stationary point is global. That is the formal version of “the bowl has one bottom”.</a:t>
             </a:r>
           </a:p>
         </p:txBody>
@@ -1598,7 +1598,7 @@
             </a:pPr>
             <a:r>
               <a:rPr/>
-              <a:t>For the third, give the number from notebook 3: a coefficient that moves from 9,261 to 45,307 across four random splits of the same dataset. The matrix was invertible every time. The answer was garbage every time.</a:t>
+              <a:t>For the third, give the number from notebook 3: a coefficient that moves from 9,261 to 45,307 across four random splits of the same dataset. The matrix was invertible every time. The coefficients were meaningless every time.</a:t>
             </a:r>
           </a:p>
         </p:txBody>
@@ -1680,7 +1680,7 @@
             </a:pPr>
             <a:r>
               <a:rPr/>
-              <a:t>This is the number behind “nearly redundant”, and it is the most transferable idea in the first half of the lesson.</a:t>
+              <a:t>This is the number behind “nearly redundant”, and it is the idea from the first half of the lesson that is most useful outside it.</a:t>
             </a:r>
           </a:p>
           <a:p>
@@ -1708,7 +1708,7 @@
             </a:pPr>
             <a:r>
               <a:rPr/>
-              <a:t>Then the payoff, which lands twice. For the exact solution, a stretched valley is what makes the inverse enormous and the answer unstable. For gradient descent - next section - one step size has to serve every direction at once, so the steep direction sets the limit and the shallow one crawls. The condition number is, near enough, what sets the iteration count.</a:t>
+              <a:t>Then the consequence, which appears twice. For the exact solution, a stretched valley is what makes the inverse enormous and the answer unstable. For gradient descent - next section - one step size has to serve every direction at once, so the steep direction sets the limit and the shallow one crawls. The condition number is, near enough, what sets the iteration count.</a:t>
             </a:r>
           </a:p>
           <a:p>
@@ -1914,7 +1914,7 @@
             </a:pPr>
             <a:r>
               <a:rPr/>
-              <a:t>Agenda. Flag that this is the first lesson where we fit something, and that regression is a deliberate first choice for three reasons: it has an exact solution, so we can see what fitting means with no machinery in the way; it has an iterative one too, which is the same algorithm that trains neural networks in lesson 9; and its coefficients are readable in the units of the problem.</a:t>
+              <a:t>The agenda. Say that this is the first lesson where we fit a model, and that regression is a deliberate first choice for three reasons: it has an exact solution, so we can see what fitting means with no machinery in the way; it has an iterative one too, which is the same algorithm that trains neural networks in lesson 9; and its coefficients are readable in the units of the problem.</a:t>
             </a:r>
           </a:p>
           <a:p>
@@ -2280,7 +2280,7 @@
             </a:pPr>
             <a:r>
               <a:rPr/>
-              <a:t>Left: the cost against iteration. It drops off a cliff in the first few dozen steps and then flattens into a long tail that is still creeping at 4,000. Point at the flat part and say what it means - the model was essentially fitted very early, and almost all the iterations bought almost nothing.</a:t>
+              <a:t>Left: the cost against iteration. It falls steeply in the first few dozen steps and then flattens into a long tail that is still creeping at 4,000. Point at the flat part and say what it means - the model was essentially fitted very early, and almost all the iterations bought almost nothing.</a:t>
             </a:r>
           </a:p>
           <a:p>
@@ -2418,7 +2418,7 @@
             </a:pPr>
             <a:r>
               <a:rPr/>
-              <a:t>The threshold is not folklore. Lesson 2 derived it: for a bowl of curvature c, convergence requires alpha below 2/c, and with several features the binding constraint is the largest curvature - the largest feature variance.</a:t>
+              <a:t>The threshold is not a rule of thumb. Handout section 4.3 derives it: for a bowl of curvature c, convergence requires alpha below 2/c, and with several features the binding constraint is the largest curvature - the largest feature variance.</a:t>
             </a:r>
           </a:p>
           <a:p>
@@ -2528,21 +2528,21 @@
             </a:pPr>
             <a:r>
               <a:rPr/>
-              <a:t>25 minutes. Let them drive.</a:t>
-            </a:r>
-          </a:p>
-          <a:p>
-            <a:pPr lvl="0" indent="0" marL="0">
-              <a:buNone/>
-            </a:pPr>
-          </a:p>
-          <a:p>
-            <a:pPr lvl="0" indent="0" marL="0">
-              <a:buNone/>
-            </a:pPr>
-            <a:r>
-              <a:rPr/>
-              <a:t>The two moments worth pausing on together. First, the agreement between their four-line normal equation and scikit-learn to twelve decimal places - it lands better than any assurance from the front. Second, the coefficient table at the end, which is the setup for the last section of the lesson.</a:t>
+              <a:t>25 minutes. Let them work through it themselves.</a:t>
+            </a:r>
+          </a:p>
+          <a:p>
+            <a:pPr lvl="0" indent="0" marL="0">
+              <a:buNone/>
+            </a:pPr>
+          </a:p>
+          <a:p>
+            <a:pPr lvl="0" indent="0" marL="0">
+              <a:buNone/>
+            </a:pPr>
+            <a:r>
+              <a:rPr/>
+              <a:t>The two moments worth pausing on together. First, the agreement between their four-line normal equation and scikit-learn to twelve decimal places - it convinces more than any assurance from the lecturer. Second, the coefficient table at the end, which is the setup for the last section of the lesson.</a:t>
             </a:r>
           </a:p>
           <a:p>
@@ -2762,7 +2762,7 @@
             </a:pPr>
             <a:r>
               <a:rPr/>
-              <a:t>Notebook 2 has this dataset: 30 days of measurements, which is deliberately few.</a:t>
+              <a:t>Notebook 2 has this dataset: 30 days of measurements, of which 21 are used for training - deliberately few.</a:t>
             </a:r>
           </a:p>
         </p:txBody>
@@ -3092,7 +3092,7 @@
             </a:pPr>
             <a:r>
               <a:rPr/>
-              <a:t>Give them the habit: after fitting anything, plot the residuals against each feature. A pattern is a message.</a:t>
+              <a:t>Give them the habit: after fitting anything, plot the residuals against each feature. A pattern means the model has missed something.</a:t>
             </a:r>
           </a:p>
         </p:txBody>
@@ -3326,7 +3326,7 @@
             </a:pPr>
             <a:r>
               <a:rPr/>
-              <a:t>Give them the habit explicitly - plot residuals against each feature, every time. A pattern is a message.</a:t>
+              <a:t>Give them the habit explicitly - plot residuals against each feature, every time. A pattern means the model has missed something.</a:t>
             </a:r>
           </a:p>
         </p:txBody>
@@ -4580,7 +4580,7 @@
             </a:pPr>
             <a:r>
               <a:rPr/>
-              <a:t>Two things to point at. The cloud clearly slopes, so a line is a reasonable first guess; and the spread around that slope is wide, which is the 18,000 euros of noise we put in. That spread is the floor: no model, however clever, can predict these prices better than the noise allows.</a:t>
+              <a:t>Two things to point at. The cloud clearly slopes, so a line is a reasonable first guess; and the spread around that slope is wide, which is the 18,000 euros of noise we put in. That spread is a floor: no model, however clever, can predict these prices better than the noise allows.</a:t>
             </a:r>
           </a:p>
           <a:p>
@@ -4690,7 +4690,7 @@
             </a:pPr>
             <a:r>
               <a:rPr/>
-              <a:t>This shape has a name - the bias-variance trade-off - and lesson 5 gives it the treatment it deserves along with the machinery to find the bottom of that curve honestly. Today the point is only that the bottom exists and is not where either extreme is.</a:t>
+              <a:t>This shape has a name - the bias-variance trade-off - and lesson 5 treats it fully, with the tools to find the bottom of that curve honestly. Today the point is only that the bottom exists and is not where either extreme is.</a:t>
             </a:r>
           </a:p>
           <a:p>
@@ -5204,7 +5204,7 @@
             </a:pPr>
             <a:r>
               <a:rPr/>
-              <a:t>Nobody told it which features matter. It was told to keep the total size small, and this is the arrangement that buys the most accuracy per euro of coefficient spent.</a:t>
+              <a:t>Nobody told it which features matter. It was told to keep the total size small, and this is the arrangement that buys the most accuracy for each unit of coefficient size it spends.</a:t>
             </a:r>
           </a:p>
           <a:p>
@@ -5842,7 +5842,7 @@
             </a:pPr>
             <a:r>
               <a:rPr/>
-              <a:t>From notebook 1, and this is the most transferable slide of the lesson.</a:t>
+              <a:t>From notebook 1, and this is the slide of the lesson most useful outside it.</a:t>
             </a:r>
           </a:p>
           <a:p>
@@ -5966,7 +5966,7 @@
             </a:pPr>
             <a:r>
               <a:rPr/>
-              <a:t>Read it as a sentence, then attack it. Is the hundred-and-first square metre really worth what the fiftieth was? Is a garage worth the same in the centre as in the suburbs, where there is street parking anyway?</a:t>
+              <a:t>Read it as a sentence, then question it. Is the hundred-and-first square metre really worth what the fiftieth was? Is a garage worth the same in the centre as in the suburbs, where there is street parking anyway?</a:t>
             </a:r>
           </a:p>
           <a:p>
@@ -6076,7 +6076,7 @@
             </a:pPr>
             <a:r>
               <a:rPr/>
-              <a:t>20 minutes. The collinear section is the one to make sure everyone reaches - it is the argument they will use in their own projects when a stakeholder asks what the model says drives the outcome.</a:t>
+              <a:t>20 minutes. The collinear section is the one to make sure everyone reaches - it is the argument they will need whenever someone asks what a model says drives the outcome.</a:t>
             </a:r>
           </a:p>
           <a:p>
@@ -6172,7 +6172,7 @@
             </a:pPr>
             <a:r>
               <a:rPr/>
-              <a:t>Draw the thread. Lesson 2 prepared data honestly; today we fitted something to it and found that fitting well and explaining well are different goals.</a:t>
+              <a:t>Connect the lessons. Lesson 2 prepared data honestly; today we fitted something to it and found that fitting well and explaining well are different goals.</a:t>
             </a:r>
           </a:p>
           <a:p>
@@ -6214,7 +6214,7 @@
             </a:pPr>
             <a:r>
               <a:rPr/>
-              <a:t>Preview lesson 4 in a sentence: same machinery, but the target becomes a category instead of a number - and that single change turns out to require a different cost function, for a reason that is one of the exam derivations.</a:t>
+              <a:t>Preview lesson 4 in a sentence: same machinery, but the target becomes a category instead of a number - and that single change turns out to require a different cost function, for a reason lesson 4 derives.</a:t>
             </a:r>
           </a:p>
         </p:txBody>
@@ -6310,21 +6310,21 @@
             </a:pPr>
             <a:r>
               <a:rPr/>
-              <a:t>Flag the two tasks that carry the most marks. Task 4 asks them to justify a choice of lambda without looking at the test set, which is genuinely awkward before lesson 5 and is meant to be: the point is to feel the need for cross-validation before being handed it. Task 6 asks which coefficients they trust and why, which is section 7 of the handout applied.</a:t>
-            </a:r>
-          </a:p>
-          <a:p>
-            <a:pPr lvl="0" indent="0" marL="0">
-              <a:buNone/>
-            </a:pPr>
-          </a:p>
-          <a:p>
-            <a:pPr lvl="0" indent="0" marL="0">
-              <a:buNone/>
-            </a:pPr>
-            <a:r>
-              <a:rPr/>
-              <a:t>As always: no marks for accuracy, at the exam or anywhere else.</a:t>
+              <a:t>Point out the two tasks that carry the most marks. Task 4 asks them to justify a choice of lambda without looking at the test set, which is genuinely awkward before lesson 5 and is meant to be: the point is to feel the need for cross-validation before being handed it. Task 6 asks which coefficients they trust and why, which is section 7 of the handout applied.</a:t>
+            </a:r>
+          </a:p>
+          <a:p>
+            <a:pPr lvl="0" indent="0" marL="0">
+              <a:buNone/>
+            </a:pPr>
+          </a:p>
+          <a:p>
+            <a:pPr lvl="0" indent="0" marL="0">
+              <a:buNone/>
+            </a:pPr>
+            <a:r>
+              <a:rPr/>
+              <a:t>As always: at the exam, accuracy alone earns nothing; the reasoning does.</a:t>
             </a:r>
           </a:p>
         </p:txBody>
@@ -6530,7 +6530,7 @@
             </a:pPr>
             <a:r>
               <a:rPr/>
-              <a:t>Then the consequence, which is not optional: squared error is sensitive to outliers, because one absurd value contributes its error squared. Lesson 2’s outlier work is a prerequisite for this lesson, not a preliminary.</a:t>
+              <a:t>Then the consequence, which is not optional: squared error is sensitive to outliers, because one absurd value contributes its error squared. Lesson 2’s work on outliers is needed for this lesson, not an optional warm-up.</a:t>
             </a:r>
           </a:p>
         </p:txBody>

</xml_diff>

<commit_message>
Anchor lesson 3's slides to the code its notebooks run
The three "Notebook N, live" slides now carry a table mapping each notebook
section to its slides, its scikit-learn calls and the number to come back
with, and the concept slides name train_test_split, mean_squared_error (and
that it has no half), DummyRegressor, r2_score, LinearRegression,
PolynomialFeatures and the scaled Ridge pipeline. Lesson 3 joins ANCHORED in
verify_lesson. No slide is added, so the numbering is unchanged.

Co-Authored-By: Claude Opus 5.5 <noreply@anthropic.com>
</commit_message>
<xml_diff>
--- a/Lessons/03_regression/Slides/regression_slides.pptx
+++ b/Lessons/03_regression/Slides/regression_slides.pptx
@@ -2528,7 +2528,7 @@
             </a:pPr>
             <a:r>
               <a:rPr/>
-              <a:t>25 minutes. Let them work through it themselves.</a:t>
+              <a:t>The model, the cost, the exact solution and the iterative one, built from scratch. 25 minutes. Let them work through it themselves.</a:t>
             </a:r>
           </a:p>
           <a:p>
@@ -3788,7 +3788,7 @@
             </a:pPr>
             <a:r>
               <a:rPr/>
-              <a:t>20 minutes. This is the shortest of the three notebooks and the most visual.</a:t>
+              <a:t>Fit the curve, push the degree up, and watch the test error turn. 20 minutes. This is the shortest of the three notebooks and the most visual.</a:t>
             </a:r>
           </a:p>
           <a:p>
@@ -6076,7 +6076,7 @@
             </a:pPr>
             <a:r>
               <a:rPr/>
-              <a:t>20 minutes. The collinear section is the one to make sure everyone reaches - it is the argument they will need whenever someone asks what a model says drives the outcome.</a:t>
+              <a:t>Ridge on the degree-12 fit, the regularisation paths, and the collinear case. 20 minutes. The collinear section is the one to make sure everyone reaches - it is the argument they will need whenever someone asks what a model says drives the outcome.</a:t>
             </a:r>
           </a:p>
           <a:p>
@@ -10398,6 +10398,23 @@
               <a:t>42%</a:t>
             </a:r>
           </a:p>
+          <a:p>
+            <a:pPr lvl="0"/>
+            <a:r>
+              <a:rPr/>
+              <a:t>In code: </a:t>
+            </a:r>
+            <a:r>
+              <a:rPr>
+                <a:latin typeface="Courier"/>
+              </a:rPr>
+              <a:t>mean_squared_error(y, y_pred)</a:t>
+            </a:r>
+            <a:r>
+              <a:rPr/>
+              <a:t>, the mean of the squared errors without the ½</a:t>
+            </a:r>
+          </a:p>
         </p:txBody>
       </p:sp>
     </p:spTree>
@@ -10481,6 +10498,16 @@
               <a:rPr b="1"/>
               <a:t>always predict the mean</a:t>
             </a:r>
+            <a:r>
+              <a:rPr/>
+              <a:t>, </a:t>
+            </a:r>
+            <a:r>
+              <a:rPr>
+                <a:latin typeface="Courier"/>
+              </a:rPr>
+              <a:t>DummyRegressor(strategy="mean")</a:t>
+            </a:r>
           </a:p>
           <a:p>
             <a:pPr lvl="0"/>
@@ -10509,7 +10536,17 @@
             </a:r>
             <a:r>
               <a:rPr/>
-              <a:t> — the same comparison as one ratio, 0 is the mean, 1 is perfect</a:t>
+              <a:t> (</a:t>
+            </a:r>
+            <a:r>
+              <a:rPr>
+                <a:latin typeface="Courier"/>
+              </a:rPr>
+              <a:t>r2_score</a:t>
+            </a:r>
+            <a:r>
+              <a:rPr/>
+              <a:t>) — the same comparison as one ratio, 0 is the mean, 1 is perfect</a:t>
             </a:r>
           </a:p>
           <a:p>
@@ -11201,6 +11238,23 @@
               <a:t> answer</a:t>
             </a:r>
           </a:p>
+          <a:p>
+            <a:pPr lvl="0"/>
+            <a:r>
+              <a:rPr/>
+              <a:t>In code: </a:t>
+            </a:r>
+            <a:r>
+              <a:rPr>
+                <a:latin typeface="Courier"/>
+              </a:rPr>
+              <a:t>LinearRegression().fit(X, y)</a:t>
+            </a:r>
+            <a:r>
+              <a:rPr/>
+              <a:t> solves the same problem</a:t>
+            </a:r>
+          </a:p>
         </p:txBody>
       </p:sp>
     </p:spTree>
@@ -12145,36 +12199,266 @@
           </a:p>
         </p:txBody>
       </p:sp>
-      <p:sp>
-        <p:nvSpPr>
-          <p:cNvPr id="3" name="Content Placeholder 2"/>
-          <p:cNvSpPr>
-            <a:spLocks noGrp="1"/>
-          </p:cNvSpPr>
+      <p:graphicFrame>
+        <p:nvGraphicFramePr>
+          <p:cNvPr id="6" name="Content Placeholder 5"/>
+          <p:cNvGraphicFramePr>
+            <a:graphicFrameLocks noGrp="1"/>
+          </p:cNvGraphicFramePr>
           <p:nvPr>
             <p:ph idx="1"/>
           </p:nvPr>
-        </p:nvSpPr>
-        <p:spPr>
-          <a:xfrm>
-            <a:off x="457200" y="1200151"/>
-            <a:ext cx="8229600" cy="3394472"/>
-          </a:xfrm>
-        </p:spPr>
-        <p:txBody>
-          <a:bodyPr/>
-          <a:lstStyle/>
-          <a:p>
-            <a:pPr lvl="0" indent="0" marL="0">
-              <a:buNone/>
-            </a:pPr>
-            <a:r>
-              <a:rPr/>
-              <a:t>The model, the cost, the exact solution, the iterative one: from scratch.</a:t>
-            </a:r>
-          </a:p>
-        </p:txBody>
-      </p:sp>
+        </p:nvGraphicFramePr>
+        <p:xfrm>
+          <a:off x="457200" y="1166099"/>
+          <a:ext cx="8229600" cy="3390900"/>
+        </p:xfrm>
+        <a:graphic>
+          <a:graphicData uri="http://schemas.openxmlformats.org/drawingml/2006/table">
+            <a:tbl>
+              <a:tblPr firstRow="1" bandRow="1">
+                <a:tableStyleId>{5C22544A-7EE6-4342-B048-85BDC9FD1C3A}</a:tableStyleId>
+              </a:tblPr>
+              <a:tblGrid>
+                <a:gridCol w="4114800"/>
+                <a:gridCol w="4114800"/>
+              </a:tblGrid>
+              <a:tr h="0">
+                <a:tc>
+                  <a:txBody>
+                    <a:bodyPr/>
+                    <a:lstStyle/>
+                    <a:p>
+                      <a:pPr lvl="0" indent="0" marL="0">
+                        <a:buNone/>
+                      </a:pPr>
+                      <a:r>
+                        <a:rPr/>
+                        <a:t>section, and its slides</a:t>
+                      </a:r>
+                    </a:p>
+                  </a:txBody>
+                  <a:tcPr/>
+                </a:tc>
+                <a:tc>
+                  <a:txBody>
+                    <a:bodyPr/>
+                    <a:lstStyle/>
+                    <a:p>
+                      <a:pPr lvl="0" indent="0" marL="0">
+                        <a:buNone/>
+                      </a:pPr>
+                      <a:r>
+                        <a:rPr/>
+                        <a:t>you call (→ the number to come back with)</a:t>
+                      </a:r>
+                    </a:p>
+                  </a:txBody>
+                  <a:tcPr/>
+                </a:tc>
+              </a:tr>
+              <a:tr h="0">
+                <a:tc>
+                  <a:txBody>
+                    <a:bodyPr/>
+                    <a:lstStyle/>
+                    <a:p>
+                      <a:pPr lvl="0" indent="0" marL="0">
+                        <a:buNone/>
+                      </a:pPr>
+                      <a:r>
+                        <a:rPr/>
+                        <a:t>one feature, 4-5</a:t>
+                      </a:r>
+                    </a:p>
+                  </a:txBody>
+                </a:tc>
+                <a:tc>
+                  <a:txBody>
+                    <a:bodyPr/>
+                    <a:lstStyle/>
+                    <a:p>
+                      <a:pPr lvl="0" indent="0" marL="0">
+                        <a:buNone/>
+                      </a:pPr>
+                      <a:r>
+                        <a:rPr>
+                          <a:latin typeface="Courier"/>
+                        </a:rPr>
+                        <a:t>train_test_split</a:t>
+                      </a:r>
+                      <a:r>
+                        <a:rPr/>
+                        <a:t> → 450 houses to fit, 150 to test</a:t>
+                      </a:r>
+                    </a:p>
+                  </a:txBody>
+                </a:tc>
+              </a:tr>
+              <a:tr h="0">
+                <a:tc>
+                  <a:txBody>
+                    <a:bodyPr/>
+                    <a:lstStyle/>
+                    <a:p>
+                      <a:pPr lvl="0" indent="0" marL="0">
+                        <a:buNone/>
+                      </a:pPr>
+                      <a:r>
+                        <a:rPr/>
+                        <a:t>the exact answer, 14-17</a:t>
+                      </a:r>
+                    </a:p>
+                  </a:txBody>
+                </a:tc>
+                <a:tc>
+                  <a:txBody>
+                    <a:bodyPr/>
+                    <a:lstStyle/>
+                    <a:p>
+                      <a:pPr lvl="0" indent="0" marL="0">
+                        <a:buNone/>
+                      </a:pPr>
+                      <a:r>
+                        <a:rPr/>
+                        <a:t>the normal equation in NumPy, then </a:t>
+                      </a:r>
+                      <a:r>
+                        <a:rPr>
+                          <a:latin typeface="Courier"/>
+                        </a:rPr>
+                        <a:t>LinearRegression</a:t>
+                      </a:r>
+                      <a:r>
+                        <a:rPr/>
+                        <a:t> → 2,785 €/m², agreeing to 1.82e-12</a:t>
+                      </a:r>
+                    </a:p>
+                  </a:txBody>
+                </a:tc>
+              </a:tr>
+              <a:tr h="0">
+                <a:tc>
+                  <a:txBody>
+                    <a:bodyPr/>
+                    <a:lstStyle/>
+                    <a:p>
+                      <a:pPr lvl="0" indent="0" marL="0">
+                        <a:buNone/>
+                      </a:pPr>
+                      <a:r>
+                        <a:rPr/>
+                        <a:t>the iterative answer, 20-24</a:t>
+                      </a:r>
+                    </a:p>
+                  </a:txBody>
+                </a:tc>
+                <a:tc>
+                  <a:txBody>
+                    <a:bodyPr/>
+                    <a:lstStyle/>
+                    <a:p>
+                      <a:pPr lvl="0" indent="0" marL="0">
+                        <a:buNone/>
+                      </a:pPr>
+                      <a:r>
+                        <a:rPr/>
+                        <a:t>NumPy only: gradient descent → the same answer, slowly</a:t>
+                      </a:r>
+                    </a:p>
+                  </a:txBody>
+                </a:tc>
+              </a:tr>
+              <a:tr h="0">
+                <a:tc>
+                  <a:txBody>
+                    <a:bodyPr/>
+                    <a:lstStyle/>
+                    <a:p>
+                      <a:pPr lvl="0" indent="0" marL="0">
+                        <a:buNone/>
+                      </a:pPr>
+                      <a:r>
+                        <a:rPr/>
+                        <a:t>all six features, 49-50</a:t>
+                      </a:r>
+                    </a:p>
+                  </a:txBody>
+                </a:tc>
+                <a:tc>
+                  <a:txBody>
+                    <a:bodyPr/>
+                    <a:lstStyle/>
+                    <a:p>
+                      <a:pPr lvl="0" indent="0" marL="0">
+                        <a:buNone/>
+                      </a:pPr>
+                      <a:r>
+                        <a:rPr>
+                          <a:latin typeface="Courier"/>
+                        </a:rPr>
+                        <a:t>LinearRegression</a:t>
+                      </a:r>
+                      <a:r>
+                        <a:rPr/>
+                        <a:t> → area 2,421, bedrooms −16.6%</a:t>
+                      </a:r>
+                    </a:p>
+                  </a:txBody>
+                </a:tc>
+              </a:tr>
+              <a:tr h="0">
+                <a:tc>
+                  <a:txBody>
+                    <a:bodyPr/>
+                    <a:lstStyle/>
+                    <a:p>
+                      <a:pPr lvl="0" indent="0" marL="0">
+                        <a:buNone/>
+                      </a:pPr>
+                      <a:r>
+                        <a:rPr/>
+                        <a:t>the baseline, 12</a:t>
+                      </a:r>
+                    </a:p>
+                  </a:txBody>
+                </a:tc>
+                <a:tc>
+                  <a:txBody>
+                    <a:bodyPr/>
+                    <a:lstStyle/>
+                    <a:p>
+                      <a:pPr lvl="0" indent="0" marL="0">
+                        <a:buNone/>
+                      </a:pPr>
+                      <a:r>
+                        <a:rPr>
+                          <a:latin typeface="Courier"/>
+                        </a:rPr>
+                        <a:t>DummyRegressor(strategy="mean")</a:t>
+                      </a:r>
+                      <a:r>
+                        <a:rPr/>
+                        <a:t>, </a:t>
+                      </a:r>
+                      <a:r>
+                        <a:rPr>
+                          <a:latin typeface="Courier"/>
+                        </a:rPr>
+                        <a:t>r2_score</a:t>
+                      </a:r>
+                      <a:r>
+                        <a:rPr/>
+                        <a:t> → 96,440 € against 20,341 €, R² 0.956</a:t>
+                      </a:r>
+                    </a:p>
+                  </a:txBody>
+                </a:tc>
+              </a:tr>
+            </a:tbl>
+          </a:graphicData>
+        </a:graphic>
+      </p:graphicFrame>
     </p:spTree>
   </p:cSld>
 </p:sld>
@@ -12314,6 +12598,25 @@
             <a:r>
               <a:rPr/>
               <a:t>No straight line follows that.</a:t>
+            </a:r>
+          </a:p>
+          <a:p>
+            <a:pPr lvl="0" indent="0" marL="0">
+              <a:buNone/>
+            </a:pPr>
+            <a:r>
+              <a:rPr/>
+              <a:t>In code: </a:t>
+            </a:r>
+            <a:r>
+              <a:rPr>
+                <a:latin typeface="Courier"/>
+              </a:rPr>
+              <a:t>PolynomialFeatures(degree=2)</a:t>
+            </a:r>
+            <a:r>
+              <a:rPr/>
+              <a:t> adds the column t² for the model to use.</a:t>
             </a:r>
           </a:p>
         </p:txBody>
@@ -13289,36 +13592,240 @@
           </a:p>
         </p:txBody>
       </p:sp>
-      <p:sp>
-        <p:nvSpPr>
-          <p:cNvPr id="3" name="Content Placeholder 2"/>
-          <p:cNvSpPr>
-            <a:spLocks noGrp="1"/>
-          </p:cNvSpPr>
+      <p:graphicFrame>
+        <p:nvGraphicFramePr>
+          <p:cNvPr id="6" name="Content Placeholder 5"/>
+          <p:cNvGraphicFramePr>
+            <a:graphicFrameLocks noGrp="1"/>
+          </p:cNvGraphicFramePr>
           <p:nvPr>
             <p:ph idx="1"/>
           </p:nvPr>
-        </p:nvSpPr>
-        <p:spPr>
-          <a:xfrm>
-            <a:off x="457200" y="1200151"/>
-            <a:ext cx="8229600" cy="3394472"/>
-          </a:xfrm>
-        </p:spPr>
-        <p:txBody>
-          <a:bodyPr/>
-          <a:lstStyle/>
-          <a:p>
-            <a:pPr lvl="0" indent="0" marL="0">
-              <a:buNone/>
-            </a:pPr>
-            <a:r>
-              <a:rPr/>
-              <a:t>Fit the curve, push the degree up, and watch the test error turn.</a:t>
-            </a:r>
-          </a:p>
-        </p:txBody>
-      </p:sp>
+        </p:nvGraphicFramePr>
+        <p:xfrm>
+          <a:off x="457200" y="1166099"/>
+          <a:ext cx="8229600" cy="3390900"/>
+        </p:xfrm>
+        <a:graphic>
+          <a:graphicData uri="http://schemas.openxmlformats.org/drawingml/2006/table">
+            <a:tbl>
+              <a:tblPr firstRow="1" bandRow="1">
+                <a:tableStyleId>{5C22544A-7EE6-4342-B048-85BDC9FD1C3A}</a:tableStyleId>
+              </a:tblPr>
+              <a:tblGrid>
+                <a:gridCol w="4114800"/>
+                <a:gridCol w="4114800"/>
+              </a:tblGrid>
+              <a:tr h="0">
+                <a:tc>
+                  <a:txBody>
+                    <a:bodyPr/>
+                    <a:lstStyle/>
+                    <a:p>
+                      <a:pPr lvl="0" indent="0" marL="0">
+                        <a:buNone/>
+                      </a:pPr>
+                      <a:r>
+                        <a:rPr/>
+                        <a:t>section, and its slides</a:t>
+                      </a:r>
+                    </a:p>
+                  </a:txBody>
+                  <a:tcPr/>
+                </a:tc>
+                <a:tc>
+                  <a:txBody>
+                    <a:bodyPr/>
+                    <a:lstStyle/>
+                    <a:p>
+                      <a:pPr lvl="0" indent="0" marL="0">
+                        <a:buNone/>
+                      </a:pPr>
+                      <a:r>
+                        <a:rPr/>
+                        <a:t>you call (→ the number to come back with)</a:t>
+                      </a:r>
+                    </a:p>
+                  </a:txBody>
+                  <a:tcPr/>
+                </a:tc>
+              </a:tr>
+              <a:tr h="0">
+                <a:tc>
+                  <a:txBody>
+                    <a:bodyPr/>
+                    <a:lstStyle/>
+                    <a:p>
+                      <a:pPr lvl="0" indent="0" marL="0">
+                        <a:buNone/>
+                      </a:pPr>
+                      <a:r>
+                        <a:rPr/>
+                        <a:t>a relationship that bends, 27-28</a:t>
+                      </a:r>
+                    </a:p>
+                  </a:txBody>
+                </a:tc>
+                <a:tc>
+                  <a:txBody>
+                    <a:bodyPr/>
+                    <a:lstStyle/>
+                    <a:p>
+                      <a:pPr lvl="0" indent="0" marL="0">
+                        <a:buNone/>
+                      </a:pPr>
+                      <a:r>
+                        <a:rPr>
+                          <a:latin typeface="Courier"/>
+                        </a:rPr>
+                        <a:t>train_test_split</a:t>
+                      </a:r>
+                      <a:r>
+                        <a:rPr/>
+                        <a:t> → 21 days to fit, 9 to test</a:t>
+                      </a:r>
+                    </a:p>
+                  </a:txBody>
+                </a:tc>
+              </a:tr>
+              <a:tr h="0">
+                <a:tc>
+                  <a:txBody>
+                    <a:bodyPr/>
+                    <a:lstStyle/>
+                    <a:p>
+                      <a:pPr lvl="0" indent="0" marL="0">
+                        <a:buNone/>
+                      </a:pPr>
+                      <a:r>
+                        <a:rPr/>
+                        <a:t>linear in the coefficients, 29-31</a:t>
+                      </a:r>
+                    </a:p>
+                  </a:txBody>
+                </a:tc>
+                <a:tc>
+                  <a:txBody>
+                    <a:bodyPr/>
+                    <a:lstStyle/>
+                    <a:p>
+                      <a:pPr lvl="0" indent="0" marL="0">
+                        <a:buNone/>
+                      </a:pPr>
+                      <a:r>
+                        <a:rPr>
+                          <a:latin typeface="Courier"/>
+                        </a:rPr>
+                        <a:t>PolynomialFeatures</a:t>
+                      </a:r>
+                      <a:r>
+                        <a:rPr/>
+                        <a:t>, </a:t>
+                      </a:r>
+                      <a:r>
+                        <a:rPr>
+                          <a:latin typeface="Courier"/>
+                        </a:rPr>
+                        <a:t>StandardScaler</a:t>
+                      </a:r>
+                      <a:r>
+                        <a:rPr/>
+                        <a:t> and </a:t>
+                      </a:r>
+                      <a:r>
+                        <a:rPr>
+                          <a:latin typeface="Courier"/>
+                        </a:rPr>
+                        <a:t>LinearRegression</a:t>
+                      </a:r>
+                      <a:r>
+                        <a:rPr/>
+                        <a:t>, chained by </a:t>
+                      </a:r>
+                      <a:r>
+                        <a:rPr>
+                          <a:latin typeface="Courier"/>
+                        </a:rPr>
+                        <a:t>make_pipeline</a:t>
+                      </a:r>
+                    </a:p>
+                  </a:txBody>
+                </a:tc>
+              </a:tr>
+              <a:tr h="0">
+                <a:tc>
+                  <a:txBody>
+                    <a:bodyPr/>
+                    <a:lstStyle/>
+                    <a:p>
+                      <a:pPr lvl="0" indent="0" marL="0">
+                        <a:buNone/>
+                      </a:pPr>
+                      <a:r>
+                        <a:rPr/>
+                        <a:t>too much flexibility, 32-34</a:t>
+                      </a:r>
+                    </a:p>
+                  </a:txBody>
+                </a:tc>
+                <a:tc>
+                  <a:txBody>
+                    <a:bodyPr/>
+                    <a:lstStyle/>
+                    <a:p>
+                      <a:pPr lvl="0" indent="0" marL="0">
+                        <a:buNone/>
+                      </a:pPr>
+                      <a:r>
+                        <a:rPr>
+                          <a:latin typeface="Courier"/>
+                        </a:rPr>
+                        <a:t>mean_squared_error</a:t>
+                      </a:r>
+                      <a:r>
+                        <a:rPr/>
+                        <a:t>, square-rooted → test RMSE 16.9 at degree 3, 24,655.7 at 12</a:t>
+                      </a:r>
+                    </a:p>
+                  </a:txBody>
+                </a:tc>
+              </a:tr>
+              <a:tr h="0">
+                <a:tc>
+                  <a:txBody>
+                    <a:bodyPr/>
+                    <a:lstStyle/>
+                    <a:p>
+                      <a:pPr lvl="0" indent="0" marL="0">
+                        <a:buNone/>
+                      </a:pPr>
+                      <a:r>
+                        <a:rPr/>
+                        <a:t>why the wiggles appear, 36</a:t>
+                      </a:r>
+                    </a:p>
+                  </a:txBody>
+                </a:tc>
+                <a:tc>
+                  <a:txBody>
+                    <a:bodyPr/>
+                    <a:lstStyle/>
+                    <a:p>
+                      <a:pPr lvl="0" indent="0" marL="0">
+                        <a:buNone/>
+                      </a:pPr>
+                      <a:r>
+                        <a:rPr/>
+                        <a:t>the fitted coefficients → largest 3,097,038,010 at degree 12</a:t>
+                      </a:r>
+                    </a:p>
+                  </a:txBody>
+                </a:tc>
+              </a:tr>
+            </a:tbl>
+          </a:graphicData>
+        </a:graphic>
+      </p:graphicFrame>
     </p:spTree>
   </p:cSld>
 </p:sld>
@@ -13599,6 +14106,19 @@
             <a:r>
               <a:rPr/>
               <a:t>, or the penalty is arbitrary</a:t>
+            </a:r>
+          </a:p>
+          <a:p>
+            <a:pPr lvl="0"/>
+            <a:r>
+              <a:rPr/>
+              <a:t>In code: </a:t>
+            </a:r>
+            <a:r>
+              <a:rPr>
+                <a:latin typeface="Courier"/>
+              </a:rPr>
+              <a:t>make_pipeline(StandardScaler(), Ridge(alpha=0.01))</a:t>
             </a:r>
           </a:p>
         </p:txBody>
@@ -14088,6 +14608,25 @@
               <a:t>And we know the coefficients that generated it.</a:t>
             </a:r>
           </a:p>
+          <a:p>
+            <a:pPr lvl="0" indent="0" marL="0">
+              <a:buNone/>
+            </a:pPr>
+            <a:r>
+              <a:rPr/>
+              <a:t>In code: </a:t>
+            </a:r>
+            <a:r>
+              <a:rPr>
+                <a:latin typeface="Courier"/>
+              </a:rPr>
+              <a:t>train_test_split(X, y, test_size=0.25)</a:t>
+            </a:r>
+            <a:r>
+              <a:rPr/>
+              <a:t> keeps 150 houses for testing.</a:t>
+            </a:r>
+          </a:p>
         </p:txBody>
       </p:sp>
     </p:spTree>
@@ -15622,36 +16161,222 @@
           </a:p>
         </p:txBody>
       </p:sp>
-      <p:sp>
-        <p:nvSpPr>
-          <p:cNvPr id="3" name="Content Placeholder 2"/>
-          <p:cNvSpPr>
-            <a:spLocks noGrp="1"/>
-          </p:cNvSpPr>
+      <p:graphicFrame>
+        <p:nvGraphicFramePr>
+          <p:cNvPr id="6" name="Content Placeholder 5"/>
+          <p:cNvGraphicFramePr>
+            <a:graphicFrameLocks noGrp="1"/>
+          </p:cNvGraphicFramePr>
           <p:nvPr>
             <p:ph idx="1"/>
           </p:nvPr>
-        </p:nvSpPr>
-        <p:spPr>
-          <a:xfrm>
-            <a:off x="457200" y="1200151"/>
-            <a:ext cx="8229600" cy="3394472"/>
-          </a:xfrm>
-        </p:spPr>
-        <p:txBody>
-          <a:bodyPr/>
-          <a:lstStyle/>
-          <a:p>
-            <a:pPr lvl="0" indent="0" marL="0">
-              <a:buNone/>
-            </a:pPr>
-            <a:r>
-              <a:rPr/>
-              <a:t>Ridge on the disaster, the regularisation paths, the collinear case.</a:t>
-            </a:r>
-          </a:p>
-        </p:txBody>
-      </p:sp>
+        </p:nvGraphicFramePr>
+        <p:xfrm>
+          <a:off x="457200" y="1166099"/>
+          <a:ext cx="8229600" cy="3390900"/>
+        </p:xfrm>
+        <a:graphic>
+          <a:graphicData uri="http://schemas.openxmlformats.org/drawingml/2006/table">
+            <a:tbl>
+              <a:tblPr firstRow="1" bandRow="1">
+                <a:tableStyleId>{5C22544A-7EE6-4342-B048-85BDC9FD1C3A}</a:tableStyleId>
+              </a:tblPr>
+              <a:tblGrid>
+                <a:gridCol w="4114800"/>
+                <a:gridCol w="4114800"/>
+              </a:tblGrid>
+              <a:tr h="0">
+                <a:tc>
+                  <a:txBody>
+                    <a:bodyPr/>
+                    <a:lstStyle/>
+                    <a:p>
+                      <a:pPr lvl="0" indent="0" marL="0">
+                        <a:buNone/>
+                      </a:pPr>
+                      <a:r>
+                        <a:rPr/>
+                        <a:t>section, and its slides</a:t>
+                      </a:r>
+                    </a:p>
+                  </a:txBody>
+                  <a:tcPr/>
+                </a:tc>
+                <a:tc>
+                  <a:txBody>
+                    <a:bodyPr/>
+                    <a:lstStyle/>
+                    <a:p>
+                      <a:pPr lvl="0" indent="0" marL="0">
+                        <a:buNone/>
+                      </a:pPr>
+                      <a:r>
+                        <a:rPr/>
+                        <a:t>you call (→ the number to come back with)</a:t>
+                      </a:r>
+                    </a:p>
+                  </a:txBody>
+                  <a:tcPr/>
+                </a:tc>
+              </a:tr>
+              <a:tr h="0">
+                <a:tc>
+                  <a:txBody>
+                    <a:bodyPr/>
+                    <a:lstStyle/>
+                    <a:p>
+                      <a:pPr lvl="0" indent="0" marL="0">
+                        <a:buNone/>
+                      </a:pPr>
+                      <a:r>
+                        <a:rPr/>
+                        <a:t>Ridge on the degree-12 fit, 37-41</a:t>
+                      </a:r>
+                    </a:p>
+                  </a:txBody>
+                </a:tc>
+                <a:tc>
+                  <a:txBody>
+                    <a:bodyPr/>
+                    <a:lstStyle/>
+                    <a:p>
+                      <a:pPr lvl="0" indent="0" marL="0">
+                        <a:buNone/>
+                      </a:pPr>
+                      <a:r>
+                        <a:rPr>
+                          <a:latin typeface="Courier"/>
+                        </a:rPr>
+                        <a:t>Ridge(alpha=0.01)</a:t>
+                      </a:r>
+                      <a:r>
+                        <a:rPr/>
+                        <a:t> after </a:t>
+                      </a:r>
+                      <a:r>
+                        <a:rPr>
+                          <a:latin typeface="Courier"/>
+                        </a:rPr>
+                        <a:t>PolynomialFeatures</a:t>
+                      </a:r>
+                      <a:r>
+                        <a:rPr/>
+                        <a:t> and </a:t>
+                      </a:r>
+                      <a:r>
+                        <a:rPr>
+                          <a:latin typeface="Courier"/>
+                        </a:rPr>
+                        <a:t>StandardScaler</a:t>
+                      </a:r>
+                      <a:r>
+                        <a:rPr/>
+                        <a:t> → largest coefficient 365</a:t>
+                      </a:r>
+                    </a:p>
+                  </a:txBody>
+                </a:tc>
+              </a:tr>
+              <a:tr h="0">
+                <a:tc>
+                  <a:txBody>
+                    <a:bodyPr/>
+                    <a:lstStyle/>
+                    <a:p>
+                      <a:pPr lvl="0" indent="0" marL="0">
+                        <a:buNone/>
+                      </a:pPr>
+                      <a:r>
+                        <a:rPr/>
+                        <a:t>regularisation paths, 44-46</a:t>
+                      </a:r>
+                    </a:p>
+                  </a:txBody>
+                </a:tc>
+                <a:tc>
+                  <a:txBody>
+                    <a:bodyPr/>
+                    <a:lstStyle/>
+                    <a:p>
+                      <a:pPr lvl="0" indent="0" marL="0">
+                        <a:buNone/>
+                      </a:pPr>
+                      <a:r>
+                        <a:rPr>
+                          <a:latin typeface="Courier"/>
+                        </a:rPr>
+                        <a:t>make_pipeline(StandardScaler(), Ridge(alpha=...))</a:t>
+                      </a:r>
+                      <a:r>
+                        <a:rPr/>
+                        <a:t>, the same with </a:t>
+                      </a:r>
+                      <a:r>
+                        <a:rPr>
+                          <a:latin typeface="Courier"/>
+                        </a:rPr>
+                        <a:t>Lasso</a:t>
+                      </a:r>
+                      <a:r>
+                        <a:rPr/>
+                        <a:t> → only area left at 40,000</a:t>
+                      </a:r>
+                    </a:p>
+                  </a:txBody>
+                </a:tc>
+              </a:tr>
+              <a:tr h="0">
+                <a:tc>
+                  <a:txBody>
+                    <a:bodyPr/>
+                    <a:lstStyle/>
+                    <a:p>
+                      <a:pPr lvl="0" indent="0" marL="0">
+                        <a:buNone/>
+                      </a:pPr>
+                      <a:r>
+                        <a:rPr/>
+                        <a:t>the collinear case, 47-48</a:t>
+                      </a:r>
+                    </a:p>
+                  </a:txBody>
+                </a:tc>
+                <a:tc>
+                  <a:txBody>
+                    <a:bodyPr/>
+                    <a:lstStyle/>
+                    <a:p>
+                      <a:pPr lvl="0" indent="0" marL="0">
+                        <a:buNone/>
+                      </a:pPr>
+                      <a:r>
+                        <a:rPr>
+                          <a:latin typeface="Courier"/>
+                        </a:rPr>
+                        <a:t>LinearRegression</a:t>
+                      </a:r>
+                      <a:r>
+                        <a:rPr/>
+                        <a:t> against </a:t>
+                      </a:r>
+                      <a:r>
+                        <a:rPr>
+                          <a:latin typeface="Courier"/>
+                        </a:rPr>
+                        <a:t>Ridge(alpha=10)</a:t>
+                      </a:r>
+                      <a:r>
+                        <a:rPr/>
+                        <a:t> on four splits → 9,261 to 45,307, then about 40,000</a:t>
+                      </a:r>
+                    </a:p>
+                  </a:txBody>
+                </a:tc>
+              </a:tr>
+            </a:tbl>
+          </a:graphicData>
+        </a:graphic>
+      </p:graphicFrame>
     </p:spTree>
   </p:cSld>
 </p:sld>

</xml_diff>

<commit_message>
Close the gaps a student with only lesson 3's deck would hit
A gap audit of the slide bodies, notes closed. Slide 12 now gives R² and RMSE
as formulas, and slide 19 the condition number as a ratio. The model itself,
ŷ = w₁x₁ + … + wₙxₙ + b, appears on slide 6 instead of only in the handout;
"maximum likelihood", "stationary point" and the learning rate are said in
words where they first appear; the hand-worked slides say which houses they
use and what X and θ are; RMSE tables carry their units; and slide 46 calls
area_sqm by its name.

Two inconsistencies are resolved. The figure on slide 40 labelled its panels
"alpha = 0.01" and "alpha = 100" while the slides write λ; notebook 3 is
re-run in the container and every printed number is unchanged. And the ridge
closed form penalises the intercept and absorbs a factor 2m, which the
handout's Section 6.2 and the slide's notes now say.

Co-Authored-By: Claude Opus 5.5 <noreply@anthropic.com>
</commit_message>
<xml_diff>
--- a/Lessons/03_regression/Slides/regression_slides.pptx
+++ b/Lessons/03_regression/Slides/regression_slides.pptx
@@ -4801,6 +4801,20 @@
             <a:r>
               <a:rPr/>
               <a:t>Everything else is identical - same derivation, same projection idea, same four lines of NumPy. Ridge is not a different method; it is least squares with the floor tilted.</a:t>
+            </a:r>
+          </a:p>
+          <a:p>
+            <a:pPr lvl="0" indent="0" marL="0">
+              <a:buNone/>
+            </a:pPr>
+          </a:p>
+          <a:p>
+            <a:pPr lvl="0" indent="0" marL="0">
+              <a:buNone/>
+            </a:pPr>
+            <a:r>
+              <a:rPr/>
+              <a:t>Two small print points, for anyone who checks it against the cost on the earlier slide. Written with theta, the formula penalises the intercept too; in practice the intercept’s entry of I is set to zero, or the data are centred first so the intercept drops out, which is what scikit-learn does. And with the cost written as MSE plus lambda times the sum of squares, the lambda in this formula is that lambda times 2m. Handout section 6.2 shows where the factor comes from.</a:t>
             </a:r>
           </a:p>
           <a:p>
@@ -10492,7 +10506,7 @@
             <a:pPr lvl="0"/>
             <a:r>
               <a:rPr/>
-              <a:t>Trivial answer for a regression: </a:t>
+              <a:t>Trivial answer: </a:t>
             </a:r>
             <a:r>
               <a:rPr b="1"/>
@@ -10506,33 +10520,41 @@
               <a:rPr>
                 <a:latin typeface="Courier"/>
               </a:rPr>
-              <a:t>DummyRegressor(strategy="mean")</a:t>
+              <a:t>DummyRegressor()</a:t>
             </a:r>
           </a:p>
           <a:p>
             <a:pPr lvl="0"/>
             <a:r>
               <a:rPr/>
-              <a:t>On the 150 test houses: root mean squared error (RMSE) </a:t>
+              <a:t>Root mean squared error, RMSE = √MSE, on the 150 test houses: </a:t>
             </a:r>
             <a:r>
               <a:rPr b="1"/>
-              <a:t>96,440 €</a:t>
-            </a:r>
-            <a:r>
-              <a:rPr/>
-              <a:t>, against the model’s </a:t>
+              <a:t>96,440 €</a:t>
+            </a:r>
+            <a:r>
+              <a:rPr/>
+              <a:t> for the mean, </a:t>
             </a:r>
             <a:r>
               <a:rPr b="1"/>
-              <a:t>20,341 €</a:t>
+              <a:t>20,341 €</a:t>
+            </a:r>
+            <a:r>
+              <a:rPr/>
+              <a:t> for the model</a:t>
             </a:r>
           </a:p>
           <a:p>
             <a:pPr lvl="0"/>
             <a:r>
+              <a:rPr/>
+              <a:t>R² = 1 − Σ(y − ŷ)² ÷ Σ(y − ȳ)² = </a:t>
+            </a:r>
+            <a:r>
               <a:rPr b="1"/>
-              <a:t>R² = 0.956</a:t>
+              <a:t>0.956</a:t>
             </a:r>
             <a:r>
               <a:rPr/>
@@ -10546,14 +10568,14 @@
             </a:r>
             <a:r>
               <a:rPr/>
-              <a:t>) — the same comparison as one ratio, 0 is the mean, 1 is perfect</a:t>
+              <a:t>): 0 is the mean, 1 is perfect</a:t>
             </a:r>
           </a:p>
           <a:p>
             <a:pPr lvl="0"/>
             <a:r>
               <a:rPr/>
-              <a:t>Quote the euros too: R² is divided by </a:t>
+              <a:t>Quote the euros too: R² depends on </a:t>
             </a:r>
             <a:r>
               <a:rPr i="1"/>
@@ -10949,6 +10971,38 @@
                       <a:r>
                         <a:rPr/>
                         <a:t>80, 120, 200 m² → 240k, 320k, 540k</a:t>
+                      </a:r>
+                    </a:p>
+                  </a:txBody>
+                </a:tc>
+              </a:tr>
+              <a:tr h="0">
+                <a:tc>
+                  <a:txBody>
+                    <a:bodyPr/>
+                    <a:lstStyle/>
+                    <a:p>
+                      <a:pPr lvl="0" indent="0" marL="0">
+                        <a:buNone/>
+                      </a:pPr>
+                      <a:r>
+                        <a:rPr/>
+                        <a:t>X, and θ</a:t>
+                      </a:r>
+                    </a:p>
+                  </a:txBody>
+                </a:tc>
+                <a:tc>
+                  <a:txBody>
+                    <a:bodyPr/>
+                    <a:lstStyle/>
+                    <a:p>
+                      <a:pPr lvl="0" indent="0" marL="0">
+                        <a:buNone/>
+                      </a:pPr>
+                      <a:r>
+                        <a:rPr/>
+                        <a:t>a column of 1s (for b) beside the areas; θ = (b, w)</a:t>
                       </a:r>
                     </a:p>
                   </a:txBody>
@@ -11219,7 +11273,7 @@
             <a:pPr lvl="0"/>
             <a:r>
               <a:rPr/>
-              <a:t>Any stationary point is </a:t>
+              <a:t>Any stationary point (zero gradient) is </a:t>
             </a:r>
             <a:r>
               <a:rPr i="1"/>
@@ -11440,7 +11494,7 @@
             </a:r>
             <a:r>
               <a:rPr/>
-              <a:t> compares the steepest direction with the shallowest.</a:t>
+              <a:t> κ = steepest curvature ÷ shallowest curvature: how many times steeper the steepest direction of the bowl is than the shallowest.</a:t>
             </a:r>
           </a:p>
           <a:p>
@@ -11672,6 +11726,23 @@
             <a:r>
               <a:rPr/>
               <a:t>You cannot see the valley, but you can feel which way the ground slopes.</a:t>
+            </a:r>
+          </a:p>
+          <a:p>
+            <a:pPr lvl="0" indent="0" marL="0">
+              <a:buNone/>
+            </a:pPr>
+            <a:r>
+              <a:rPr/>
+              <a:t>So: step against the slope, by an amount set by the </a:t>
+            </a:r>
+            <a:r>
+              <a:rPr b="1"/>
+              <a:t>learning rate</a:t>
+            </a:r>
+            <a:r>
+              <a:rPr/>
+              <a:t> α, and repeat until the cost stops falling.</a:t>
             </a:r>
           </a:p>
         </p:txBody>
@@ -11805,7 +11876,7 @@
             </a:pPr>
             <a:r>
               <a:rPr/>
-              <a:t>One step, from w = 0 and b = 0</a:t>
+              <a:t>One step on two houses, from w = 0 and b = 0</a:t>
             </a:r>
           </a:p>
         </p:txBody>
@@ -11846,7 +11917,7 @@
                       </a:pPr>
                       <a:r>
                         <a:rPr/>
-                        <a:t>α = 10⁻⁵</a:t>
+                        <a:t>80 m² at 240k, 200 m² at 540k; α = 10⁻⁵</a:t>
                       </a:r>
                     </a:p>
                   </a:txBody>
@@ -12616,7 +12687,7 @@
             </a:r>
             <a:r>
               <a:rPr/>
-              <a:t> adds the column t² for the model to use.</a:t>
+              <a:t> adds the squared temperature, t², as a second column.</a:t>
             </a:r>
           </a:p>
         </p:txBody>
@@ -13243,7 +13314,7 @@
                       </a:pPr>
                       <a:r>
                         <a:rPr/>
-                        <a:t>Train RMSE</a:t>
+                        <a:t>Train RMSE (kWh)</a:t>
                       </a:r>
                     </a:p>
                   </a:txBody>
@@ -13259,7 +13330,7 @@
                       </a:pPr>
                       <a:r>
                         <a:rPr/>
-                        <a:t>Test RMSE</a:t>
+                        <a:t>Test RMSE (kWh)</a:t>
                       </a:r>
                     </a:p>
                   </a:txBody>
@@ -14120,6 +14191,16 @@
               </a:rPr>
               <a:t>make_pipeline(StandardScaler(), Ridge(alpha=0.01))</a:t>
             </a:r>
+            <a:r>
+              <a:rPr/>
+              <a:t>; scikit-learn calls λ </a:t>
+            </a:r>
+            <a:r>
+              <a:rPr>
+                <a:latin typeface="Courier"/>
+              </a:rPr>
+              <a:t>alpha</a:t>
+            </a:r>
           </a:p>
         </p:txBody>
       </p:sp>
@@ -14228,7 +14309,7 @@
                       </a:pPr>
                       <a:r>
                         <a:rPr/>
-                        <a:t>Train</a:t>
+                        <a:t>Train RMSE</a:t>
                       </a:r>
                     </a:p>
                   </a:txBody>
@@ -14244,7 +14325,7 @@
                       </a:pPr>
                       <a:r>
                         <a:rPr/>
-                        <a:t>Test</a:t>
+                        <a:t>Test RMSE</a:t>
                       </a:r>
                     </a:p>
                   </a:txBody>
@@ -14972,7 +15053,7 @@
             <a:pPr lvl="0"/>
             <a:r>
               <a:rPr/>
-              <a:t>Every eigenvalue shifts up by λ, so none of them can be zero</a:t>
+              <a:t>Every eigenvalue of XᵀX shifts up by λ, so none of them can be zero</a:t>
             </a:r>
           </a:p>
         </p:txBody>
@@ -15357,7 +15438,7 @@
                         <a:rPr>
                           <a:latin typeface="Courier"/>
                         </a:rPr>
-                        <a:t>area</a:t>
+                        <a:t>area_sqm</a:t>
                       </a:r>
                       <a:r>
                         <a:rPr/>
@@ -16674,7 +16755,7 @@
             </a:pPr>
             <a:r>
               <a:rPr/>
-              <a:t>Each feature contributes a fixed amount per unit, and the contributions add up.</a:t>
+              <a:t>Each feature contributes a fixed amount per unit, and the contributions add up: ŷ = w₁x₁ + w₂x₂ + … + wₙxₙ + b, one coefficient w per feature plus an intercept b.</a:t>
             </a:r>
           </a:p>
           <a:p>
@@ -16881,15 +16962,15 @@
             <a:pPr lvl="0"/>
             <a:r>
               <a:rPr/>
-              <a:t>Under Gaussian noise, it </a:t>
+              <a:t>Under Gaussian noise it is </a:t>
             </a:r>
             <a:r>
               <a:rPr b="1"/>
-              <a:t>is</a:t>
-            </a:r>
-            <a:r>
-              <a:rPr/>
-              <a:t> maximum likelihood</a:t>
+              <a:t>maximum likelihood</a:t>
+            </a:r>
+            <a:r>
+              <a:rPr/>
+              <a:t>: the coefficients that make the observed prices most probable</a:t>
             </a:r>
           </a:p>
         </p:txBody>

</xml_diff>

<commit_message>
Rewrite lesson 3's speaker notes in full, and state the units of the Ridge coefficients
Every note reread against its slide and every number checked against the
notebook outputs. Fixes the overfitting mechanism (the cancellation holds at
the training points and fails between them), 'four features' where the table
has none, degree 9 'nearly as many coefficients as data', and a pointer to
before the break. The Ridge coefficients on the collinear columns are euros
per standard deviation, not per square metre; the handout and commentary now
say so, and give the combined effect as within 2% of 2,400 rather than 2,420.

Co-Authored-By: Claude Opus 5.5 <noreply@anthropic.com>
</commit_message>
<xml_diff>
--- a/Lessons/03_regression/Slides/regression_slides.pptx
+++ b/Lessons/03_regression/Slides/regression_slides.pptx
@@ -1170,7 +1170,7 @@
             </a:pPr>
             <a:r>
               <a:rPr/>
-              <a:t>Four lines of NumPy, and notebook 1 shows it agreeing with scikit-learn to 1.8e-12 euros per square metre.</a:t>
+              <a:t>This is the exact solution: theta collects the intercept and every coefficient, and the formula gives all of them at once, with no iteration. It is four lines of NumPy, and notebook 1 shows it agreeing with scikit-learn’s answer to within 1.8 × 10⁻¹² euros per square metre - the two differ only by rounding.</a:t>
             </a:r>
           </a:p>
           <a:p>
@@ -1198,7 +1198,7 @@
             </a:pPr>
             <a:r>
               <a:rPr/>
-              <a:t>Also mention that the second derivative is X transpose X, which is positive semi-definite (it is never negative in any direction), so the cost is convex and any stationary point is global. That is the formal version of “the bowl has one bottom”.</a:t>
+              <a:t>Why it is the minimum and not some other flat point is the next slide but one.</a:t>
             </a:r>
           </a:p>
         </p:txBody>
@@ -1680,7 +1680,7 @@
             </a:pPr>
             <a:r>
               <a:rPr/>
-              <a:t>This is the number behind “nearly redundant”, and it is the idea from the first half of the lesson that is most useful outside it.</a:t>
+              <a:t>This is the number behind “nearly redundant”, and one of the ideas from the first half of the lesson that is most useful outside it.</a:t>
             </a:r>
           </a:p>
           <a:p>
@@ -1708,7 +1708,7 @@
             </a:pPr>
             <a:r>
               <a:rPr/>
-              <a:t>Then the consequence, which appears twice. For the exact solution, a stretched valley is what makes the inverse enormous and the answer unstable. For gradient descent - next section - one step size has to serve every direction at once, so the steep direction sets the limit and the shallow one crawls. The condition number is, near enough, what sets the iteration count.</a:t>
+              <a:t>Then the consequence, which appears twice. For the exact solution, a stretched valley is what makes the inverse enormous and the answer unstable. For gradient descent, which is the next section, one step size has to serve every direction at once, so the steep direction sets the limit and the shallow one crawls. The condition number is, near enough, what sets the iteration count.</a:t>
             </a:r>
           </a:p>
           <a:p>
@@ -2134,7 +2134,21 @@
             </a:pPr>
             <a:r>
               <a:rPr/>
-              <a:t>Both gradients are negative - the model predicts zero for everything, so every prediction is far too low - and both parameters therefore increase. So far, so unremarkable.</a:t>
+              <a:t>Say first that the prices here are in thousands of euros, so 240 means 240,000, which keeps the numbers small enough to read.</a:t>
+            </a:r>
+          </a:p>
+          <a:p>
+            <a:pPr lvl="0" indent="0" marL="0">
+              <a:buNone/>
+            </a:pPr>
+          </a:p>
+          <a:p>
+            <a:pPr lvl="0" indent="0" marL="0">
+              <a:buNone/>
+            </a:pPr>
+            <a:r>
+              <a:rPr/>
+              <a:t>Both gradients are negative - the model starts at zero and predicts zero for every house, so every prediction is far too low - and both parameters therefore increase. So far, nothing surprising.</a:t>
             </a:r>
           </a:p>
           <a:p>
@@ -2170,7 +2184,7 @@
             </a:pPr>
             <a:r>
               <a:rPr/>
-              <a:t>Nothing clever caused that. Areas are around 140, and the intercept’s “feature” is always 1, so the slope’s gradient is roughly 140 times larger before anything else happens. With one shared learning rate, the intercept crawls towards its value long after the slope has arrived - which is exactly what notebook 1 shows after 4,000 iterations.</a:t>
+              <a:t>Nothing clever caused that. In the gradient, each house’s error is multiplied by its area for the slope, and by 1 for the intercept (the intercept behaves like a feature that is always 1). The two areas are 80 and 200, so the slope’s gradient comes out about 163 times larger before anything else happens. With one shared learning rate, the intercept crawls towards its value long after the slope has arrived - which is exactly what notebook 1 shows after 4,000 iterations.</a:t>
             </a:r>
           </a:p>
           <a:p>
@@ -2280,7 +2294,7 @@
             </a:pPr>
             <a:r>
               <a:rPr/>
-              <a:t>Left: the cost against iteration. It falls steeply in the first few dozen steps and then flattens into a long tail that is still creeping at 4,000. Point at the flat part and say what it means - the model was essentially fitted very early, and almost all the iterations bought almost nothing.</a:t>
+              <a:t>Left: the cost against the iteration number. It falls steeply in the first few dozen steps and then flattens into a long tail that is still creeping at 4,000. Point at the flat part and say what it means - the model was essentially fitted very early, and almost all the iterations bought almost nothing.</a:t>
             </a:r>
           </a:p>
           <a:p>
@@ -2418,7 +2432,7 @@
             </a:pPr>
             <a:r>
               <a:rPr/>
-              <a:t>The threshold is not a rule of thumb. Handout section 4.3 derives it: for a bowl of curvature c, convergence requires alpha below 2/c, and with several features the binding constraint is the largest curvature - the largest feature variance.</a:t>
+              <a:t>The threshold is not a rule of thumb. Handout section 4.3 derives it: for a bowl whose curvature (how quickly the slope changes) is c, gradient descent converges only when alpha is below 2/c. With several features the bowl has a different curvature in each direction, and the steepest one sets the limit; on unscaled data that steepest direction belongs to the feature with the largest spread.</a:t>
             </a:r>
           </a:p>
           <a:p>
@@ -2542,7 +2556,7 @@
             </a:pPr>
             <a:r>
               <a:rPr/>
-              <a:t>The two moments worth pausing on together. First, the agreement between their four-line normal equation and scikit-learn to twelve decimal places - it convinces more than any assurance from the lecturer. Second, the coefficient table at the end, which is the setup for the last section of the lesson.</a:t>
+              <a:t>The two moments worth pausing on together. First, the agreement between their four-line normal equation and scikit-learn, to within about 10⁻¹² - seeing it on their own screen convinces more than any assurance from the lecturer. Second, the coefficient table at the end, which is the setup for the last section of the lesson.</a:t>
             </a:r>
           </a:p>
           <a:p>
@@ -2954,7 +2968,7 @@
             </a:pPr>
             <a:r>
               <a:rPr/>
-              <a:t>The trick, and it surprises people. Nothing in the derivation required the inputs to be straight - only that the model is linear in w, which it still is.</a:t>
+              <a:t>This is the trick, and it surprises people. The model is a curve in t, but it is still a weighted sum of columns: one column holds t, a second holds t squared, and the weights w enter only by multiplication and addition. Nothing in the derivation of least squares required the columns to be the raw inputs - only that the model is linear in w, which it still is.</a:t>
             </a:r>
           </a:p>
           <a:p>
@@ -3408,7 +3422,7 @@
             </a:pPr>
             <a:r>
               <a:rPr/>
-              <a:t>Degree 1 too rigid, degree 2 right, degree 12 wild.</a:t>
+              <a:t>Three fits to the same 21 points. The degree-1 line is too rigid to follow the U; degree 2 matches the true curve, which is quadratic; degree 12 swings wildly between the points.</a:t>
             </a:r>
           </a:p>
           <a:p>
@@ -3546,7 +3560,21 @@
             </a:pPr>
             <a:r>
               <a:rPr/>
-              <a:t>Training error falls at every single step, 113 down to 14, monotonically, never once suggesting anything is wrong. Test error bottoms out at degree 3 and then climbs: 590 at degree 9, and 24,656 at degree 12.</a:t>
+              <a:t>Training error falls at every single step, from 113 down to 14, never once suggesting anything is wrong. Test error bottoms out at degree 3 and then climbs: 590 at degree 9, and 24,656 at degree 12.</a:t>
+            </a:r>
+          </a:p>
+          <a:p>
+            <a:pPr lvl="0" indent="0" marL="0">
+              <a:buNone/>
+            </a:pPr>
+          </a:p>
+          <a:p>
+            <a:pPr lvl="0" indent="0" marL="0">
+              <a:buNone/>
+            </a:pPr>
+            <a:r>
+              <a:rPr/>
+              <a:t>If someone asks why degree 3 wins when the truth is quadratic: the notebook also fits degree 2, which scores 17.4 against degree 3’s 16.9. With nine test days that difference is noise; the two are equally good.</a:t>
             </a:r>
           </a:p>
           <a:p>
@@ -3574,7 +3602,7 @@
             </a:pPr>
             <a:r>
               <a:rPr/>
-              <a:t>This is lesson 1’s empirical-versus-expected risk with numbers in it. And note how little it took: 21 training points, and by degree 9 the model has nearly as many coefficients as data.</a:t>
+              <a:t>This is lesson 1’s empirical-versus-expected risk with numbers in it: the error on the data we fitted against the error on data we have not seen. And note how little it took: 21 training points, and at degree 12 the model has 12 coefficients plus an intercept to place among them.</a:t>
             </a:r>
           </a:p>
         </p:txBody>
@@ -3706,7 +3734,7 @@
             </a:pPr>
             <a:r>
               <a:rPr/>
-              <a:t>This is lesson 1’s empirical risk versus expected risk, now with numbers and a picture. Lesson 5 is about measuring the upper curve honestly when you do not have a test set to spend.</a:t>
+              <a:t>This is lesson 1’s empirical risk versus expected risk, now with numbers and a picture. Lesson 5 is about measuring the upper curve, the test error, honestly when you do not have a test set to spend.</a:t>
             </a:r>
           </a:p>
         </p:txBody>
@@ -3926,7 +3954,7 @@
             </a:pPr>
             <a:r>
               <a:rPr/>
-              <a:t>The huge coefficients work in OPPOSITION. With 21 points and 12 coefficients there are many ways to pass close to every point, and the one least squares finds has terms that nearly cancel - one pushing the curve up where the next pushes it down, the cancellation failing exactly where a training point sits. Between the points, nothing constrains the swing.</a:t>
+              <a:t>The huge coefficients work in OPPOSITION. With 21 points and 12 coefficients there are many ways to pass close to every point, and the one least squares finds is built from enormous terms that nearly cancel: one pushes the curve up, the next pushes it down by almost the same amount. At each training point the cancellation is tuned so the curve lands near the point, because that is all least squares checks. Between the points nothing tunes it, and the curve swings by thousands.</a:t>
             </a:r>
           </a:p>
           <a:p>
@@ -4070,21 +4098,7 @@
             </a:pPr>
             <a:r>
               <a:rPr/>
-              <a:t>Two things that are not optional and that students get wrong. The intercept is never penalised - it is not a claim about any feature, and shrinking it would bias every prediction towards zero. And features MUST be scaled first: the penalty is a sum over coefficients, so the same feature in metres and in kilometres attracts penalties differing by a factor of a thousand.</a:t>
-            </a:r>
-          </a:p>
-          <a:p>
-            <a:pPr lvl="0" indent="0" marL="0">
-              <a:buNone/>
-            </a:pPr>
-          </a:p>
-          <a:p>
-            <a:pPr lvl="0" indent="0" marL="0">
-              <a:buNone/>
-            </a:pPr>
-            <a:r>
-              <a:rPr/>
-              <a:t>Lesson 2 introduced scaling for optimisation speed. Here it is correctness.</a:t>
+              <a:t>Ridge charges the sum of the squared coefficients, Lasso the sum of their absolute values; the next slide gives the two rules both of them need.</a:t>
             </a:r>
           </a:p>
         </p:txBody>
@@ -4304,7 +4318,7 @@
             </a:pPr>
             <a:r>
               <a:rPr/>
-              <a:t>Read the last column first: three billion down to 365, from a penalty of one hundredth. And the test error falls from 24,656 to 23, which is the noise floor - a thousandfold improvement bought with one number.</a:t>
+              <a:t>Read the last column first: three billion down to 365, from a penalty of one hundredth. And the test error falls from 24,656 to 23, which is the noise floor: the noise we added to each day has a standard deviation of 22 kWh, and no model can predict below it. A thousandfold improvement, bought with one number.</a:t>
             </a:r>
           </a:p>
           <a:p>
@@ -4346,7 +4360,7 @@
             </a:pPr>
             <a:r>
               <a:rPr/>
-              <a:t>The useful range spans four orders of magnitude, which is why lambda cannot be guessed.</a:t>
+              <a:t>The table runs lambda from 0.01 to 100, four orders of magnitude, and the test error changes tenfold across them. That is why lambda cannot be guessed: it has to be searched for, which lesson 5 does properly.</a:t>
             </a:r>
           </a:p>
         </p:txBody>
@@ -4800,7 +4814,7 @@
             </a:pPr>
             <a:r>
               <a:rPr/>
-              <a:t>Everything else is identical - same derivation, same projection idea, same four lines of NumPy. Ridge is not a different method; it is least squares with the floor tilted.</a:t>
+              <a:t>Everything else is identical - same derivation, same projection idea, same four lines of NumPy. Ridge is not a different method; it is least squares with a price on large coefficients.</a:t>
             </a:r>
           </a:p>
           <a:p>
@@ -4828,21 +4842,7 @@
             </a:pPr>
             <a:r>
               <a:rPr/>
-              <a:t>Note that Lasso has no such formula. The absolute value has a corner, so it cannot be differentiated at zero, and the solution has to be found iteratively. That inconvenience is inseparable from the property that makes Lasso useful - the corner is exactly what produces the zeros.</a:t>
-            </a:r>
-          </a:p>
-          <a:p>
-            <a:pPr lvl="0" indent="0" marL="0">
-              <a:buNone/>
-            </a:pPr>
-          </a:p>
-          <a:p>
-            <a:pPr lvl="0" indent="0" marL="0">
-              <a:buNone/>
-            </a:pPr>
-            <a:r>
-              <a:rPr/>
-              <a:t>Handout section 6.2 derives it in three lines.</a:t>
+              <a:t>Note that Lasso has no such formula. The absolute value has a corner, so it cannot be differentiated at zero, and the solution has to be found iteratively. That inconvenience is inseparable from the property that makes Lasso useful: the corner is exactly what produces the zeros, as two slides from now show.</a:t>
             </a:r>
           </a:p>
         </p:txBody>
@@ -4938,7 +4938,7 @@
             </a:pPr>
             <a:r>
               <a:rPr/>
-              <a:t>Ridge tilts the floor. Once coefficient size costs something, moving along that flat direction is no longer free, the flatness acquires a slope, and a single lowest point appears.</a:t>
+              <a:t>Ridge tilts the floor of that valley. Once coefficient size costs something, moving along that flat direction is no longer free, the flatness acquires a slope, and a single lowest point appears.</a:t>
             </a:r>
           </a:p>
           <a:p>
@@ -5066,21 +5066,21 @@
             </a:pPr>
             <a:r>
               <a:rPr/>
-              <a:t>Think of the penalty as a budget: you may spend a fixed total on coefficients and want the best fit that money buys. Draw what you can afford. Charging squares gives a disc; charging absolute values gives a diamond on its corners.</a:t>
-            </a:r>
-          </a:p>
-          <a:p>
-            <a:pPr lvl="0" indent="0" marL="0">
-              <a:buNone/>
-            </a:pPr>
-          </a:p>
-          <a:p>
-            <a:pPr lvl="0" indent="0" marL="0">
-              <a:buNone/>
-            </a:pPr>
-            <a:r>
-              <a:rPr/>
-              <a:t>The best affordable fit is where the error contours first touch the region.</a:t>
+              <a:t>Think of the penalty as a budget: you may spend a fixed total on coefficients and want the best fit that money buys. Draw what you can afford. For two coefficients, charging squares makes the affordable region a disc; charging absolute values makes it a diamond, a square turned to stand on its corners.</a:t>
+            </a:r>
+          </a:p>
+          <a:p>
+            <a:pPr lvl="0" indent="0" marL="0">
+              <a:buNone/>
+            </a:pPr>
+          </a:p>
+          <a:p>
+            <a:pPr lvl="0" indent="0" marL="0">
+              <a:buNone/>
+            </a:pPr>
+            <a:r>
+              <a:rPr/>
+              <a:t>The best affordable fit is where the error contours (the rings of equal cost around the unpenalised answer) first touch the region.</a:t>
             </a:r>
           </a:p>
           <a:p>
@@ -5204,35 +5204,7 @@
             </a:pPr>
             <a:r>
               <a:rPr/>
-              <a:t>Give the order in which lasso drops features on the housing data, because it is not arbitrary: garage first at lambda 10,000 - the smallest effect once everything is on a common scale - then distance and age, and by 40,000 only area survives.</a:t>
-            </a:r>
-          </a:p>
-          <a:p>
-            <a:pPr lvl="0" indent="0" marL="0">
-              <a:buNone/>
-            </a:pPr>
-          </a:p>
-          <a:p>
-            <a:pPr lvl="0" indent="0" marL="0">
-              <a:buNone/>
-            </a:pPr>
-            <a:r>
-              <a:rPr/>
-              <a:t>Nobody told it which features matter. It was told to keep the total size small, and this is the arrangement that buys the most accuracy for each unit of coefficient size it spends.</a:t>
-            </a:r>
-          </a:p>
-          <a:p>
-            <a:pPr lvl="0" indent="0" marL="0">
-              <a:buNone/>
-            </a:pPr>
-          </a:p>
-          <a:p>
-            <a:pPr lvl="0" indent="0" marL="0">
-              <a:buNone/>
-            </a:pPr>
-            <a:r>
-              <a:rPr/>
-              <a:t>The warning: the selection depends entirely on lambda, so “Lasso chose these features” is never a complete statement.</a:t>
+              <a:t>The housing data again, with all six features scaled, and lambda growing from left to right. Point at the right panel: one by one the lasso lines reach the zero line and stay on it. The next slide reads off the order.</a:t>
             </a:r>
           </a:p>
         </p:txBody>
@@ -5384,7 +5356,7 @@
             </a:r>
             <a:r>
               <a:rPr/>
-              <a:t>. “Lasso chose these four features” is not a complete statement - at a different lambda it chooses differently. Presenting lasso output as an objective ranking of importance is one of the commonest misuses of it.</a:t>
+              <a:t>. “Lasso chose these three features” is not a complete statement - at a different lambda it chooses differently. Presenting lasso output as an objective ranking of importance is one of the commonest misuses of it.</a:t>
             </a:r>
           </a:p>
           <a:p>
@@ -5604,21 +5576,21 @@
             </a:pPr>
             <a:r>
               <a:rPr/>
-              <a:t>Stress what is and is not broken: the PREDICTIONS are fine throughout - the combined effect is stable at about 2,420, close to the true 2,400. It is the EXPLANATION that is noise.</a:t>
-            </a:r>
-          </a:p>
-          <a:p>
-            <a:pPr lvl="0" indent="0" marL="0">
-              <a:buNone/>
-            </a:pPr>
-          </a:p>
-          <a:p>
-            <a:pPr lvl="0" indent="0" marL="0">
-              <a:buNone/>
-            </a:pPr>
-            <a:r>
-              <a:rPr/>
-              <a:t>Anyone reading these coefficients to learn what drives house prices would draw nonsense, confidently. With ridge at lambda 10 the same four splits give 38,000 to 41,000 on both columns, split evenly, because two moderate coefficients cost less under a squared penalty than one huge positive and one huge negative.</a:t>
+              <a:t>Stress what is and is not broken: the PREDICTIONS are fine throughout. What a square metre adds is the metres coefficient plus 10.76 times the feet coefficient, since a square metre is 10.76 square feet, and on every split that sum stays within about 2% of the true 2,400 (the notebook prints 2,424 for its own split). It is the EXPLANATION that is noise.</a:t>
+            </a:r>
+          </a:p>
+          <a:p>
+            <a:pPr lvl="0" indent="0" marL="0">
+              <a:buNone/>
+            </a:pPr>
+          </a:p>
+          <a:p>
+            <a:pPr lvl="0" indent="0" marL="0">
+              <a:buNone/>
+            </a:pPr>
+            <a:r>
+              <a:rPr/>
+              <a:t>Anyone reading these coefficients to learn what drives house prices would draw nonsense, confidently. With ridge at lambda 10 the same four splits give 38,000 to 41,000 on both columns, split evenly. Say the units, or the comparison misleads: ridge runs on scaled features, so these are euros per standard deviation of area, not euros per square metre, and they cannot be set against the table. What matters is that they are stable and equal, because two moderate coefficients cost less under a squared penalty than one huge positive and one huge negative.</a:t>
             </a:r>
           </a:p>
           <a:p>
@@ -5870,7 +5842,7 @@
             </a:pPr>
             <a:r>
               <a:rPr/>
-              <a:t>The x axis is how correlated each feature is with area; the y axis is how far its estimated coefficient landed from the truth. Two of the three features uncorrelated with area, distance and age, are recovered to within 1%; garage is the exception, 9.6% out, because a yes-or-no column varies little and the noise weighs more on its coefficient. Bathrooms, at 0.49, is out by 9%. Bedrooms, at 0.77, is out by 17%.</a:t>
+              <a:t>The x axis is how correlated each feature is with area; the y axis is how far its estimated coefficient landed from the truth. Read it from left to right. Three features are uncorrelated with area. Two of them, distance and age, are recovered to within 1%. The third, garage, is 9.6% out: it is a yes-or-no column, so it varies little, and the noise weighs more on its coefficient. Then the correlated ones: bathrooms, correlated 0.49 with area, is 9% out; bedrooms, correlated 0.77, is 17% out.</a:t>
             </a:r>
           </a:p>
           <a:p>
@@ -6214,7 +6186,7 @@
             </a:pPr>
             <a:r>
               <a:rPr/>
-              <a:t>And the number to leave them with, repeated from before the break: a penalty of one hundredth took the largest coefficient from billions to 365 and the test error from 24,656 to 22.8. One number, chosen well, bought all of that.</a:t>
+              <a:t>And the number to leave them with, repeated from slide 39: a penalty of one hundredth took the largest coefficient from billions to 365 and the test error from 24,656 to 22.8. One number, chosen well, bought all of that.</a:t>
             </a:r>
           </a:p>
           <a:p>
@@ -6310,7 +6282,7 @@
             </a:pPr>
             <a:r>
               <a:rPr/>
-              <a:t>Set it explicitly and say when it is discussed. It uses a new dataset - bike sharing demand - so the exploration is theirs to do.</a:t>
+              <a:t>Set it explicitly and say when it is discussed. It uses a new dataset, bike sharing demand, so the exploration is theirs to do.</a:t>
             </a:r>
           </a:p>
           <a:p>
@@ -6516,21 +6488,21 @@
             </a:pPr>
             <a:r>
               <a:rPr/>
-              <a:t>Give the three in increasing order of depth. The first is convenience. The second is a design decision: being wrong by 40,000 on one house costs the same as 20,000 on four, which matches most intuitions about what a bad prediction is.</a:t>
-            </a:r>
-          </a:p>
-          <a:p>
-            <a:pPr lvl="0" indent="0" marL="0">
-              <a:buNone/>
-            </a:pPr>
-          </a:p>
-          <a:p>
-            <a:pPr lvl="0" indent="0" marL="0">
-              <a:buNone/>
-            </a:pPr>
-            <a:r>
-              <a:rPr/>
-              <a:t>The third is the real reason and worth saying even though we do not prove it: if you believe the noise is Gaussian, least squares is not a convention, it is the maximum likelihood estimator. That connects to the residual histogram in notebook 1.</a:t>
+              <a:t>Give the three reasons on the slide in increasing order of depth. The first, differentiability, is convenience: the cost has a derivative everywhere, so calculus can find its minimum. The second is a design decision: being wrong by 40,000 on one house costs the same as 20,000 on four, which matches most intuitions about what a bad prediction is.</a:t>
+            </a:r>
+          </a:p>
+          <a:p>
+            <a:pPr lvl="0" indent="0" marL="0">
+              <a:buNone/>
+            </a:pPr>
+          </a:p>
+          <a:p>
+            <a:pPr lvl="0" indent="0" marL="0">
+              <a:buNone/>
+            </a:pPr>
+            <a:r>
+              <a:rPr/>
+              <a:t>The third is the real reason and worth saying even though we do not prove it: if you believe the noise is Gaussian, least squares is not a convention, it is the maximum likelihood estimator - the coefficients it picks are the ones under which the observed prices were most probable. That connects to the histogram of the residuals (the leftover errors) in notebook 1, which has the bell shape of a Gaussian.</a:t>
             </a:r>
           </a:p>
           <a:p>
@@ -6626,7 +6598,7 @@
             </a:pPr>
             <a:r>
               <a:rPr/>
-              <a:t>Name the parts: m examples, the half for convenience when we differentiate, the square doing the work discussed. This is the mean squared error, MSE from here on, and the name is worth saying aloud because every later slide uses the abbreviation.</a:t>
+              <a:t>Name the parts: m is the number of examples, the sum runs over all of them, the half is there for convenience when we differentiate, and the square makes every error positive and punishes large ones most, as the previous slide said. This is the mean squared error, MSE from here on, and the name is worth saying aloud because every later slide uses the abbreviation.</a:t>
             </a:r>
           </a:p>
           <a:p>

</xml_diff>

<commit_message>
Write lesson 3's error sums out on slides 7 and 8
Slide 7 said adding up the errors fails without showing the sum: it now
prints the plain sum of the errors, and the absolute and squared sums that
make every error positive. Slide 8 opens on the squared error and says
each error e counts as e squared rather than its absolute value, which the
three reasons then compare. Handout section 2.2 carries the same sums.

Co-Authored-By: Claude Opus 5.5 <noreply@anthropic.com>
</commit_message>
<xml_diff>
--- a/Lessons/03_regression/Slides/regression_slides.pptx
+++ b/Lessons/03_regression/Slides/regression_slides.pptx
@@ -6392,21 +6392,21 @@
             </a:pPr>
             <a:r>
               <a:rPr/>
-              <a:t>This is the intuition before the formula, and it takes ten seconds. A model that is 50,000 too high on one house and 50,000 too low on another is not perfect, but the sum of its errors is zero.</a:t>
-            </a:r>
-          </a:p>
-          <a:p>
-            <a:pPr lvl="0" indent="0" marL="0">
-              <a:buNone/>
-            </a:pPr>
-          </a:p>
-          <a:p>
-            <a:pPr lvl="0" indent="0" marL="0">
-              <a:buNone/>
-            </a:pPr>
-            <a:r>
-              <a:rPr/>
-              <a:t>So every error must count as a positive amount. That is the requirement; squaring is one way to meet it, absolute value is another. The next slide says why we choose squaring.</a:t>
+              <a:t>This is the intuition before the formula, and it takes ten seconds. Read the first sum aloud: for every house i, the prediction minus the true price, added up. A model that is 50,000 too high on one house and 50,000 too low on another is not perfect, but that sum is zero.</a:t>
+            </a:r>
+          </a:p>
+          <a:p>
+            <a:pPr lvl="0" indent="0" marL="0">
+              <a:buNone/>
+            </a:pPr>
+          </a:p>
+          <a:p>
+            <a:pPr lvl="0" indent="0" marL="0">
+              <a:buNone/>
+            </a:pPr>
+            <a:r>
+              <a:rPr/>
+              <a:t>So every error must count as a positive amount. That is the requirement, and the last line gives the two ways of meeting it: take the absolute value of each error, or square it. The next slide says why we choose squaring, and the one after turns the squared sum into the cost the lesson minimises.</a:t>
             </a:r>
           </a:p>
         </p:txBody>
@@ -6488,7 +6488,21 @@
             </a:pPr>
             <a:r>
               <a:rPr/>
-              <a:t>Give the three reasons on the slide in increasing order of depth. The first, differentiability, is convenience: the cost has a derivative everywhere, so calculus can find its minimum. The second is a design decision: being wrong by 40,000 on one house costs the same as 20,000 on four, which matches most intuitions about what a bad prediction is.</a:t>
+              <a:t>Start from the formula on the first line, the squared error of the previous slide: for each house, the prediction minus the true price, squared, then added up. Call one error e: squared error adds e squared for it, absolute error would add the size of e.</a:t>
+            </a:r>
+          </a:p>
+          <a:p>
+            <a:pPr lvl="0" indent="0" marL="0">
+              <a:buNone/>
+            </a:pPr>
+          </a:p>
+          <a:p>
+            <a:pPr lvl="0" indent="0" marL="0">
+              <a:buNone/>
+            </a:pPr>
+            <a:r>
+              <a:rPr/>
+              <a:t>Then give the three reasons on the slide in increasing order of depth. The first, differentiability, is convenience: e squared has a derivative everywhere, while the absolute value has a corner at zero, so with squared error calculus can find the minimum directly. The second is a design decision: doubling an error quadruples its cost, so being wrong by 40,000 on one house costs the same as 20,000 on four, which matches most intuitions about what a bad prediction is.</a:t>
             </a:r>
           </a:p>
           <a:p>
@@ -16832,7 +16846,30 @@
             </a:pPr>
             <a:r>
               <a:rPr/>
-              <a:t>Adding up the errors fails: +50,000 and −50,000 cancel to zero.</a:t>
+              <a:t>Adding up the errors, Σᵢ (ŷ⁽ⁱ⁾ − y⁽ⁱ⁾), fails: +50,000 and −50,000 cancel to zero.</a:t>
+            </a:r>
+          </a:p>
+          <a:p>
+            <a:pPr lvl="0" indent="0" marL="0">
+              <a:buNone/>
+            </a:pPr>
+            <a:r>
+              <a:rPr/>
+              <a:t>Every error must count as a positive amount:</a:t>
+            </a:r>
+          </a:p>
+          <a:p>
+            <a:pPr lvl="0"/>
+            <a:r>
+              <a:rPr/>
+              <a:t>absolute error Σᵢ |ŷ⁽ⁱ⁾ − y⁽ⁱ⁾|</a:t>
+            </a:r>
+          </a:p>
+          <a:p>
+            <a:pPr lvl="0"/>
+            <a:r>
+              <a:rPr/>
+              <a:t>squared error Σᵢ (ŷ⁽ⁱ⁾ − y⁽ⁱ⁾)²</a:t>
             </a:r>
           </a:p>
         </p:txBody>
@@ -16911,12 +16948,19 @@
           <a:p>
             <a:pPr lvl="0"/>
             <a:r>
+              <a:rPr/>
+              <a:t>Squared error Σᵢ (ŷ⁽ⁱ⁾ − y⁽ⁱ⁾)²: each error e = ŷ⁽ⁱ⁾ − y⁽ⁱ⁾ counts as e², not as |⁠e⁠|</a:t>
+            </a:r>
+          </a:p>
+          <a:p>
+            <a:pPr lvl="0"/>
+            <a:r>
               <a:rPr b="1"/>
               <a:t>Differentiable everywhere</a:t>
             </a:r>
             <a:r>
               <a:rPr/>
-              <a:t>: no corner at zero</a:t>
+              <a:t>: e² is smooth, |⁠e⁠| has a corner at e = 0</a:t>
             </a:r>
           </a:p>
           <a:p>
@@ -16927,7 +16971,7 @@
             </a:r>
             <a:r>
               <a:rPr/>
-              <a:t> than several small ones</a:t>
+              <a:t>: double an error and |⁠e⁠| doubles, e² quadruples</a:t>
             </a:r>
           </a:p>
           <a:p>
@@ -16942,7 +16986,7 @@
             </a:r>
             <a:r>
               <a:rPr/>
-              <a:t>: the coefficients that make the observed prices most probable</a:t>
+              <a:t>: it picks the coefficients that make the observed prices most probable</a:t>
             </a:r>
           </a:p>
         </p:txBody>

</xml_diff>

<commit_message>
Mark lesson 3's arg min on the cost bowl
Notebook 1 now draws the cost on a finer and wider grid, so the bowl's
bottom is no longer cut off, and marks its lowest grid point with a gold
star: a slope of 2,790 and an intercept of -52,000, within one grid step
of the normal equation's 2,785 and -51,025. It is slide 13's arg min,
found by brute force. The gradient-descent path reuses the grid and now
shows the closed bowl too. Captions in the handout and commentary and the
slide 14 notes say what the star is. Re-run in the container; no other
output changed.

Co-Authored-By: Claude Opus 5.5 <noreply@anthropic.com>
</commit_message>
<xml_diff>
--- a/Lessons/03_regression/Slides/regression_slides.pptx
+++ b/Lessons/03_regression/Slides/regression_slides.pptx
@@ -1075,7 +1075,15 @@
             </a:pPr>
             <a:r>
               <a:rPr/>
-              <a:t>From notebook 1. Two parameters, so the cost is a surface over the plane of (slope, intercept), and fitting means finding its lowest point.</a:t>
+              <a:t>From notebook 1. Two parameters, so the cost is a surface over the plane of (slope, intercept), and fitting means finding its lowest point. The gold star is the previous slide’s (w</a:t>
+            </a:r>
+            <a:r>
+              <a:rPr i="1"/>
+              <a:t>, b</a:t>
+            </a:r>
+            <a:r>
+              <a:rPr/>
+              <a:t>): the notebook computes the cost at every point of a grid and keeps the lowest, a slope of 2,790 and an intercept of -52,000. The normal equation, two slides on, leads to the exact answer, 2,785 and -51,025, within one grid step of the star.</a:t>
             </a:r>
           </a:p>
           <a:p>
@@ -12315,8 +12323,8 @@
         </p:blipFill>
         <p:spPr bwMode="auto">
           <a:xfrm>
-            <a:off x="457200" y="1461889"/>
-            <a:ext cx="8229600" cy="2768600"/>
+            <a:off x="457200" y="1468239"/>
+            <a:ext cx="8229600" cy="2755900"/>
           </a:xfrm>
           <a:prstGeom prst="rect">
             <a:avLst/>

</xml_diff>

<commit_message>
Spell out lesson 3's gradient-descent loop, and b's update
Slide 23 showed only w's update, with b folded into the handout's theta,
and no slide said that every round recomputes the predictions. Slide 23
now gives both gradients, w's and b's. A new slide 24 lists one
iteration as five steps - predict, measure the errors, average them into
the gradients, step w and b, go back - with notes tying them to the
notebook's gradient_descent function. Handout section 4.1 gains the same
loop in general form, and the commentary the boxed per-coefficient
gradients. Slides 24 onwards move up by one, with the plan, tables,
notes, commentary and worked-example keys.

Co-Authored-By: Claude Opus 5.5 <noreply@anthropic.com>
</commit_message>
<xml_diff>
--- a/Lessons/03_regression/Slides/regression_slides.pptx
+++ b/Lessons/03_regression/Slides/regression_slides.pptx
@@ -5,7 +5,7 @@
     <p:sldMasterId id="2147483648" r:id="rId1"/>
   </p:sldMasterIdLst>
   <p:notesMasterIdLst>
-    <p:notesMasterId r:id="rId57"/>
+    <p:notesMasterId r:id="rId58"/>
   </p:notesMasterIdLst>
   <p:sldIdLst>
     <p:sldId id="256" r:id="rId2"/>
@@ -63,6 +63,7 @@
     <p:sldId id="308" r:id="rId54"/>
     <p:sldId id="309" r:id="rId55"/>
     <p:sldId id="310" r:id="rId56"/>
+    <p:sldId id="311" r:id="rId57"/>
   </p:sldIdLst>
   <p:sldSz cx="9144000" cy="5143500" type="screen16x9"/>
   <p:notesSz cx="6858000" cy="9144000"/>
@@ -980,7 +981,7 @@
             </a:pPr>
             <a:r>
               <a:rPr/>
-              <a:t>This line is the whole of “fitting”. Everything else in the first half of the lesson is a way of computing it: exactly, with the normal equation on slides 15-18, or step by step, with gradient descent on slides 22-26. The next slide shows J as a surface over (w, b), and the pair this formula asks for is the lowest point of that surface.</a:t>
+              <a:t>This line is the whole of “fitting”. Everything else in the first half of the lesson is a way of computing it: exactly, with the normal equation on slides 15-19, or step by step, with gradient descent on slides 22-27. The next slide shows J as a surface over (w, b), and the pair this formula asks for is the lowest point of that surface.</a:t>
             </a:r>
           </a:p>
           <a:p>
@@ -2282,7 +2283,21 @@
             </a:pPr>
             <a:r>
               <a:rPr/>
-              <a:t>Read the gradient aloud as a sentence, because its shape carries a lesson: each example pulls the coefficient in proportion to two things - how wrong the prediction was, AND how large that feature was for that example.</a:t>
+              <a:t>Two parameters, so two slopes to feel in the fog: how fast J rises as w grows, and how fast it rises as b grows. Both come from differentiating the mean squared error; handout section 4.1 does it in two lines. Write the error of house i as e(i) = y-hat(i) - y(i), and both gradients are averages of errors.</a:t>
+            </a:r>
+          </a:p>
+          <a:p>
+            <a:pPr lvl="0" indent="0" marL="0">
+              <a:buNone/>
+            </a:pPr>
+          </a:p>
+          <a:p>
+            <a:pPr lvl="0" indent="0" marL="0">
+              <a:buNone/>
+            </a:pPr>
+            <a:r>
+              <a:rPr/>
+              <a:t>Read the first one aloud as a sentence, because its shape carries a lesson: each example pulls the coefficient in proportion to two things - how wrong the prediction was, AND how large that feature was for that example.</a:t>
             </a:r>
           </a:p>
           <a:p>
@@ -2310,21 +2325,21 @@
             </a:pPr>
             <a:r>
               <a:rPr/>
-              <a:t>That is precisely why unscaled features cause trouble, and it is lesson 2’s argument arriving from a different direction. The intercept gradient has no x in it - every example gets an equal vote there.</a:t>
-            </a:r>
-          </a:p>
-          <a:p>
-            <a:pPr lvl="0" indent="0" marL="0">
-              <a:buNone/>
-            </a:pPr>
-          </a:p>
-          <a:p>
-            <a:pPr lvl="0" indent="0" marL="0">
-              <a:buNone/>
-            </a:pPr>
-            <a:r>
-              <a:rPr/>
-              <a:t>Handout 4.2 works one step by hand: after a single update the slope has moved 163 times further than the intercept.</a:t>
+              <a:t>That is precisely why unscaled features cause trouble, and it is lesson 2’s argument arriving from a different direction. The intercept’s gradient, on the right, has no x in it - every example gets an equal vote there, as if b were the coefficient of a feature that is always 1.</a:t>
+            </a:r>
+          </a:p>
+          <a:p>
+            <a:pPr lvl="0" indent="0" marL="0">
+              <a:buNone/>
+            </a:pPr>
+          </a:p>
+          <a:p>
+            <a:pPr lvl="0" indent="0" marL="0">
+              <a:buNone/>
+            </a:pPr>
+            <a:r>
+              <a:rPr/>
+              <a:t>With several features there is one gradient like the first for each w_j, with x_j in place of x. The next slide puts the two gradients to work.</a:t>
             </a:r>
           </a:p>
         </p:txBody>
@@ -2406,71 +2421,73 @@
             </a:pPr>
             <a:r>
               <a:rPr/>
-              <a:t>Say first that the prices here are in thousands of euros, so 240 means 240,000, which keeps the numbers small enough to read.</a:t>
-            </a:r>
-          </a:p>
-          <a:p>
-            <a:pPr lvl="0" indent="0" marL="0">
-              <a:buNone/>
-            </a:pPr>
-          </a:p>
-          <a:p>
-            <a:pPr lvl="0" indent="0" marL="0">
-              <a:buNone/>
-            </a:pPr>
-            <a:r>
-              <a:rPr/>
-              <a:t>Both gradients are negative - the model starts at zero and predicts zero for every house, so every prediction is far too low - and both parameters therefore increase. So far, nothing surprising.</a:t>
-            </a:r>
-          </a:p>
-          <a:p>
-            <a:pPr lvl="0" indent="0" marL="0">
-              <a:buNone/>
-            </a:pPr>
-          </a:p>
-          <a:p>
-            <a:pPr lvl="0" indent="0" marL="0">
-              <a:buNone/>
-            </a:pPr>
-            <a:r>
-              <a:rPr/>
-              <a:t>Now the thing to notice, and give the room a moment to spot it: after one identical step the slope has moved </a:t>
-            </a:r>
-            <a:r>
-              <a:rPr b="1"/>
-              <a:t>163 times further</a:t>
-            </a:r>
-            <a:r>
-              <a:rPr/>
-              <a:t> than the intercept.</a:t>
-            </a:r>
-          </a:p>
-          <a:p>
-            <a:pPr lvl="0" indent="0" marL="0">
-              <a:buNone/>
-            </a:pPr>
-          </a:p>
-          <a:p>
-            <a:pPr lvl="0" indent="0" marL="0">
-              <a:buNone/>
-            </a:pPr>
-            <a:r>
-              <a:rPr/>
-              <a:t>Nothing clever caused that. In the gradient, each house’s error is multiplied by its area for the slope, and by 1 for the intercept (the intercept behaves like a feature that is always 1). The two areas are 80 and 200, so the slope’s gradient comes out about 163 times larger before anything else happens. With one shared learning rate, the intercept crawls towards its value long after the slope has arrived - which is exactly what notebook 1 shows after 4,000 iterations.</a:t>
-            </a:r>
-          </a:p>
-          <a:p>
-            <a:pPr lvl="0" indent="0" marL="0">
-              <a:buNone/>
-            </a:pPr>
-          </a:p>
-          <a:p>
-            <a:pPr lvl="0" indent="0" marL="0">
-              <a:buNone/>
-            </a:pPr>
-            <a:r>
-              <a:rPr/>
-              <a:t>That is the concrete cost of unscaled features, and the cure is lesson 2’s. Handout section 4.2.</a:t>
+              <a:t>This is the loop the fog picture describes, written as the five things the computer does, in order. Walk it once with the room before the numbers on the next slide.</a:t>
+            </a:r>
+          </a:p>
+          <a:p>
+            <a:pPr lvl="0" indent="0" marL="0">
+              <a:buNone/>
+            </a:pPr>
+          </a:p>
+          <a:p>
+            <a:pPr lvl="0" indent="0" marL="0">
+              <a:buNone/>
+            </a:pPr>
+            <a:r>
+              <a:rPr/>
+              <a:t>Step 1 uses whatever w and b the previous round left; the very first round starts from a guess, here w = 0 and b = 0. Steps 2 and 3 turn the predictions into the two gradients. Step 4 moves BOTH parameters at once, each against its own gradient, by the same learning rate alpha - and both updates use the gradients computed from the old values, before either has moved.</a:t>
+            </a:r>
+          </a:p>
+          <a:p>
+            <a:pPr lvl="0" indent="0" marL="0">
+              <a:buNone/>
+            </a:pPr>
+          </a:p>
+          <a:p>
+            <a:pPr lvl="0" indent="0" marL="0">
+              <a:buNone/>
+            </a:pPr>
+            <a:r>
+              <a:rPr/>
+              <a:t>Step 5 is the part that makes it iterative, and the part students most often miss: after the update the model is a different line, so every prediction changes, so every error changes, so the gradients have to be computed again from scratch. Nothing from the previous round is reused except w and b themselves. The loop stops after a fixed number of rounds, or when the cost stops falling.</a:t>
+            </a:r>
+          </a:p>
+          <a:p>
+            <a:pPr lvl="0" indent="0" marL="0">
+              <a:buNone/>
+            </a:pPr>
+          </a:p>
+          <a:p>
+            <a:pPr lvl="0" indent="0" marL="0">
+              <a:buNone/>
+            </a:pPr>
+            <a:r>
+              <a:rPr/>
+              <a:t>In compact form, with theta holding b and w, steps 3 and 4 are the handout’s theta &lt;- theta - alpha times the gradient of J. In notebook 1 the loop is the </a:t>
+            </a:r>
+            <a:r>
+              <a:rPr>
+                <a:latin typeface="Courier"/>
+              </a:rPr>
+              <a:t>gradient_descent</a:t>
+            </a:r>
+            <a:r>
+              <a:rPr/>
+              <a:t> function, and its body is these steps line for line: error = (w * x + b) - y, then grad_w = (error * x).mean() and grad_b = error.mean(), then the two updates. Notebook 1 runs it 4,000 times.</a:t>
+            </a:r>
+          </a:p>
+          <a:p>
+            <a:pPr lvl="0" indent="0" marL="0">
+              <a:buNone/>
+            </a:pPr>
+          </a:p>
+          <a:p>
+            <a:pPr lvl="0" indent="0" marL="0">
+              <a:buNone/>
+            </a:pPr>
+            <a:r>
+              <a:rPr/>
+              <a:t>The next slide is one pass through steps 1 to 4, on two houses.</a:t>
             </a:r>
           </a:p>
         </p:txBody>
@@ -2552,63 +2569,71 @@
             </a:pPr>
             <a:r>
               <a:rPr/>
-              <a:t>Both panels are from notebook 1, and they are the same run seen two ways.</a:t>
-            </a:r>
-          </a:p>
-          <a:p>
-            <a:pPr lvl="0" indent="0" marL="0">
-              <a:buNone/>
-            </a:pPr>
-          </a:p>
-          <a:p>
-            <a:pPr lvl="0" indent="0" marL="0">
-              <a:buNone/>
-            </a:pPr>
-            <a:r>
-              <a:rPr/>
-              <a:t>Left: the cost against the iteration number. It falls steeply in the first few dozen steps and then flattens into a long tail that is still creeping at 4,000. Point at the flat part and say what it means - the model was essentially fitted very early, and almost all the iterations bought almost nothing.</a:t>
-            </a:r>
-          </a:p>
-          <a:p>
-            <a:pPr lvl="0" indent="0" marL="0">
-              <a:buNone/>
-            </a:pPr>
-          </a:p>
-          <a:p>
-            <a:pPr lvl="0" indent="0" marL="0">
-              <a:buNone/>
-            </a:pPr>
-            <a:r>
-              <a:rPr/>
-              <a:t>Right: the same run drawn on the contours, with the star marking the exact solution from the normal equation. The path arrives quickly in the steep direction and then crawls along the floor of the valley towards the star. That crawl is the previous slide’s 163-to-1 asymmetry, and it is the condition number made visible.</a:t>
-            </a:r>
-          </a:p>
-          <a:p>
-            <a:pPr lvl="0" indent="0" marL="0">
-              <a:buNone/>
-            </a:pPr>
-          </a:p>
-          <a:p>
-            <a:pPr lvl="0" indent="0" marL="0">
-              <a:buNone/>
-            </a:pPr>
-            <a:r>
-              <a:rPr/>
-              <a:t>The two panels are one point: progress stalls because one stride length has to serve a direction that is steep and a direction that is nearly flat.</a:t>
-            </a:r>
-          </a:p>
-          <a:p>
-            <a:pPr lvl="0" indent="0" marL="0">
-              <a:buNone/>
-            </a:pPr>
-          </a:p>
-          <a:p>
-            <a:pPr lvl="0" indent="0" marL="0">
-              <a:buNone/>
-            </a:pPr>
-            <a:r>
-              <a:rPr/>
-              <a:t>Ask what would happen with a much larger stride. Answer on the next slide.</a:t>
+              <a:t>This is steps 1 to 4 of the previous slide, done once. Say first that the prices here are in thousands of euros, so 240 means 240,000, which keeps the numbers small enough to read.</a:t>
+            </a:r>
+          </a:p>
+          <a:p>
+            <a:pPr lvl="0" indent="0" marL="0">
+              <a:buNone/>
+            </a:pPr>
+          </a:p>
+          <a:p>
+            <a:pPr lvl="0" indent="0" marL="0">
+              <a:buNone/>
+            </a:pPr>
+            <a:r>
+              <a:rPr/>
+              <a:t>Both gradients are negative - the model starts at zero and predicts zero for every house, so every prediction is far too low - and both parameters therefore increase. So far, nothing surprising.</a:t>
+            </a:r>
+          </a:p>
+          <a:p>
+            <a:pPr lvl="0" indent="0" marL="0">
+              <a:buNone/>
+            </a:pPr>
+          </a:p>
+          <a:p>
+            <a:pPr lvl="0" indent="0" marL="0">
+              <a:buNone/>
+            </a:pPr>
+            <a:r>
+              <a:rPr/>
+              <a:t>Now the thing to notice, and give the room a moment to spot it: after one identical step the slope has moved </a:t>
+            </a:r>
+            <a:r>
+              <a:rPr b="1"/>
+              <a:t>163 times further</a:t>
+            </a:r>
+            <a:r>
+              <a:rPr/>
+              <a:t> than the intercept.</a:t>
+            </a:r>
+          </a:p>
+          <a:p>
+            <a:pPr lvl="0" indent="0" marL="0">
+              <a:buNone/>
+            </a:pPr>
+          </a:p>
+          <a:p>
+            <a:pPr lvl="0" indent="0" marL="0">
+              <a:buNone/>
+            </a:pPr>
+            <a:r>
+              <a:rPr/>
+              <a:t>Nothing clever caused that. In the gradient, each house’s error is multiplied by its area for the slope, and by 1 for the intercept (the intercept behaves like a feature that is always 1). The two areas are 80 and 200, so the slope’s gradient comes out about 163 times larger before anything else happens. With one shared learning rate, the intercept crawls towards its value long after the slope has arrived - which is exactly what notebook 1 shows after 4,000 iterations.</a:t>
+            </a:r>
+          </a:p>
+          <a:p>
+            <a:pPr lvl="0" indent="0" marL="0">
+              <a:buNone/>
+            </a:pPr>
+          </a:p>
+          <a:p>
+            <a:pPr lvl="0" indent="0" marL="0">
+              <a:buNone/>
+            </a:pPr>
+            <a:r>
+              <a:rPr/>
+              <a:t>That is the concrete cost of unscaled features, and the cure is lesson 2’s. Handout section 4.2.</a:t>
             </a:r>
           </a:p>
         </p:txBody>
@@ -2690,49 +2715,63 @@
             </a:pPr>
             <a:r>
               <a:rPr/>
-              <a:t>Left: too small, correct but slow - the cost falls every iteration and simply takes too many of them. Middle: about right. Right: too large, and it climbs out of the valley.</a:t>
-            </a:r>
-          </a:p>
-          <a:p>
-            <a:pPr lvl="0" indent="0" marL="0">
-              <a:buNone/>
-            </a:pPr>
-          </a:p>
-          <a:p>
-            <a:pPr lvl="0" indent="0" marL="0">
-              <a:buNone/>
-            </a:pPr>
-            <a:r>
-              <a:rPr/>
-              <a:t>The threshold is not a rule of thumb. Handout section 4.3 derives it: for a bowl whose curvature (how quickly the slope changes) is c, gradient descent converges only when alpha is below 2/c. With several features the bowl has a different curvature in each direction, and the steepest one sets the limit; on unscaled data that steepest direction belongs to the feature with the largest spread.</a:t>
-            </a:r>
-          </a:p>
-          <a:p>
-            <a:pPr lvl="0" indent="0" marL="0">
-              <a:buNone/>
-            </a:pPr>
-          </a:p>
-          <a:p>
-            <a:pPr lvl="0" indent="0" marL="0">
-              <a:buNone/>
-            </a:pPr>
-            <a:r>
-              <a:rPr/>
-              <a:t>So the safe learning rate is set by your worst-scaled feature, which is another argument for scaling everything.</a:t>
-            </a:r>
-          </a:p>
-          <a:p>
-            <a:pPr lvl="0" indent="0" marL="0">
-              <a:buNone/>
-            </a:pPr>
-          </a:p>
-          <a:p>
-            <a:pPr lvl="0" indent="0" marL="0">
-              <a:buNone/>
-            </a:pPr>
-            <a:r>
-              <a:rPr/>
-              <a:t>Practical recipe to give them: start at 0.01 on scaled features, watch the cost, divide by three if it rises. Lesson 5 replaces the recipe with a search.</a:t>
+              <a:t>Both panels are from notebook 1, and they are the same run seen two ways.</a:t>
+            </a:r>
+          </a:p>
+          <a:p>
+            <a:pPr lvl="0" indent="0" marL="0">
+              <a:buNone/>
+            </a:pPr>
+          </a:p>
+          <a:p>
+            <a:pPr lvl="0" indent="0" marL="0">
+              <a:buNone/>
+            </a:pPr>
+            <a:r>
+              <a:rPr/>
+              <a:t>Left: the cost against the iteration number. It falls steeply in the first few dozen steps and then flattens into a long tail that is still creeping at 4,000. Point at the flat part and say what it means - the model was essentially fitted very early, and almost all the iterations bought almost nothing.</a:t>
+            </a:r>
+          </a:p>
+          <a:p>
+            <a:pPr lvl="0" indent="0" marL="0">
+              <a:buNone/>
+            </a:pPr>
+          </a:p>
+          <a:p>
+            <a:pPr lvl="0" indent="0" marL="0">
+              <a:buNone/>
+            </a:pPr>
+            <a:r>
+              <a:rPr/>
+              <a:t>Right: the same run drawn on the contours, with the star marking the exact solution from the normal equation. The path arrives quickly in the steep direction and then crawls along the floor of the valley towards the star. That crawl is the previous slide’s 163-to-1 asymmetry, and it is the condition number made visible.</a:t>
+            </a:r>
+          </a:p>
+          <a:p>
+            <a:pPr lvl="0" indent="0" marL="0">
+              <a:buNone/>
+            </a:pPr>
+          </a:p>
+          <a:p>
+            <a:pPr lvl="0" indent="0" marL="0">
+              <a:buNone/>
+            </a:pPr>
+            <a:r>
+              <a:rPr/>
+              <a:t>The two panels are one point: progress stalls because one stride length has to serve a direction that is steep and a direction that is nearly flat.</a:t>
+            </a:r>
+          </a:p>
+          <a:p>
+            <a:pPr lvl="0" indent="0" marL="0">
+              <a:buNone/>
+            </a:pPr>
+          </a:p>
+          <a:p>
+            <a:pPr lvl="0" indent="0" marL="0">
+              <a:buNone/>
+            </a:pPr>
+            <a:r>
+              <a:rPr/>
+              <a:t>Ask what would happen with a much larger stride. Answer on the next slide.</a:t>
             </a:r>
           </a:p>
         </p:txBody>
@@ -2814,35 +2853,49 @@
             </a:pPr>
             <a:r>
               <a:rPr/>
-              <a:t>The model, the cost, the exact solution and the iterative one, built from scratch. 25 minutes. Let them work through it themselves.</a:t>
-            </a:r>
-          </a:p>
-          <a:p>
-            <a:pPr lvl="0" indent="0" marL="0">
-              <a:buNone/>
-            </a:pPr>
-          </a:p>
-          <a:p>
-            <a:pPr lvl="0" indent="0" marL="0">
-              <a:buNone/>
-            </a:pPr>
-            <a:r>
-              <a:rPr/>
-              <a:t>The two moments worth pausing on together. First, the agreement between their four-line normal equation and scikit-learn, to within about 10⁻¹² - seeing it on their own screen convinces more than any assurance from the lecturer. Second, the coefficient table at the end, which is the setup for the last section of the lesson.</a:t>
-            </a:r>
-          </a:p>
-          <a:p>
-            <a:pPr lvl="0" indent="0" marL="0">
-              <a:buNone/>
-            </a:pPr>
-          </a:p>
-          <a:p>
-            <a:pPr lvl="0" indent="0" marL="0">
-              <a:buNone/>
-            </a:pPr>
-            <a:r>
-              <a:rPr/>
-              <a:t>Watch for anyone whose gradient descent diverges. That is the “try this” at the end of the notebook and it is a good thing to have happen.</a:t>
+              <a:t>Left: too small, correct but slow - the cost falls every iteration and simply takes too many of them. Middle: about right. Right: too large, and it climbs out of the valley.</a:t>
+            </a:r>
+          </a:p>
+          <a:p>
+            <a:pPr lvl="0" indent="0" marL="0">
+              <a:buNone/>
+            </a:pPr>
+          </a:p>
+          <a:p>
+            <a:pPr lvl="0" indent="0" marL="0">
+              <a:buNone/>
+            </a:pPr>
+            <a:r>
+              <a:rPr/>
+              <a:t>The threshold is not a rule of thumb. Handout section 4.3 derives it: for a bowl whose curvature (how quickly the slope changes) is c, gradient descent converges only when alpha is below 2/c. With several features the bowl has a different curvature in each direction, and the steepest one sets the limit; on unscaled data that steepest direction belongs to the feature with the largest spread.</a:t>
+            </a:r>
+          </a:p>
+          <a:p>
+            <a:pPr lvl="0" indent="0" marL="0">
+              <a:buNone/>
+            </a:pPr>
+          </a:p>
+          <a:p>
+            <a:pPr lvl="0" indent="0" marL="0">
+              <a:buNone/>
+            </a:pPr>
+            <a:r>
+              <a:rPr/>
+              <a:t>So the safe learning rate is set by your worst-scaled feature, which is another argument for scaling everything.</a:t>
+            </a:r>
+          </a:p>
+          <a:p>
+            <a:pPr lvl="0" indent="0" marL="0">
+              <a:buNone/>
+            </a:pPr>
+          </a:p>
+          <a:p>
+            <a:pPr lvl="0" indent="0" marL="0">
+              <a:buNone/>
+            </a:pPr>
+            <a:r>
+              <a:rPr/>
+              <a:t>Practical recipe to give them: start at 0.01 on scaled features, watch the cost, divide by three if it rises. Lesson 5 replaces the recipe with a search.</a:t>
             </a:r>
           </a:p>
         </p:txBody>
@@ -2924,21 +2977,35 @@
             </a:pPr>
             <a:r>
               <a:rPr/>
-              <a:t>15 minutes. Back for curves, overfitting and regularisation.</a:t>
-            </a:r>
-          </a:p>
-          <a:p>
-            <a:pPr lvl="0" indent="0" marL="0">
-              <a:buNone/>
-            </a:pPr>
-          </a:p>
-          <a:p>
-            <a:pPr lvl="0" indent="0" marL="0">
-              <a:buNone/>
-            </a:pPr>
-            <a:r>
-              <a:rPr/>
-              <a:t>Check who is stuck in notebook 1 - the second half assumes everyone got the coefficient table out, and it is much cheaper to fix now.</a:t>
+              <a:t>The model, the cost, the exact solution and the iterative one, built from scratch. 25 minutes. Let them work through it themselves.</a:t>
+            </a:r>
+          </a:p>
+          <a:p>
+            <a:pPr lvl="0" indent="0" marL="0">
+              <a:buNone/>
+            </a:pPr>
+          </a:p>
+          <a:p>
+            <a:pPr lvl="0" indent="0" marL="0">
+              <a:buNone/>
+            </a:pPr>
+            <a:r>
+              <a:rPr/>
+              <a:t>The two moments worth pausing on together. First, the agreement between their four-line normal equation and scikit-learn, to within about 10⁻¹² - seeing it on their own screen convinces more than any assurance from the lecturer. Second, the coefficient table at the end, which is the setup for the last section of the lesson.</a:t>
+            </a:r>
+          </a:p>
+          <a:p>
+            <a:pPr lvl="0" indent="0" marL="0">
+              <a:buNone/>
+            </a:pPr>
+          </a:p>
+          <a:p>
+            <a:pPr lvl="0" indent="0" marL="0">
+              <a:buNone/>
+            </a:pPr>
+            <a:r>
+              <a:rPr/>
+              <a:t>Watch for anyone whose gradient descent diverges. That is the “try this” at the end of the notebook and it is a good thing to have happen.</a:t>
             </a:r>
           </a:p>
         </p:txBody>
@@ -3020,35 +3087,21 @@
             </a:pPr>
             <a:r>
               <a:rPr/>
-              <a:t>Set the problem before the solution. Draw the U shape in the air: consumption high at both ends, minimum somewhere around 18 degrees.</a:t>
-            </a:r>
-          </a:p>
-          <a:p>
-            <a:pPr lvl="0" indent="0" marL="0">
-              <a:buNone/>
-            </a:pPr>
-          </a:p>
-          <a:p>
-            <a:pPr lvl="0" indent="0" marL="0">
-              <a:buNone/>
-            </a:pPr>
-            <a:r>
-              <a:rPr/>
-              <a:t>Ask what a straight line would do here. Someone will say it averages through the middle - right, and it will be too high in the centre and too low at both ends, wrong in a structural way rather than slightly imprecise.</a:t>
-            </a:r>
-          </a:p>
-          <a:p>
-            <a:pPr lvl="0" indent="0" marL="0">
-              <a:buNone/>
-            </a:pPr>
-          </a:p>
-          <a:p>
-            <a:pPr lvl="0" indent="0" marL="0">
-              <a:buNone/>
-            </a:pPr>
-            <a:r>
-              <a:rPr/>
-              <a:t>Notebook 2 has this dataset: 30 days of measurements, of which 21 are used for training - deliberately few.</a:t>
+              <a:t>15 minutes. Back for curves, overfitting and regularisation.</a:t>
+            </a:r>
+          </a:p>
+          <a:p>
+            <a:pPr lvl="0" indent="0" marL="0">
+              <a:buNone/>
+            </a:pPr>
+          </a:p>
+          <a:p>
+            <a:pPr lvl="0" indent="0" marL="0">
+              <a:buNone/>
+            </a:pPr>
+            <a:r>
+              <a:rPr/>
+              <a:t>Check who is stuck in notebook 1 - the second half assumes everyone got the coefficient table out, and it is much cheaper to fix now.</a:t>
             </a:r>
           </a:p>
         </p:txBody>
@@ -3130,35 +3183,35 @@
             </a:pPr>
             <a:r>
               <a:rPr/>
-              <a:t>From notebook 2. Daily energy consumption against outdoor temperature: heating at the cold end, cooling at the warm end, a minimum somewhere around 18 degrees.</a:t>
-            </a:r>
-          </a:p>
-          <a:p>
-            <a:pPr lvl="0" indent="0" marL="0">
-              <a:buNone/>
-            </a:pPr>
-          </a:p>
-          <a:p>
-            <a:pPr lvl="0" indent="0" marL="0">
-              <a:buNone/>
-            </a:pPr>
-            <a:r>
-              <a:rPr/>
-              <a:t>Let them look at it before saying anything. The U is obvious to a human eye in under a second, which is worth remarking on - the hard part was never seeing the shape, it is getting a model to represent it.</a:t>
-            </a:r>
-          </a:p>
-          <a:p>
-            <a:pPr lvl="0" indent="0" marL="0">
-              <a:buNone/>
-            </a:pPr>
-          </a:p>
-          <a:p>
-            <a:pPr lvl="0" indent="0" marL="0">
-              <a:buNone/>
-            </a:pPr>
-            <a:r>
-              <a:rPr/>
-              <a:t>Note the sample size out loud: 21 training points. Deliberately few, because the overfitting we are about to produce needs the model to have nearly as many coefficients as there are observations, and that situation is far more common in real work than people expect.</a:t>
+              <a:t>Set the problem before the solution. Draw the U shape in the air: consumption high at both ends, minimum somewhere around 18 degrees.</a:t>
+            </a:r>
+          </a:p>
+          <a:p>
+            <a:pPr lvl="0" indent="0" marL="0">
+              <a:buNone/>
+            </a:pPr>
+          </a:p>
+          <a:p>
+            <a:pPr lvl="0" indent="0" marL="0">
+              <a:buNone/>
+            </a:pPr>
+            <a:r>
+              <a:rPr/>
+              <a:t>Ask what a straight line would do here. Someone will say it averages through the middle - right, and it will be too high in the centre and too low at both ends, wrong in a structural way rather than slightly imprecise.</a:t>
+            </a:r>
+          </a:p>
+          <a:p>
+            <a:pPr lvl="0" indent="0" marL="0">
+              <a:buNone/>
+            </a:pPr>
+          </a:p>
+          <a:p>
+            <a:pPr lvl="0" indent="0" marL="0">
+              <a:buNone/>
+            </a:pPr>
+            <a:r>
+              <a:rPr/>
+              <a:t>Notebook 2 has this dataset: 30 days of measurements, of which 21 are used for training - deliberately few.</a:t>
             </a:r>
           </a:p>
         </p:txBody>
@@ -3350,35 +3403,35 @@
             </a:pPr>
             <a:r>
               <a:rPr/>
-              <a:t>This is the trick, and it surprises people. The model is a curve in t, but it is still a weighted sum of columns: one column holds t, a second holds t squared, and the weights w enter only by multiplication and addition. Nothing in the derivation of least squares required the columns to be the raw inputs - only that the model is linear in w, which it still is.</a:t>
-            </a:r>
-          </a:p>
-          <a:p>
-            <a:pPr lvl="0" indent="0" marL="0">
-              <a:buNone/>
-            </a:pPr>
-          </a:p>
-          <a:p>
-            <a:pPr lvl="0" indent="0" marL="0">
-              <a:buNone/>
-            </a:pPr>
-            <a:r>
-              <a:rPr/>
-              <a:t>So this is the same least squares, the same normal equation, the same code, on a design matrix with one extra column. PolynomialFeatures builds those columns.</a:t>
-            </a:r>
-          </a:p>
-          <a:p>
-            <a:pPr lvl="0" indent="0" marL="0">
-              <a:buNone/>
-            </a:pPr>
-          </a:p>
-          <a:p>
-            <a:pPr lvl="0" indent="0" marL="0">
-              <a:buNone/>
-            </a:pPr>
-            <a:r>
-              <a:rPr/>
-              <a:t>The same trick covers interactions like x1 times x2, logarithms, anything you can compute. It is why linear models remain useful on relationships that are not lines.</a:t>
+              <a:t>From notebook 2. Daily energy consumption against outdoor temperature: heating at the cold end, cooling at the warm end, a minimum somewhere around 18 degrees.</a:t>
+            </a:r>
+          </a:p>
+          <a:p>
+            <a:pPr lvl="0" indent="0" marL="0">
+              <a:buNone/>
+            </a:pPr>
+          </a:p>
+          <a:p>
+            <a:pPr lvl="0" indent="0" marL="0">
+              <a:buNone/>
+            </a:pPr>
+            <a:r>
+              <a:rPr/>
+              <a:t>Let them look at it before saying anything. The U is obvious to a human eye in under a second, which is worth remarking on - the hard part was never seeing the shape, it is getting a model to represent it.</a:t>
+            </a:r>
+          </a:p>
+          <a:p>
+            <a:pPr lvl="0" indent="0" marL="0">
+              <a:buNone/>
+            </a:pPr>
+          </a:p>
+          <a:p>
+            <a:pPr lvl="0" indent="0" marL="0">
+              <a:buNone/>
+            </a:pPr>
+            <a:r>
+              <a:rPr/>
+              <a:t>Note the sample size out loud: 21 training points. Deliberately few, because the overfitting we are about to produce needs the model to have nearly as many coefficients as there are observations, and that situation is far more common in real work than people expect.</a:t>
             </a:r>
           </a:p>
         </p:txBody>
@@ -3460,35 +3513,35 @@
             </a:pPr>
             <a:r>
               <a:rPr/>
-              <a:t>This is the diagnostic to teach. The U in the residuals says: there is structure here the model did not take.</a:t>
-            </a:r>
-          </a:p>
-          <a:p>
-            <a:pPr lvl="0" indent="0" marL="0">
-              <a:buNone/>
-            </a:pPr>
-          </a:p>
-          <a:p>
-            <a:pPr lvl="0" indent="0" marL="0">
-              <a:buNone/>
-            </a:pPr>
-            <a:r>
-              <a:rPr/>
-              <a:t>Contrast with notebook 1, where the residuals were a formless cloud with a spread matching the known noise. That is what “the model got everything” looks like.</a:t>
-            </a:r>
-          </a:p>
-          <a:p>
-            <a:pPr lvl="0" indent="0" marL="0">
-              <a:buNone/>
-            </a:pPr>
-          </a:p>
-          <a:p>
-            <a:pPr lvl="0" indent="0" marL="0">
-              <a:buNone/>
-            </a:pPr>
-            <a:r>
-              <a:rPr/>
-              <a:t>Give them the habit: after fitting anything, plot the residuals against each feature. A pattern means the model has missed something.</a:t>
+              <a:t>This is the trick, and it surprises people. The model is a curve in t, but it is still a weighted sum of columns: one column holds t, a second holds t squared, and the weights w enter only by multiplication and addition. Nothing in the derivation of least squares required the columns to be the raw inputs - only that the model is linear in w, which it still is.</a:t>
+            </a:r>
+          </a:p>
+          <a:p>
+            <a:pPr lvl="0" indent="0" marL="0">
+              <a:buNone/>
+            </a:pPr>
+          </a:p>
+          <a:p>
+            <a:pPr lvl="0" indent="0" marL="0">
+              <a:buNone/>
+            </a:pPr>
+            <a:r>
+              <a:rPr/>
+              <a:t>So this is the same least squares, the same normal equation, the same code, on a design matrix with one extra column. PolynomialFeatures builds those columns.</a:t>
+            </a:r>
+          </a:p>
+          <a:p>
+            <a:pPr lvl="0" indent="0" marL="0">
+              <a:buNone/>
+            </a:pPr>
+          </a:p>
+          <a:p>
+            <a:pPr lvl="0" indent="0" marL="0">
+              <a:buNone/>
+            </a:pPr>
+            <a:r>
+              <a:rPr/>
+              <a:t>The same trick covers interactions like x1 times x2, logarithms, anything you can compute. It is why linear models remain useful on relationships that are not lines.</a:t>
             </a:r>
           </a:p>
         </p:txBody>
@@ -3570,49 +3623,35 @@
             </a:pPr>
             <a:r>
               <a:rPr/>
-              <a:t>The contrast to the previous slide, and from notebook 1 - the housing fit, where the model did capture the structure.</a:t>
-            </a:r>
-          </a:p>
-          <a:p>
-            <a:pPr lvl="0" indent="0" marL="0">
-              <a:buNone/>
-            </a:pPr>
-          </a:p>
-          <a:p>
-            <a:pPr lvl="0" indent="0" marL="0">
-              <a:buNone/>
-            </a:pPr>
-            <a:r>
-              <a:rPr/>
-              <a:t>A formless cloud, centred on zero, with no pattern as you sweep left to right. The spread matches the 18,000 euros of noise we know we put in, which is the best possible outcome: the model has taken everything that was there to take, and what remains is the part nobody could have predicted.</a:t>
-            </a:r>
-          </a:p>
-          <a:p>
-            <a:pPr lvl="0" indent="0" marL="0">
-              <a:buNone/>
-            </a:pPr>
-          </a:p>
-          <a:p>
-            <a:pPr lvl="0" indent="0" marL="0">
-              <a:buNone/>
-            </a:pPr>
-            <a:r>
-              <a:rPr/>
-              <a:t>Put the two pictures side by side in words: a U means structure you missed, a cloud means you are done. That is the whole diagnostic, and it costs one line of code after every fit.</a:t>
-            </a:r>
-          </a:p>
-          <a:p>
-            <a:pPr lvl="0" indent="0" marL="0">
-              <a:buNone/>
-            </a:pPr>
-          </a:p>
-          <a:p>
-            <a:pPr lvl="0" indent="0" marL="0">
-              <a:buNone/>
-            </a:pPr>
-            <a:r>
-              <a:rPr/>
-              <a:t>Give them the habit explicitly - plot residuals against each feature, every time. A pattern means the model has missed something.</a:t>
+              <a:t>This is the diagnostic to teach. The U in the residuals says: there is structure here the model did not take.</a:t>
+            </a:r>
+          </a:p>
+          <a:p>
+            <a:pPr lvl="0" indent="0" marL="0">
+              <a:buNone/>
+            </a:pPr>
+          </a:p>
+          <a:p>
+            <a:pPr lvl="0" indent="0" marL="0">
+              <a:buNone/>
+            </a:pPr>
+            <a:r>
+              <a:rPr/>
+              <a:t>Contrast with notebook 1, where the residuals were a formless cloud with a spread matching the known noise. That is what “the model got everything” looks like.</a:t>
+            </a:r>
+          </a:p>
+          <a:p>
+            <a:pPr lvl="0" indent="0" marL="0">
+              <a:buNone/>
+            </a:pPr>
+          </a:p>
+          <a:p>
+            <a:pPr lvl="0" indent="0" marL="0">
+              <a:buNone/>
+            </a:pPr>
+            <a:r>
+              <a:rPr/>
+              <a:t>Give them the habit: after fitting anything, plot the residuals against each feature. A pattern means the model has missed something.</a:t>
             </a:r>
           </a:p>
         </p:txBody>
@@ -3694,35 +3733,49 @@
             </a:pPr>
             <a:r>
               <a:rPr/>
-              <a:t>Three fits to the same 21 points. The degree-1 line is too rigid to follow the U; degree 2 matches the true curve, which is quadratic; degree 12 swings wildly between the points.</a:t>
-            </a:r>
-          </a:p>
-          <a:p>
-            <a:pPr lvl="0" indent="0" marL="0">
-              <a:buNone/>
-            </a:pPr>
-          </a:p>
-          <a:p>
-            <a:pPr lvl="0" indent="0" marL="0">
-              <a:buNone/>
-            </a:pPr>
-            <a:r>
-              <a:rPr/>
-              <a:t>Ask them which they would pick if the dashed true curve were not drawn - because that is the real situation. The only thing you ever see is the points.</a:t>
-            </a:r>
-          </a:p>
-          <a:p>
-            <a:pPr lvl="0" indent="0" marL="0">
-              <a:buNone/>
-            </a:pPr>
-          </a:p>
-          <a:p>
-            <a:pPr lvl="0" indent="0" marL="0">
-              <a:buNone/>
-            </a:pPr>
-            <a:r>
-              <a:rPr/>
-              <a:t>Then note the trap in the right-hand panel: it passes closest to the training points of the three. If you selected by training error you would pick it every time.</a:t>
+              <a:t>The contrast to the previous slide, and from notebook 1 - the housing fit, where the model did capture the structure.</a:t>
+            </a:r>
+          </a:p>
+          <a:p>
+            <a:pPr lvl="0" indent="0" marL="0">
+              <a:buNone/>
+            </a:pPr>
+          </a:p>
+          <a:p>
+            <a:pPr lvl="0" indent="0" marL="0">
+              <a:buNone/>
+            </a:pPr>
+            <a:r>
+              <a:rPr/>
+              <a:t>A formless cloud, centred on zero, with no pattern as you sweep left to right. The spread matches the 18,000 euros of noise we know we put in, which is the best possible outcome: the model has taken everything that was there to take, and what remains is the part nobody could have predicted.</a:t>
+            </a:r>
+          </a:p>
+          <a:p>
+            <a:pPr lvl="0" indent="0" marL="0">
+              <a:buNone/>
+            </a:pPr>
+          </a:p>
+          <a:p>
+            <a:pPr lvl="0" indent="0" marL="0">
+              <a:buNone/>
+            </a:pPr>
+            <a:r>
+              <a:rPr/>
+              <a:t>Put the two pictures side by side in words: a U means structure you missed, a cloud means you are done. That is the whole diagnostic, and it costs one line of code after every fit.</a:t>
+            </a:r>
+          </a:p>
+          <a:p>
+            <a:pPr lvl="0" indent="0" marL="0">
+              <a:buNone/>
+            </a:pPr>
+          </a:p>
+          <a:p>
+            <a:pPr lvl="0" indent="0" marL="0">
+              <a:buNone/>
+            </a:pPr>
+            <a:r>
+              <a:rPr/>
+              <a:t>Give them the habit explicitly - plot residuals against each feature, every time. A pattern means the model has missed something.</a:t>
             </a:r>
           </a:p>
         </p:txBody>
@@ -3804,77 +3857,35 @@
             </a:pPr>
             <a:r>
               <a:rPr/>
-              <a:t>Say the name in full before anything else, because every later slide uses the abbreviation: root mean squared error, RMSE, the square root of the mean squared error. Taking the root puts the number back into the units of the target - kilowatt-hours here - so it can be compared with the thing being predicted. An MSE of 285 means nothing to anyone; an RMSE of 16.9 kWh does.</a:t>
-            </a:r>
-          </a:p>
-          <a:p>
-            <a:pPr lvl="0" indent="0" marL="0">
-              <a:buNone/>
-            </a:pPr>
-          </a:p>
-          <a:p>
-            <a:pPr lvl="0" indent="0" marL="0">
-              <a:buNone/>
-            </a:pPr>
-            <a:r>
-              <a:rPr/>
-              <a:t>This is the table the whole lesson turns on. Read the columns against each other, slowly.</a:t>
-            </a:r>
-          </a:p>
-          <a:p>
-            <a:pPr lvl="0" indent="0" marL="0">
-              <a:buNone/>
-            </a:pPr>
-          </a:p>
-          <a:p>
-            <a:pPr lvl="0" indent="0" marL="0">
-              <a:buNone/>
-            </a:pPr>
-            <a:r>
-              <a:rPr/>
-              <a:t>Training error falls at every single step, from 113 down to 14, never once suggesting anything is wrong. Test error bottoms out at degree 3 and then climbs: 590 at degree 9, and 24,656 at degree 12.</a:t>
-            </a:r>
-          </a:p>
-          <a:p>
-            <a:pPr lvl="0" indent="0" marL="0">
-              <a:buNone/>
-            </a:pPr>
-          </a:p>
-          <a:p>
-            <a:pPr lvl="0" indent="0" marL="0">
-              <a:buNone/>
-            </a:pPr>
-            <a:r>
-              <a:rPr/>
-              <a:t>If someone asks why degree 3 wins when the truth is quadratic: the notebook also fits degree 2, which scores 17.4 against degree 3’s 16.9. With nine test days that difference is noise; the two are equally good.</a:t>
-            </a:r>
-          </a:p>
-          <a:p>
-            <a:pPr lvl="0" indent="0" marL="0">
-              <a:buNone/>
-            </a:pPr>
-          </a:p>
-          <a:p>
-            <a:pPr lvl="0" indent="0" marL="0">
-              <a:buNone/>
-            </a:pPr>
-            <a:r>
-              <a:rPr/>
-              <a:t>So the model that fits the training data best is more than a thousand times worse on data it has not seen - and the training error congratulated us the whole way.</a:t>
-            </a:r>
-          </a:p>
-          <a:p>
-            <a:pPr lvl="0" indent="0" marL="0">
-              <a:buNone/>
-            </a:pPr>
-          </a:p>
-          <a:p>
-            <a:pPr lvl="0" indent="0" marL="0">
-              <a:buNone/>
-            </a:pPr>
-            <a:r>
-              <a:rPr/>
-              <a:t>This is lesson 1’s empirical-versus-expected risk with numbers in it: the error on the data we fitted against the error on data we have not seen. And note how little it took: 21 training points, and at degree 12 the model has 12 coefficients plus an intercept to place among them.</a:t>
+              <a:t>Three fits to the same 21 points. The degree-1 line is too rigid to follow the U; degree 2 matches the true curve, which is quadratic; degree 12 swings wildly between the points.</a:t>
+            </a:r>
+          </a:p>
+          <a:p>
+            <a:pPr lvl="0" indent="0" marL="0">
+              <a:buNone/>
+            </a:pPr>
+          </a:p>
+          <a:p>
+            <a:pPr lvl="0" indent="0" marL="0">
+              <a:buNone/>
+            </a:pPr>
+            <a:r>
+              <a:rPr/>
+              <a:t>Ask them which they would pick if the dashed true curve were not drawn - because that is the real situation. The only thing you ever see is the points.</a:t>
+            </a:r>
+          </a:p>
+          <a:p>
+            <a:pPr lvl="0" indent="0" marL="0">
+              <a:buNone/>
+            </a:pPr>
+          </a:p>
+          <a:p>
+            <a:pPr lvl="0" indent="0" marL="0">
+              <a:buNone/>
+            </a:pPr>
+            <a:r>
+              <a:rPr/>
+              <a:t>Then note the trap in the right-hand panel: it passes closest to the training points of the three. If you selected by training error you would pick it every time.</a:t>
             </a:r>
           </a:p>
         </p:txBody>
@@ -3956,57 +3967,77 @@
             </a:pPr>
             <a:r>
               <a:rPr/>
-              <a:t>The previous table as a picture, and the shape is the one to carry out of the room.</a:t>
-            </a:r>
-          </a:p>
-          <a:p>
-            <a:pPr lvl="0" indent="0" marL="0">
-              <a:buNone/>
-            </a:pPr>
-          </a:p>
-          <a:p>
-            <a:pPr lvl="0" indent="0" marL="0">
-              <a:buNone/>
-            </a:pPr>
-            <a:r>
-              <a:rPr/>
-              <a:t>Training error, the lower line, falls monotonically and never once turns up. If that were the only curve you could see - and on your own data it is - you would keep adding degrees forever and congratulate yourself the whole way.</a:t>
-            </a:r>
-          </a:p>
-          <a:p>
-            <a:pPr lvl="0" indent="0" marL="0">
-              <a:buNone/>
-            </a:pPr>
-          </a:p>
-          <a:p>
-            <a:pPr lvl="0" indent="0" marL="0">
-              <a:buNone/>
-            </a:pPr>
-            <a:r>
-              <a:rPr/>
-              <a:t>Test error is the other line, and it turns. The gap between the two curves is the thing with a name: that gap </a:t>
-            </a:r>
-            <a:r>
-              <a:rPr i="1"/>
-              <a:t>is</a:t>
-            </a:r>
-            <a:r>
-              <a:rPr/>
-              <a:t> overfitting, and it widens without limit.</a:t>
-            </a:r>
-          </a:p>
-          <a:p>
-            <a:pPr lvl="0" indent="0" marL="0">
-              <a:buNone/>
-            </a:pPr>
-          </a:p>
-          <a:p>
-            <a:pPr lvl="0" indent="0" marL="0">
-              <a:buNone/>
-            </a:pPr>
-            <a:r>
-              <a:rPr/>
-              <a:t>This is lesson 1’s empirical risk versus expected risk, now with numbers and a picture. Lesson 5 is about measuring the upper curve, the test error, honestly when you do not have a test set to spend.</a:t>
+              <a:t>Say the name in full before anything else, because every later slide uses the abbreviation: root mean squared error, RMSE, the square root of the mean squared error. Taking the root puts the number back into the units of the target - kilowatt-hours here - so it can be compared with the thing being predicted. An MSE of 285 means nothing to anyone; an RMSE of 16.9 kWh does.</a:t>
+            </a:r>
+          </a:p>
+          <a:p>
+            <a:pPr lvl="0" indent="0" marL="0">
+              <a:buNone/>
+            </a:pPr>
+          </a:p>
+          <a:p>
+            <a:pPr lvl="0" indent="0" marL="0">
+              <a:buNone/>
+            </a:pPr>
+            <a:r>
+              <a:rPr/>
+              <a:t>This is the table the whole lesson turns on. Read the columns against each other, slowly.</a:t>
+            </a:r>
+          </a:p>
+          <a:p>
+            <a:pPr lvl="0" indent="0" marL="0">
+              <a:buNone/>
+            </a:pPr>
+          </a:p>
+          <a:p>
+            <a:pPr lvl="0" indent="0" marL="0">
+              <a:buNone/>
+            </a:pPr>
+            <a:r>
+              <a:rPr/>
+              <a:t>Training error falls at every single step, from 113 down to 14, never once suggesting anything is wrong. Test error bottoms out at degree 3 and then climbs: 590 at degree 9, and 24,656 at degree 12.</a:t>
+            </a:r>
+          </a:p>
+          <a:p>
+            <a:pPr lvl="0" indent="0" marL="0">
+              <a:buNone/>
+            </a:pPr>
+          </a:p>
+          <a:p>
+            <a:pPr lvl="0" indent="0" marL="0">
+              <a:buNone/>
+            </a:pPr>
+            <a:r>
+              <a:rPr/>
+              <a:t>If someone asks why degree 3 wins when the truth is quadratic: the notebook also fits degree 2, which scores 17.4 against degree 3’s 16.9. With nine test days that difference is noise; the two are equally good.</a:t>
+            </a:r>
+          </a:p>
+          <a:p>
+            <a:pPr lvl="0" indent="0" marL="0">
+              <a:buNone/>
+            </a:pPr>
+          </a:p>
+          <a:p>
+            <a:pPr lvl="0" indent="0" marL="0">
+              <a:buNone/>
+            </a:pPr>
+            <a:r>
+              <a:rPr/>
+              <a:t>So the model that fits the training data best is more than a thousand times worse on data it has not seen - and the training error congratulated us the whole way.</a:t>
+            </a:r>
+          </a:p>
+          <a:p>
+            <a:pPr lvl="0" indent="0" marL="0">
+              <a:buNone/>
+            </a:pPr>
+          </a:p>
+          <a:p>
+            <a:pPr lvl="0" indent="0" marL="0">
+              <a:buNone/>
+            </a:pPr>
+            <a:r>
+              <a:rPr/>
+              <a:t>This is lesson 1’s empirical-versus-expected risk with numbers in it: the error on the data we fitted against the error on data we have not seen. And note how little it took: 21 training points, and at degree 12 the model has 12 coefficients plus an intercept to place among them.</a:t>
             </a:r>
           </a:p>
         </p:txBody>
@@ -4088,49 +4119,57 @@
             </a:pPr>
             <a:r>
               <a:rPr/>
-              <a:t>Fit the curve, push the degree up, and watch the test error turn. 20 minutes. This is the shortest of the three notebooks and the most visual.</a:t>
-            </a:r>
-          </a:p>
-          <a:p>
-            <a:pPr lvl="0" indent="0" marL="0">
-              <a:buNone/>
-            </a:pPr>
-          </a:p>
-          <a:p>
-            <a:pPr lvl="0" indent="0" marL="0">
-              <a:buNone/>
-            </a:pPr>
-            <a:r>
-              <a:rPr/>
-              <a:t>Have them run the degree sweep first and stop at the table, then predict which degree wins before scrolling. Most rooms guess too high - the instinct that more flexibility is better is exactly what the lesson is dismantling.</a:t>
-            </a:r>
-          </a:p>
-          <a:p>
-            <a:pPr lvl="0" indent="0" marL="0">
-              <a:buNone/>
-            </a:pPr>
-          </a:p>
-          <a:p>
-            <a:pPr lvl="0" indent="0" marL="0">
-              <a:buNone/>
-            </a:pPr>
-            <a:r>
-              <a:rPr/>
-              <a:t>The moment to make sure everyone reaches is the coefficient printout at the end, because the next slide is about that number and it lands far better if they have just seen it appear on their own screen.</a:t>
-            </a:r>
-          </a:p>
-          <a:p>
-            <a:pPr lvl="0" indent="0" marL="0">
-              <a:buNone/>
-            </a:pPr>
-          </a:p>
-          <a:p>
-            <a:pPr lvl="0" indent="0" marL="0">
-              <a:buNone/>
-            </a:pPr>
-            <a:r>
-              <a:rPr/>
-              <a:t>The “try this” reduces the training set from 21 points to 15 and asks which degree wins then. The answer moves down, which is the first hint that the right amount of flexibility depends on how much data you have - a theme for lesson 5.</a:t>
+              <a:t>The previous table as a picture, and the shape is the one to carry out of the room.</a:t>
+            </a:r>
+          </a:p>
+          <a:p>
+            <a:pPr lvl="0" indent="0" marL="0">
+              <a:buNone/>
+            </a:pPr>
+          </a:p>
+          <a:p>
+            <a:pPr lvl="0" indent="0" marL="0">
+              <a:buNone/>
+            </a:pPr>
+            <a:r>
+              <a:rPr/>
+              <a:t>Training error, the lower line, falls monotonically and never once turns up. If that were the only curve you could see - and on your own data it is - you would keep adding degrees forever and congratulate yourself the whole way.</a:t>
+            </a:r>
+          </a:p>
+          <a:p>
+            <a:pPr lvl="0" indent="0" marL="0">
+              <a:buNone/>
+            </a:pPr>
+          </a:p>
+          <a:p>
+            <a:pPr lvl="0" indent="0" marL="0">
+              <a:buNone/>
+            </a:pPr>
+            <a:r>
+              <a:rPr/>
+              <a:t>Test error is the other line, and it turns. The gap between the two curves is the thing with a name: that gap </a:t>
+            </a:r>
+            <a:r>
+              <a:rPr i="1"/>
+              <a:t>is</a:t>
+            </a:r>
+            <a:r>
+              <a:rPr/>
+              <a:t> overfitting, and it widens without limit.</a:t>
+            </a:r>
+          </a:p>
+          <a:p>
+            <a:pPr lvl="0" indent="0" marL="0">
+              <a:buNone/>
+            </a:pPr>
+          </a:p>
+          <a:p>
+            <a:pPr lvl="0" indent="0" marL="0">
+              <a:buNone/>
+            </a:pPr>
+            <a:r>
+              <a:rPr/>
+              <a:t>This is lesson 1’s empirical risk versus expected risk, now with numbers and a picture. Lesson 5 is about measuring the upper curve, the test error, honestly when you do not have a test set to spend.</a:t>
             </a:r>
           </a:p>
         </p:txBody>
@@ -4212,35 +4251,49 @@
             </a:pPr>
             <a:r>
               <a:rPr/>
-              <a:t>Here is the mechanism, and it is the setup for everything after the break.</a:t>
-            </a:r>
-          </a:p>
-          <a:p>
-            <a:pPr lvl="0" indent="0" marL="0">
-              <a:buNone/>
-            </a:pPr>
-          </a:p>
-          <a:p>
-            <a:pPr lvl="0" indent="0" marL="0">
-              <a:buNone/>
-            </a:pPr>
-            <a:r>
-              <a:rPr/>
-              <a:t>The huge coefficients work in OPPOSITION. With 21 points and 12 coefficients there are many ways to pass close to every point, and the one least squares finds is built from enormous terms that nearly cancel: one pushes the curve up, the next pushes it down by almost the same amount. At each training point the cancellation is tuned so the curve lands near the point, because that is all least squares checks. Between the points nothing tunes it, and the curve swings by thousands.</a:t>
-            </a:r>
-          </a:p>
-          <a:p>
-            <a:pPr lvl="0" indent="0" marL="0">
-              <a:buNone/>
-            </a:pPr>
-          </a:p>
-          <a:p>
-            <a:pPr lvl="0" indent="0" marL="0">
-              <a:buNone/>
-            </a:pPr>
-            <a:r>
-              <a:rPr/>
-              <a:t>Then the question that leads the rest of the lesson: if enormous opposing coefficients are the symptom, what would happen if we charged for coefficient size?</a:t>
+              <a:t>Fit the curve, push the degree up, and watch the test error turn. 20 minutes. This is the shortest of the three notebooks and the most visual.</a:t>
+            </a:r>
+          </a:p>
+          <a:p>
+            <a:pPr lvl="0" indent="0" marL="0">
+              <a:buNone/>
+            </a:pPr>
+          </a:p>
+          <a:p>
+            <a:pPr lvl="0" indent="0" marL="0">
+              <a:buNone/>
+            </a:pPr>
+            <a:r>
+              <a:rPr/>
+              <a:t>Have them run the degree sweep first and stop at the table, then predict which degree wins before scrolling. Most rooms guess too high - the instinct that more flexibility is better is exactly what the lesson is dismantling.</a:t>
+            </a:r>
+          </a:p>
+          <a:p>
+            <a:pPr lvl="0" indent="0" marL="0">
+              <a:buNone/>
+            </a:pPr>
+          </a:p>
+          <a:p>
+            <a:pPr lvl="0" indent="0" marL="0">
+              <a:buNone/>
+            </a:pPr>
+            <a:r>
+              <a:rPr/>
+              <a:t>The moment to make sure everyone reaches is the coefficient printout at the end, because the next slide is about that number and it lands far better if they have just seen it appear on their own screen.</a:t>
+            </a:r>
+          </a:p>
+          <a:p>
+            <a:pPr lvl="0" indent="0" marL="0">
+              <a:buNone/>
+            </a:pPr>
+          </a:p>
+          <a:p>
+            <a:pPr lvl="0" indent="0" marL="0">
+              <a:buNone/>
+            </a:pPr>
+            <a:r>
+              <a:rPr/>
+              <a:t>The “try this” reduces the training set from 21 points to 15 and asks which degree wins then. The answer moves down, which is the first hint that the right amount of flexibility depends on how much data you have - a theme for lesson 5.</a:t>
             </a:r>
           </a:p>
         </p:txBody>
@@ -4322,55 +4375,35 @@
             </a:pPr>
             <a:r>
               <a:rPr/>
-              <a:t>Two penalties, one difference: squares or absolute values. MSE here is the mean squared error from the first half of the lesson. Lambda sets the exchange rate between fitting the data and keeping coefficients small; at lambda = 0 both are ordinary least squares.</a:t>
-            </a:r>
-          </a:p>
-          <a:p>
-            <a:pPr lvl="0" indent="0" marL="0">
-              <a:buNone/>
-            </a:pPr>
-          </a:p>
-          <a:p>
-            <a:pPr lvl="0" indent="0" marL="0">
-              <a:buNone/>
-            </a:pPr>
-            <a:r>
-              <a:rPr/>
-              <a:t>Say the naming trap out loud, because they will hit it in five minutes: we write the penalty strength as lambda, and reserve alpha for the learning rate. scikit-learn calls the penalty </a:t>
-            </a:r>
-            <a:r>
-              <a:rPr>
-                <a:latin typeface="Courier"/>
-              </a:rPr>
-              <a:t>alpha</a:t>
-            </a:r>
-            <a:r>
-              <a:rPr/>
-              <a:t>. So </a:t>
-            </a:r>
-            <a:r>
-              <a:rPr>
-                <a:latin typeface="Courier"/>
-              </a:rPr>
-              <a:t>Ridge(alpha=0.01)</a:t>
-            </a:r>
-            <a:r>
-              <a:rPr/>
-              <a:t> in code is lambda = 0.01 on this slide.</a:t>
-            </a:r>
-          </a:p>
-          <a:p>
-            <a:pPr lvl="0" indent="0" marL="0">
-              <a:buNone/>
-            </a:pPr>
-          </a:p>
-          <a:p>
-            <a:pPr lvl="0" indent="0" marL="0">
-              <a:buNone/>
-            </a:pPr>
-            <a:r>
-              <a:rPr/>
-              <a:t>Ridge charges the sum of the squared coefficients, Lasso the sum of their absolute values; the next slide gives the two rules both of them need.</a:t>
+              <a:t>Here is the mechanism, and it is the setup for everything after the break.</a:t>
+            </a:r>
+          </a:p>
+          <a:p>
+            <a:pPr lvl="0" indent="0" marL="0">
+              <a:buNone/>
+            </a:pPr>
+          </a:p>
+          <a:p>
+            <a:pPr lvl="0" indent="0" marL="0">
+              <a:buNone/>
+            </a:pPr>
+            <a:r>
+              <a:rPr/>
+              <a:t>The huge coefficients work in OPPOSITION. With 21 points and 12 coefficients there are many ways to pass close to every point, and the one least squares finds is built from enormous terms that nearly cancel: one pushes the curve up, the next pushes it down by almost the same amount. At each training point the cancellation is tuned so the curve lands near the point, because that is all least squares checks. Between the points nothing tunes it, and the curve swings by thousands.</a:t>
+            </a:r>
+          </a:p>
+          <a:p>
+            <a:pPr lvl="0" indent="0" marL="0">
+              <a:buNone/>
+            </a:pPr>
+          </a:p>
+          <a:p>
+            <a:pPr lvl="0" indent="0" marL="0">
+              <a:buNone/>
+            </a:pPr>
+            <a:r>
+              <a:rPr/>
+              <a:t>Then the question that leads the rest of the lesson: if enormous opposing coefficients are the symptom, what would happen if we charged for coefficient size?</a:t>
             </a:r>
           </a:p>
         </p:txBody>
@@ -4452,63 +4485,55 @@
             </a:pPr>
             <a:r>
               <a:rPr/>
-              <a:t>Both of these are things students get wrong, and both produce results that look fine, which is what makes them worth a slide of their own.</a:t>
-            </a:r>
-          </a:p>
-          <a:p>
-            <a:pPr lvl="0" indent="0" marL="0">
-              <a:buNone/>
-            </a:pPr>
-          </a:p>
-          <a:p>
-            <a:pPr lvl="0" indent="0" marL="0">
-              <a:buNone/>
-            </a:pPr>
-            <a:r>
-              <a:rPr/>
-              <a:t>The intercept says where the surface sits, not what any feature is worth. Shrinking it would drag every prediction towards zero, which for house prices in euros is a meaningless place to be dragged. scikit-learn handles this for you in both Ridge and Lasso - but only because someone decided it should, not because the formula does it by itself.</a:t>
-            </a:r>
-          </a:p>
-          <a:p>
-            <a:pPr lvl="0" indent="0" marL="0">
-              <a:buNone/>
-            </a:pPr>
-          </a:p>
-          <a:p>
-            <a:pPr lvl="0" indent="0" marL="0">
-              <a:buNone/>
-            </a:pPr>
-            <a:r>
-              <a:rPr/>
-              <a:t>Scaling is the sharper one. The penalty is a sum over coefficients, so the same feature measured in metres and in kilometres attracts penalties differing by a factor of a thousand. Whichever feature happens to be recorded in small units gets a large coefficient and is therefore punished hardest, entirely by accident of the unit someone chose.</a:t>
-            </a:r>
-          </a:p>
-          <a:p>
-            <a:pPr lvl="0" indent="0" marL="0">
-              <a:buNone/>
-            </a:pPr>
-          </a:p>
-          <a:p>
-            <a:pPr lvl="0" indent="0" marL="0">
-              <a:buNone/>
-            </a:pPr>
-            <a:r>
-              <a:rPr/>
-              <a:t>Say the contrast with lesson 2 explicitly, because it is the point: there, scaling was about optimisation speed and you could skip it and still be right. Here it is correctness. Skip it and the model answers a different question.</a:t>
-            </a:r>
-          </a:p>
-          <a:p>
-            <a:pPr lvl="0" indent="0" marL="0">
-              <a:buNone/>
-            </a:pPr>
-          </a:p>
-          <a:p>
-            <a:pPr lvl="0" indent="0" marL="0">
-              <a:buNone/>
-            </a:pPr>
-            <a:r>
-              <a:rPr/>
-              <a:t>Handout section 6.1.</a:t>
+              <a:t>Two penalties, one difference: squares or absolute values. MSE here is the mean squared error from the first half of the lesson. Lambda sets the exchange rate between fitting the data and keeping coefficients small; at lambda = 0 both are ordinary least squares.</a:t>
+            </a:r>
+          </a:p>
+          <a:p>
+            <a:pPr lvl="0" indent="0" marL="0">
+              <a:buNone/>
+            </a:pPr>
+          </a:p>
+          <a:p>
+            <a:pPr lvl="0" indent="0" marL="0">
+              <a:buNone/>
+            </a:pPr>
+            <a:r>
+              <a:rPr/>
+              <a:t>Say the naming trap out loud, because they will hit it in five minutes: we write the penalty strength as lambda, and reserve alpha for the learning rate. scikit-learn calls the penalty </a:t>
+            </a:r>
+            <a:r>
+              <a:rPr>
+                <a:latin typeface="Courier"/>
+              </a:rPr>
+              <a:t>alpha</a:t>
+            </a:r>
+            <a:r>
+              <a:rPr/>
+              <a:t>. So </a:t>
+            </a:r>
+            <a:r>
+              <a:rPr>
+                <a:latin typeface="Courier"/>
+              </a:rPr>
+              <a:t>Ridge(alpha=0.01)</a:t>
+            </a:r>
+            <a:r>
+              <a:rPr/>
+              <a:t> in code is lambda = 0.01 on this slide.</a:t>
+            </a:r>
+          </a:p>
+          <a:p>
+            <a:pPr lvl="0" indent="0" marL="0">
+              <a:buNone/>
+            </a:pPr>
+          </a:p>
+          <a:p>
+            <a:pPr lvl="0" indent="0" marL="0">
+              <a:buNone/>
+            </a:pPr>
+            <a:r>
+              <a:rPr/>
+              <a:t>Ridge charges the sum of the squared coefficients, Lasso the sum of their absolute values; the next slide gives the two rules both of them need.</a:t>
             </a:r>
           </a:p>
         </p:txBody>
@@ -4700,49 +4725,63 @@
             </a:pPr>
             <a:r>
               <a:rPr/>
-              <a:t>Read the last column first: three billion down to 365, from a penalty of one hundredth. And the test error falls from 24,656 to 23, which is the noise floor: the noise we added to each day has a standard deviation of 22 kWh, and no model can predict below it. A thousandfold improvement, bought with one number.</a:t>
-            </a:r>
-          </a:p>
-          <a:p>
-            <a:pPr lvl="0" indent="0" marL="0">
-              <a:buNone/>
-            </a:pPr>
-          </a:p>
-          <a:p>
-            <a:pPr lvl="0" indent="0" marL="0">
-              <a:buNone/>
-            </a:pPr>
-            <a:r>
-              <a:rPr/>
-              <a:t>Now the training column, which is the honest part: it gets WORSE at every step. 13.6, 18, 45, 96. That is the trade being made deliberately - a worse fit on the data we have, in exchange for a better fit on data we do not.</a:t>
-            </a:r>
-          </a:p>
-          <a:p>
-            <a:pPr lvl="0" indent="0" marL="0">
-              <a:buNone/>
-            </a:pPr>
-          </a:p>
-          <a:p>
-            <a:pPr lvl="0" indent="0" marL="0">
-              <a:buNone/>
-            </a:pPr>
-            <a:r>
-              <a:rPr/>
-              <a:t>And it stops paying. The test error rises from 22.8 at lambda 0.01, to 105 at lambda 1, to 228 at lambda 100 - a tenfold loss against the best penalty, because the model is now too rigid to follow the curve.</a:t>
-            </a:r>
-          </a:p>
-          <a:p>
-            <a:pPr lvl="0" indent="0" marL="0">
-              <a:buNone/>
-            </a:pPr>
-          </a:p>
-          <a:p>
-            <a:pPr lvl="0" indent="0" marL="0">
-              <a:buNone/>
-            </a:pPr>
-            <a:r>
-              <a:rPr/>
-              <a:t>The table runs lambda from 0.01 to 100, four orders of magnitude, and the test error changes tenfold across them. That is why lambda cannot be guessed: it has to be searched for, which lesson 5 does properly.</a:t>
+              <a:t>Both of these are things students get wrong, and both produce results that look fine, which is what makes them worth a slide of their own.</a:t>
+            </a:r>
+          </a:p>
+          <a:p>
+            <a:pPr lvl="0" indent="0" marL="0">
+              <a:buNone/>
+            </a:pPr>
+          </a:p>
+          <a:p>
+            <a:pPr lvl="0" indent="0" marL="0">
+              <a:buNone/>
+            </a:pPr>
+            <a:r>
+              <a:rPr/>
+              <a:t>The intercept says where the surface sits, not what any feature is worth. Shrinking it would drag every prediction towards zero, which for house prices in euros is a meaningless place to be dragged. scikit-learn handles this for you in both Ridge and Lasso - but only because someone decided it should, not because the formula does it by itself.</a:t>
+            </a:r>
+          </a:p>
+          <a:p>
+            <a:pPr lvl="0" indent="0" marL="0">
+              <a:buNone/>
+            </a:pPr>
+          </a:p>
+          <a:p>
+            <a:pPr lvl="0" indent="0" marL="0">
+              <a:buNone/>
+            </a:pPr>
+            <a:r>
+              <a:rPr/>
+              <a:t>Scaling is the sharper one. The penalty is a sum over coefficients, so the same feature measured in metres and in kilometres attracts penalties differing by a factor of a thousand. Whichever feature happens to be recorded in small units gets a large coefficient and is therefore punished hardest, entirely by accident of the unit someone chose.</a:t>
+            </a:r>
+          </a:p>
+          <a:p>
+            <a:pPr lvl="0" indent="0" marL="0">
+              <a:buNone/>
+            </a:pPr>
+          </a:p>
+          <a:p>
+            <a:pPr lvl="0" indent="0" marL="0">
+              <a:buNone/>
+            </a:pPr>
+            <a:r>
+              <a:rPr/>
+              <a:t>Say the contrast with lesson 2 explicitly, because it is the point: there, scaling was about optimisation speed and you could skip it and still be right. Here it is correctness. Skip it and the model answers a different question.</a:t>
+            </a:r>
+          </a:p>
+          <a:p>
+            <a:pPr lvl="0" indent="0" marL="0">
+              <a:buNone/>
+            </a:pPr>
+          </a:p>
+          <a:p>
+            <a:pPr lvl="0" indent="0" marL="0">
+              <a:buNone/>
+            </a:pPr>
+            <a:r>
+              <a:rPr/>
+              <a:t>Handout section 6.1.</a:t>
             </a:r>
           </a:p>
         </p:txBody>
@@ -4824,63 +4863,49 @@
             </a:pPr>
             <a:r>
               <a:rPr/>
-              <a:t>The last column of that table, drawn. Give the room a moment on the left panel before saying anything.</a:t>
-            </a:r>
-          </a:p>
-          <a:p>
-            <a:pPr lvl="0" indent="0" marL="0">
-              <a:buNone/>
-            </a:pPr>
-          </a:p>
-          <a:p>
-            <a:pPr lvl="0" indent="0" marL="0">
-              <a:buNone/>
-            </a:pPr>
-            <a:r>
-              <a:rPr/>
-              <a:t>Point at the vertical scale. The unpenalised curve goes off the top and off the bottom between the training points, and it only comes back where a point is sitting there to pull it. That is what a coefficient of three billion looks like from the outside.</a:t>
-            </a:r>
-          </a:p>
-          <a:p>
-            <a:pPr lvl="0" indent="0" marL="0">
-              <a:buNone/>
-            </a:pPr>
-          </a:p>
-          <a:p>
-            <a:pPr lvl="0" indent="0" marL="0">
-              <a:buNone/>
-            </a:pPr>
-            <a:r>
-              <a:rPr/>
-              <a:t>Middle panel, lambda one hundredth: on top of the true curve, the dashed line. You cannot separate them by eye.</a:t>
-            </a:r>
-          </a:p>
-          <a:p>
-            <a:pPr lvl="0" indent="0" marL="0">
-              <a:buNone/>
-            </a:pPr>
-          </a:p>
-          <a:p>
-            <a:pPr lvl="0" indent="0" marL="0">
-              <a:buNone/>
-            </a:pPr>
-            <a:r>
-              <a:rPr/>
-              <a:t>Right panel, lambda one hundred: a nearly flat line. It misses the curve completely - but look at how it misses. It is wrong by a few hundred kilowatt hours, on a plot where the left panel is wrong by thousands.</a:t>
-            </a:r>
-          </a:p>
-          <a:p>
-            <a:pPr lvl="0" indent="0" marL="0">
-              <a:buNone/>
-            </a:pPr>
-          </a:p>
-          <a:p>
-            <a:pPr lvl="0" indent="0" marL="0">
-              <a:buNone/>
-            </a:pPr>
-            <a:r>
-              <a:rPr/>
-              <a:t>That is the asymmetry to take away, and the table hides it: too much penalty is a mild failure, too little is a catastrophic one. If you have to err, err towards more penalty. Handout section 6.4.</a:t>
+              <a:t>Read the last column first: three billion down to 365, from a penalty of one hundredth. And the test error falls from 24,656 to 23, which is the noise floor: the noise we added to each day has a standard deviation of 22 kWh, and no model can predict below it. A thousandfold improvement, bought with one number.</a:t>
+            </a:r>
+          </a:p>
+          <a:p>
+            <a:pPr lvl="0" indent="0" marL="0">
+              <a:buNone/>
+            </a:pPr>
+          </a:p>
+          <a:p>
+            <a:pPr lvl="0" indent="0" marL="0">
+              <a:buNone/>
+            </a:pPr>
+            <a:r>
+              <a:rPr/>
+              <a:t>Now the training column, which is the honest part: it gets WORSE at every step. 13.6, 18, 45, 96. That is the trade being made deliberately - a worse fit on the data we have, in exchange for a better fit on data we do not.</a:t>
+            </a:r>
+          </a:p>
+          <a:p>
+            <a:pPr lvl="0" indent="0" marL="0">
+              <a:buNone/>
+            </a:pPr>
+          </a:p>
+          <a:p>
+            <a:pPr lvl="0" indent="0" marL="0">
+              <a:buNone/>
+            </a:pPr>
+            <a:r>
+              <a:rPr/>
+              <a:t>And it stops paying. The test error rises from 22.8 at lambda 0.01, to 105 at lambda 1, to 228 at lambda 100 - a tenfold loss against the best penalty, because the model is now too rigid to follow the curve.</a:t>
+            </a:r>
+          </a:p>
+          <a:p>
+            <a:pPr lvl="0" indent="0" marL="0">
+              <a:buNone/>
+            </a:pPr>
+          </a:p>
+          <a:p>
+            <a:pPr lvl="0" indent="0" marL="0">
+              <a:buNone/>
+            </a:pPr>
+            <a:r>
+              <a:rPr/>
+              <a:t>The table runs lambda from 0.01 to 100, four orders of magnitude, and the test error changes tenfold across them. That is why lambda cannot be guessed: it has to be searched for, which lesson 5 does properly.</a:t>
             </a:r>
           </a:p>
         </p:txBody>
@@ -4962,35 +4987,63 @@
             </a:pPr>
             <a:r>
               <a:rPr/>
-              <a:t>The same table as a picture. Both ends are failures, and they fail for opposite reasons.</a:t>
-            </a:r>
-          </a:p>
-          <a:p>
-            <a:pPr lvl="0" indent="0" marL="0">
-              <a:buNone/>
-            </a:pPr>
-          </a:p>
-          <a:p>
-            <a:pPr lvl="0" indent="0" marL="0">
-              <a:buNone/>
-            </a:pPr>
-            <a:r>
-              <a:rPr/>
-              <a:t>This shape has a name - the bias-variance trade-off - and lesson 5 treats it fully, with the tools to find the bottom of that curve honestly. Today the point is only that the bottom exists and is not where either extreme is.</a:t>
-            </a:r>
-          </a:p>
-          <a:p>
-            <a:pPr lvl="0" indent="0" marL="0">
-              <a:buNone/>
-            </a:pPr>
-          </a:p>
-          <a:p>
-            <a:pPr lvl="0" indent="0" marL="0">
-              <a:buNone/>
-            </a:pPr>
-            <a:r>
-              <a:rPr/>
-              <a:t>If someone asks how to choose lambda: not by looking at this test curve, because that would be selecting on the test set. Cross-validation, lesson 5.</a:t>
+              <a:t>The last column of that table, drawn. Give the room a moment on the left panel before saying anything.</a:t>
+            </a:r>
+          </a:p>
+          <a:p>
+            <a:pPr lvl="0" indent="0" marL="0">
+              <a:buNone/>
+            </a:pPr>
+          </a:p>
+          <a:p>
+            <a:pPr lvl="0" indent="0" marL="0">
+              <a:buNone/>
+            </a:pPr>
+            <a:r>
+              <a:rPr/>
+              <a:t>Point at the vertical scale. The unpenalised curve goes off the top and off the bottom between the training points, and it only comes back where a point is sitting there to pull it. That is what a coefficient of three billion looks like from the outside.</a:t>
+            </a:r>
+          </a:p>
+          <a:p>
+            <a:pPr lvl="0" indent="0" marL="0">
+              <a:buNone/>
+            </a:pPr>
+          </a:p>
+          <a:p>
+            <a:pPr lvl="0" indent="0" marL="0">
+              <a:buNone/>
+            </a:pPr>
+            <a:r>
+              <a:rPr/>
+              <a:t>Middle panel, lambda one hundredth: on top of the true curve, the dashed line. You cannot separate them by eye.</a:t>
+            </a:r>
+          </a:p>
+          <a:p>
+            <a:pPr lvl="0" indent="0" marL="0">
+              <a:buNone/>
+            </a:pPr>
+          </a:p>
+          <a:p>
+            <a:pPr lvl="0" indent="0" marL="0">
+              <a:buNone/>
+            </a:pPr>
+            <a:r>
+              <a:rPr/>
+              <a:t>Right panel, lambda one hundred: a nearly flat line. It misses the curve completely - but look at how it misses. It is wrong by a few hundred kilowatt hours, on a plot where the left panel is wrong by thousands.</a:t>
+            </a:r>
+          </a:p>
+          <a:p>
+            <a:pPr lvl="0" indent="0" marL="0">
+              <a:buNone/>
+            </a:pPr>
+          </a:p>
+          <a:p>
+            <a:pPr lvl="0" indent="0" marL="0">
+              <a:buNone/>
+            </a:pPr>
+            <a:r>
+              <a:rPr/>
+              <a:t>That is the asymmetry to take away, and the table hides it: too much penalty is a mild failure, too little is a catastrophic one. If you have to err, err towards more penalty. Handout section 6.4.</a:t>
             </a:r>
           </a:p>
         </p:txBody>
@@ -5072,49 +5125,35 @@
             </a:pPr>
             <a:r>
               <a:rPr/>
-              <a:t>Put this next to the normal equation from before the break and ask what changed. The answer is: one term. Add lambda down the diagonal of the matrix you invert, and that is the entire modification.</a:t>
-            </a:r>
-          </a:p>
-          <a:p>
-            <a:pPr lvl="0" indent="0" marL="0">
-              <a:buNone/>
-            </a:pPr>
-          </a:p>
-          <a:p>
-            <a:pPr lvl="0" indent="0" marL="0">
-              <a:buNone/>
-            </a:pPr>
-            <a:r>
-              <a:rPr/>
-              <a:t>Everything else is identical - same derivation, same projection idea, same four lines of NumPy. Ridge is not a different method; it is least squares with a price on large coefficients.</a:t>
-            </a:r>
-          </a:p>
-          <a:p>
-            <a:pPr lvl="0" indent="0" marL="0">
-              <a:buNone/>
-            </a:pPr>
-          </a:p>
-          <a:p>
-            <a:pPr lvl="0" indent="0" marL="0">
-              <a:buNone/>
-            </a:pPr>
-            <a:r>
-              <a:rPr/>
-              <a:t>Two small print points, for anyone who checks it against the cost on the earlier slide. Written with theta, the formula penalises the intercept too; in practice the intercept’s entry of I is set to zero, or the data are centred first so the intercept drops out, which is what scikit-learn does. And with the cost written as MSE plus lambda times the sum of squares, the lambda in this formula is that lambda times 2m. Handout section 6.2 shows where the factor comes from.</a:t>
-            </a:r>
-          </a:p>
-          <a:p>
-            <a:pPr lvl="0" indent="0" marL="0">
-              <a:buNone/>
-            </a:pPr>
-          </a:p>
-          <a:p>
-            <a:pPr lvl="0" indent="0" marL="0">
-              <a:buNone/>
-            </a:pPr>
-            <a:r>
-              <a:rPr/>
-              <a:t>Note that Lasso has no such formula. The absolute value has a corner, so it cannot be differentiated at zero, and the solution has to be found iteratively. That inconvenience is inseparable from the property that makes Lasso useful: the corner is exactly what produces the zeros, as two slides from now show.</a:t>
+              <a:t>The same table as a picture. Both ends are failures, and they fail for opposite reasons.</a:t>
+            </a:r>
+          </a:p>
+          <a:p>
+            <a:pPr lvl="0" indent="0" marL="0">
+              <a:buNone/>
+            </a:pPr>
+          </a:p>
+          <a:p>
+            <a:pPr lvl="0" indent="0" marL="0">
+              <a:buNone/>
+            </a:pPr>
+            <a:r>
+              <a:rPr/>
+              <a:t>This shape has a name - the bias-variance trade-off - and lesson 5 treats it fully, with the tools to find the bottom of that curve honestly. Today the point is only that the bottom exists and is not where either extreme is.</a:t>
+            </a:r>
+          </a:p>
+          <a:p>
+            <a:pPr lvl="0" indent="0" marL="0">
+              <a:buNone/>
+            </a:pPr>
+          </a:p>
+          <a:p>
+            <a:pPr lvl="0" indent="0" marL="0">
+              <a:buNone/>
+            </a:pPr>
+            <a:r>
+              <a:rPr/>
+              <a:t>If someone asks how to choose lambda: not by looking at this test curve, because that would be selecting on the test set. Cross-validation, lesson 5.</a:t>
             </a:r>
           </a:p>
         </p:txBody>
@@ -5196,53 +5235,49 @@
             </a:pPr>
             <a:r>
               <a:rPr/>
-              <a:t>Come back to the ravine picture from before the break. The reason two identical columns break least squares is that there is a direction in which moving the coefficients changes the predictions not at all - the valley is perfectly flat along it, so there is no unique lowest point. Infinitely many answers fit equally well.</a:t>
-            </a:r>
-          </a:p>
-          <a:p>
-            <a:pPr lvl="0" indent="0" marL="0">
-              <a:buNone/>
-            </a:pPr>
-          </a:p>
-          <a:p>
-            <a:pPr lvl="0" indent="0" marL="0">
-              <a:buNone/>
-            </a:pPr>
-            <a:r>
-              <a:rPr/>
-              <a:t>Ridge tilts the floor of that valley. Once coefficient size costs something, moving along that flat direction is no longer free, the flatness acquires a slope, and a single lowest point appears.</a:t>
-            </a:r>
-          </a:p>
-          <a:p>
-            <a:pPr lvl="0" indent="0" marL="0">
-              <a:buNone/>
-            </a:pPr>
-          </a:p>
-          <a:p>
-            <a:pPr lvl="0" indent="0" marL="0">
-              <a:buNone/>
-            </a:pPr>
-            <a:r>
-              <a:rPr/>
-              <a:t>The algebraic version is the third bullet and it is worth one sentence: adding lambda to the diagonal shifts every eigenvalue up by lambda, and a matrix is singular exactly when one of its eigenvalues is zero. So for any lambda above zero, it cannot be singular. </a:t>
-            </a:r>
-            <a:r>
-              <a:rPr b="1"/>
-              <a:t>Ridge always has a unique answer, even where least squares has none at all.</a:t>
-            </a:r>
-          </a:p>
-          <a:p>
-            <a:pPr lvl="0" indent="0" marL="0">
-              <a:buNone/>
-            </a:pPr>
-          </a:p>
-          <a:p>
-            <a:pPr lvl="0" indent="0" marL="0">
-              <a:buNone/>
-            </a:pPr>
-            <a:r>
-              <a:rPr/>
-              <a:t>Worth saying plainly: Hoerl and Kennard invented ridge in 1970 for this problem, not for overfitting. The overfitting cure was the side effect.</a:t>
+              <a:t>Put this next to the normal equation from before the break and ask what changed. The answer is: one term. Add lambda down the diagonal of the matrix you invert, and that is the entire modification.</a:t>
+            </a:r>
+          </a:p>
+          <a:p>
+            <a:pPr lvl="0" indent="0" marL="0">
+              <a:buNone/>
+            </a:pPr>
+          </a:p>
+          <a:p>
+            <a:pPr lvl="0" indent="0" marL="0">
+              <a:buNone/>
+            </a:pPr>
+            <a:r>
+              <a:rPr/>
+              <a:t>Everything else is identical - same derivation, same projection idea, same four lines of NumPy. Ridge is not a different method; it is least squares with a price on large coefficients.</a:t>
+            </a:r>
+          </a:p>
+          <a:p>
+            <a:pPr lvl="0" indent="0" marL="0">
+              <a:buNone/>
+            </a:pPr>
+          </a:p>
+          <a:p>
+            <a:pPr lvl="0" indent="0" marL="0">
+              <a:buNone/>
+            </a:pPr>
+            <a:r>
+              <a:rPr/>
+              <a:t>Two small print points, for anyone who checks it against the cost on the earlier slide. Written with theta, the formula penalises the intercept too; in practice the intercept’s entry of I is set to zero, or the data are centred first so the intercept drops out, which is what scikit-learn does. And with the cost written as MSE plus lambda times the sum of squares, the lambda in this formula is that lambda times 2m. Handout section 6.2 shows where the factor comes from.</a:t>
+            </a:r>
+          </a:p>
+          <a:p>
+            <a:pPr lvl="0" indent="0" marL="0">
+              <a:buNone/>
+            </a:pPr>
+          </a:p>
+          <a:p>
+            <a:pPr lvl="0" indent="0" marL="0">
+              <a:buNone/>
+            </a:pPr>
+            <a:r>
+              <a:rPr/>
+              <a:t>Note that Lasso has no such formula. The absolute value has a corner, so it cannot be differentiated at zero, and the solution has to be found iteratively. That inconvenience is inseparable from the property that makes Lasso useful: the corner is exactly what produces the zeros, as two slides from now show.</a:t>
             </a:r>
           </a:p>
         </p:txBody>
@@ -5324,63 +5359,53 @@
             </a:pPr>
             <a:r>
               <a:rPr/>
-              <a:t>Intuition before algebra again, and this one is worth the time.</a:t>
-            </a:r>
-          </a:p>
-          <a:p>
-            <a:pPr lvl="0" indent="0" marL="0">
-              <a:buNone/>
-            </a:pPr>
-          </a:p>
-          <a:p>
-            <a:pPr lvl="0" indent="0" marL="0">
-              <a:buNone/>
-            </a:pPr>
-            <a:r>
-              <a:rPr/>
-              <a:t>Think of the penalty as a budget: you may spend a fixed total on coefficients and want the best fit that money buys. Draw what you can afford. For two coefficients, charging squares makes the affordable region a disc; charging absolute values makes it a diamond, a square turned to stand on its corners.</a:t>
-            </a:r>
-          </a:p>
-          <a:p>
-            <a:pPr lvl="0" indent="0" marL="0">
-              <a:buNone/>
-            </a:pPr>
-          </a:p>
-          <a:p>
-            <a:pPr lvl="0" indent="0" marL="0">
-              <a:buNone/>
-            </a:pPr>
-            <a:r>
-              <a:rPr/>
-              <a:t>The best affordable fit is where the error contours (the rings of equal cost around the unpenalised answer) first touch the region.</a:t>
-            </a:r>
-          </a:p>
-          <a:p>
-            <a:pPr lvl="0" indent="0" marL="0">
-              <a:buNone/>
-            </a:pPr>
-          </a:p>
-          <a:p>
-            <a:pPr lvl="0" indent="0" marL="0">
-              <a:buNone/>
-            </a:pPr>
-            <a:r>
-              <a:rPr/>
-              <a:t>A disc is smooth, so contact happens at a generic point with both coefficients non-zero. A diamond has corners, its corners lie ON THE AXES, and a corner is a point where one coefficient is exactly zero. Corners stick out, so they get touched first.</a:t>
-            </a:r>
-          </a:p>
-          <a:p>
-            <a:pPr lvl="0" indent="0" marL="0">
-              <a:buNone/>
-            </a:pPr>
-          </a:p>
-          <a:p>
-            <a:pPr lvl="0" indent="0" marL="0">
-              <a:buNone/>
-            </a:pPr>
-            <a:r>
-              <a:rPr/>
-              <a:t>That is the entire reason Lasso produces zeros and Ridge does not. Not a tolerance, not a numerical accident - the shape of the budget.</a:t>
+              <a:t>Come back to the ravine picture from before the break. The reason two identical columns break least squares is that there is a direction in which moving the coefficients changes the predictions not at all - the valley is perfectly flat along it, so there is no unique lowest point. Infinitely many answers fit equally well.</a:t>
+            </a:r>
+          </a:p>
+          <a:p>
+            <a:pPr lvl="0" indent="0" marL="0">
+              <a:buNone/>
+            </a:pPr>
+          </a:p>
+          <a:p>
+            <a:pPr lvl="0" indent="0" marL="0">
+              <a:buNone/>
+            </a:pPr>
+            <a:r>
+              <a:rPr/>
+              <a:t>Ridge tilts the floor of that valley. Once coefficient size costs something, moving along that flat direction is no longer free, the flatness acquires a slope, and a single lowest point appears.</a:t>
+            </a:r>
+          </a:p>
+          <a:p>
+            <a:pPr lvl="0" indent="0" marL="0">
+              <a:buNone/>
+            </a:pPr>
+          </a:p>
+          <a:p>
+            <a:pPr lvl="0" indent="0" marL="0">
+              <a:buNone/>
+            </a:pPr>
+            <a:r>
+              <a:rPr/>
+              <a:t>The algebraic version is the third bullet and it is worth one sentence: adding lambda to the diagonal shifts every eigenvalue up by lambda, and a matrix is singular exactly when one of its eigenvalues is zero. So for any lambda above zero, it cannot be singular. </a:t>
+            </a:r>
+            <a:r>
+              <a:rPr b="1"/>
+              <a:t>Ridge always has a unique answer, even where least squares has none at all.</a:t>
+            </a:r>
+          </a:p>
+          <a:p>
+            <a:pPr lvl="0" indent="0" marL="0">
+              <a:buNone/>
+            </a:pPr>
+          </a:p>
+          <a:p>
+            <a:pPr lvl="0" indent="0" marL="0">
+              <a:buNone/>
+            </a:pPr>
+            <a:r>
+              <a:rPr/>
+              <a:t>Worth saying plainly: Hoerl and Kennard invented ridge in 1970 for this problem, not for overfitting. The overfitting cure was the side effect.</a:t>
             </a:r>
           </a:p>
         </p:txBody>
@@ -5462,21 +5487,63 @@
             </a:pPr>
             <a:r>
               <a:rPr/>
-              <a:t>From notebook 3. Left: ridge coefficients approach zero smoothly and never arrive. Right: lasso coefficients hit zero at a finite lambda and stay.</a:t>
-            </a:r>
-          </a:p>
-          <a:p>
-            <a:pPr lvl="0" indent="0" marL="0">
-              <a:buNone/>
-            </a:pPr>
-          </a:p>
-          <a:p>
-            <a:pPr lvl="0" indent="0" marL="0">
-              <a:buNone/>
-            </a:pPr>
-            <a:r>
-              <a:rPr/>
-              <a:t>The housing data again, with all six features scaled, and lambda growing from left to right. Point at the right panel: one by one the lasso lines reach the zero line and stay on it. The next slide reads off the order.</a:t>
+              <a:t>Intuition before algebra again, and this one is worth the time.</a:t>
+            </a:r>
+          </a:p>
+          <a:p>
+            <a:pPr lvl="0" indent="0" marL="0">
+              <a:buNone/>
+            </a:pPr>
+          </a:p>
+          <a:p>
+            <a:pPr lvl="0" indent="0" marL="0">
+              <a:buNone/>
+            </a:pPr>
+            <a:r>
+              <a:rPr/>
+              <a:t>Think of the penalty as a budget: you may spend a fixed total on coefficients and want the best fit that money buys. Draw what you can afford. For two coefficients, charging squares makes the affordable region a disc; charging absolute values makes it a diamond, a square turned to stand on its corners.</a:t>
+            </a:r>
+          </a:p>
+          <a:p>
+            <a:pPr lvl="0" indent="0" marL="0">
+              <a:buNone/>
+            </a:pPr>
+          </a:p>
+          <a:p>
+            <a:pPr lvl="0" indent="0" marL="0">
+              <a:buNone/>
+            </a:pPr>
+            <a:r>
+              <a:rPr/>
+              <a:t>The best affordable fit is where the error contours (the rings of equal cost around the unpenalised answer) first touch the region.</a:t>
+            </a:r>
+          </a:p>
+          <a:p>
+            <a:pPr lvl="0" indent="0" marL="0">
+              <a:buNone/>
+            </a:pPr>
+          </a:p>
+          <a:p>
+            <a:pPr lvl="0" indent="0" marL="0">
+              <a:buNone/>
+            </a:pPr>
+            <a:r>
+              <a:rPr/>
+              <a:t>A disc is smooth, so contact happens at a generic point with both coefficients non-zero. A diamond has corners, its corners lie ON THE AXES, and a corner is a point where one coefficient is exactly zero. Corners stick out, so they get touched first.</a:t>
+            </a:r>
+          </a:p>
+          <a:p>
+            <a:pPr lvl="0" indent="0" marL="0">
+              <a:buNone/>
+            </a:pPr>
+          </a:p>
+          <a:p>
+            <a:pPr lvl="0" indent="0" marL="0">
+              <a:buNone/>
+            </a:pPr>
+            <a:r>
+              <a:rPr/>
+              <a:t>That is the entire reason Lasso produces zeros and Ridge does not. Not a tolerance, not a numerical accident - the shape of the budget.</a:t>
             </a:r>
           </a:p>
         </p:txBody>
@@ -5558,91 +5625,21 @@
             </a:pPr>
             <a:r>
               <a:rPr/>
-              <a:t>The previous picture, now as numbers. Read down the right column.</a:t>
-            </a:r>
-          </a:p>
-          <a:p>
-            <a:pPr lvl="0" indent="0" marL="0">
-              <a:buNone/>
-            </a:pPr>
-          </a:p>
-          <a:p>
-            <a:pPr lvl="0" indent="0" marL="0">
-              <a:buNone/>
-            </a:pPr>
-            <a:r>
-              <a:rPr/>
-              <a:t>The order is not arbitrary and it is worth asking the room to explain it before you do. </a:t>
-            </a:r>
-            <a:r>
-              <a:rPr>
-                <a:latin typeface="Courier"/>
-              </a:rPr>
-              <a:t>garage</a:t>
-            </a:r>
-            <a:r>
-              <a:rPr/>
-              <a:t> goes first because, once every feature is on a common scale, it buys the least accuracy per unit of coefficient spent. </a:t>
-            </a:r>
-            <a:r>
-              <a:rPr>
-                <a:latin typeface="Courier"/>
-              </a:rPr>
-              <a:t>area_sqm</a:t>
-            </a:r>
-            <a:r>
-              <a:rPr/>
-              <a:t> survives longest because it buys the most.</a:t>
-            </a:r>
-          </a:p>
-          <a:p>
-            <a:pPr lvl="0" indent="0" marL="0">
-              <a:buNone/>
-            </a:pPr>
-          </a:p>
-          <a:p>
-            <a:pPr lvl="0" indent="0" marL="0">
-              <a:buNone/>
-            </a:pPr>
-            <a:r>
-              <a:rPr/>
-              <a:t>Nobody told Lasso which features mattered. It was given a budget and told to spend it well, and this ranking fell out of that - which is genuinely remarkable and is why Lasso is used as a feature selector at all.</a:t>
-            </a:r>
-          </a:p>
-          <a:p>
-            <a:pPr lvl="0" indent="0" marL="0">
-              <a:buNone/>
-            </a:pPr>
-          </a:p>
-          <a:p>
-            <a:pPr lvl="0" indent="0" marL="0">
-              <a:buNone/>
-            </a:pPr>
-            <a:r>
-              <a:rPr/>
-              <a:t>Now the warning, and it is the part that gets forgotten in practice: </a:t>
-            </a:r>
-            <a:r>
-              <a:rPr b="1"/>
-              <a:t>the selection depends entirely on lambda</a:t>
-            </a:r>
-            <a:r>
-              <a:rPr/>
-              <a:t>. “Lasso chose these three features” is not a complete statement - at a different lambda it chooses differently. Presenting lasso output as an objective ranking of importance is one of the commonest misuses of it.</a:t>
-            </a:r>
-          </a:p>
-          <a:p>
-            <a:pPr lvl="0" indent="0" marL="0">
-              <a:buNone/>
-            </a:pPr>
-          </a:p>
-          <a:p>
-            <a:pPr lvl="0" indent="0" marL="0">
-              <a:buNone/>
-            </a:pPr>
-            <a:r>
-              <a:rPr/>
-              <a:t>Handout section 6.5.</a:t>
+              <a:t>From notebook 3. Left: ridge coefficients approach zero smoothly and never arrive. Right: lasso coefficients hit zero at a finite lambda and stay.</a:t>
+            </a:r>
+          </a:p>
+          <a:p>
+            <a:pPr lvl="0" indent="0" marL="0">
+              <a:buNone/>
+            </a:pPr>
+          </a:p>
+          <a:p>
+            <a:pPr lvl="0" indent="0" marL="0">
+              <a:buNone/>
+            </a:pPr>
+            <a:r>
+              <a:rPr/>
+              <a:t>The housing data again, with all six features scaled, and lambda growing from left to right. Point at the right panel: one by one the lasso lines reach the zero line and stay on it. The next slide reads off the order.</a:t>
             </a:r>
           </a:p>
         </p:txBody>
@@ -5724,35 +5721,91 @@
             </a:pPr>
             <a:r>
               <a:rPr/>
-              <a:t>The situation from the failure-modes slide, made concrete: someone merged two systems and the same fact arrived twice.</a:t>
-            </a:r>
-          </a:p>
-          <a:p>
-            <a:pPr lvl="0" indent="0" marL="0">
-              <a:buNone/>
-            </a:pPr>
-          </a:p>
-          <a:p>
-            <a:pPr lvl="0" indent="0" marL="0">
-              <a:buNone/>
-            </a:pPr>
-            <a:r>
-              <a:rPr/>
-              <a:t>Ask what least squares should do. The honest answer is that it has no basis for choosing between “all the effect on the metres column” and “all of it on the feet column” and everything in between - they all fit identically.</a:t>
-            </a:r>
-          </a:p>
-          <a:p>
-            <a:pPr lvl="0" indent="0" marL="0">
-              <a:buNone/>
-            </a:pPr>
-          </a:p>
-          <a:p>
-            <a:pPr lvl="0" indent="0" marL="0">
-              <a:buNone/>
-            </a:pPr>
-            <a:r>
-              <a:rPr/>
-              <a:t>So it picks one arbitrarily, and the arbitrariness changes with the sample.</a:t>
+              <a:t>The previous picture, now as numbers. Read down the right column.</a:t>
+            </a:r>
+          </a:p>
+          <a:p>
+            <a:pPr lvl="0" indent="0" marL="0">
+              <a:buNone/>
+            </a:pPr>
+          </a:p>
+          <a:p>
+            <a:pPr lvl="0" indent="0" marL="0">
+              <a:buNone/>
+            </a:pPr>
+            <a:r>
+              <a:rPr/>
+              <a:t>The order is not arbitrary and it is worth asking the room to explain it before you do. </a:t>
+            </a:r>
+            <a:r>
+              <a:rPr>
+                <a:latin typeface="Courier"/>
+              </a:rPr>
+              <a:t>garage</a:t>
+            </a:r>
+            <a:r>
+              <a:rPr/>
+              <a:t> goes first because, once every feature is on a common scale, it buys the least accuracy per unit of coefficient spent. </a:t>
+            </a:r>
+            <a:r>
+              <a:rPr>
+                <a:latin typeface="Courier"/>
+              </a:rPr>
+              <a:t>area_sqm</a:t>
+            </a:r>
+            <a:r>
+              <a:rPr/>
+              <a:t> survives longest because it buys the most.</a:t>
+            </a:r>
+          </a:p>
+          <a:p>
+            <a:pPr lvl="0" indent="0" marL="0">
+              <a:buNone/>
+            </a:pPr>
+          </a:p>
+          <a:p>
+            <a:pPr lvl="0" indent="0" marL="0">
+              <a:buNone/>
+            </a:pPr>
+            <a:r>
+              <a:rPr/>
+              <a:t>Nobody told Lasso which features mattered. It was given a budget and told to spend it well, and this ranking fell out of that - which is genuinely remarkable and is why Lasso is used as a feature selector at all.</a:t>
+            </a:r>
+          </a:p>
+          <a:p>
+            <a:pPr lvl="0" indent="0" marL="0">
+              <a:buNone/>
+            </a:pPr>
+          </a:p>
+          <a:p>
+            <a:pPr lvl="0" indent="0" marL="0">
+              <a:buNone/>
+            </a:pPr>
+            <a:r>
+              <a:rPr/>
+              <a:t>Now the warning, and it is the part that gets forgotten in practice: </a:t>
+            </a:r>
+            <a:r>
+              <a:rPr b="1"/>
+              <a:t>the selection depends entirely on lambda</a:t>
+            </a:r>
+            <a:r>
+              <a:rPr/>
+              <a:t>. “Lasso chose these three features” is not a complete statement - at a different lambda it chooses differently. Presenting lasso output as an objective ranking of importance is one of the commonest misuses of it.</a:t>
+            </a:r>
+          </a:p>
+          <a:p>
+            <a:pPr lvl="0" indent="0" marL="0">
+              <a:buNone/>
+            </a:pPr>
+          </a:p>
+          <a:p>
+            <a:pPr lvl="0" indent="0" marL="0">
+              <a:buNone/>
+            </a:pPr>
+            <a:r>
+              <a:rPr/>
+              <a:t>Handout section 6.5.</a:t>
             </a:r>
           </a:p>
         </p:txBody>
@@ -5834,49 +5887,35 @@
             </a:pPr>
             <a:r>
               <a:rPr/>
-              <a:t>Same dataset, four different random splits. The area coefficient varies by a factor of five, and its duplicate swings the opposite way to compensate.</a:t>
-            </a:r>
-          </a:p>
-          <a:p>
-            <a:pPr lvl="0" indent="0" marL="0">
-              <a:buNone/>
-            </a:pPr>
-          </a:p>
-          <a:p>
-            <a:pPr lvl="0" indent="0" marL="0">
-              <a:buNone/>
-            </a:pPr>
-            <a:r>
-              <a:rPr/>
-              <a:t>Stress what is and is not broken: the PREDICTIONS are fine throughout. What a square metre adds is the metres coefficient plus 10.76 times the feet coefficient, since a square metre is 10.76 square feet, and on every split that sum stays within about 2% of the true 2,400 (the notebook prints 2,424 for its own split). It is the EXPLANATION that is noise.</a:t>
-            </a:r>
-          </a:p>
-          <a:p>
-            <a:pPr lvl="0" indent="0" marL="0">
-              <a:buNone/>
-            </a:pPr>
-          </a:p>
-          <a:p>
-            <a:pPr lvl="0" indent="0" marL="0">
-              <a:buNone/>
-            </a:pPr>
-            <a:r>
-              <a:rPr/>
-              <a:t>Anyone reading these coefficients to learn what drives house prices would draw nonsense, confidently. With ridge at lambda 10 the same four splits give 38,000 to 41,000 on both columns, split evenly. Say the units, or the comparison misleads: ridge runs on scaled features, so these are euros per standard deviation of area, not euros per square metre, and they cannot be set against the table. What matters is that they are stable and equal, because two moderate coefficients cost less under a squared penalty than one huge positive and one huge negative.</a:t>
-            </a:r>
-          </a:p>
-          <a:p>
-            <a:pPr lvl="0" indent="0" marL="0">
-              <a:buNone/>
-            </a:pPr>
-          </a:p>
-          <a:p>
-            <a:pPr lvl="0" indent="0" marL="0">
-              <a:buNone/>
-            </a:pPr>
-            <a:r>
-              <a:rPr/>
-              <a:t>So ridge is not only a cure for overfitting. It is what makes coefficients readable when features overlap - which in real data they always do.</a:t>
+              <a:t>The situation from the failure-modes slide, made concrete: someone merged two systems and the same fact arrived twice.</a:t>
+            </a:r>
+          </a:p>
+          <a:p>
+            <a:pPr lvl="0" indent="0" marL="0">
+              <a:buNone/>
+            </a:pPr>
+          </a:p>
+          <a:p>
+            <a:pPr lvl="0" indent="0" marL="0">
+              <a:buNone/>
+            </a:pPr>
+            <a:r>
+              <a:rPr/>
+              <a:t>Ask what least squares should do. The honest answer is that it has no basis for choosing between “all the effect on the metres column” and “all of it on the feet column” and everything in between - they all fit identically.</a:t>
+            </a:r>
+          </a:p>
+          <a:p>
+            <a:pPr lvl="0" indent="0" marL="0">
+              <a:buNone/>
+            </a:pPr>
+          </a:p>
+          <a:p>
+            <a:pPr lvl="0" indent="0" marL="0">
+              <a:buNone/>
+            </a:pPr>
+            <a:r>
+              <a:rPr/>
+              <a:t>So it picks one arbitrarily, and the arbitrariness changes with the sample.</a:t>
             </a:r>
           </a:p>
         </p:txBody>
@@ -6068,67 +6107,49 @@
             </a:pPr>
             <a:r>
               <a:rPr/>
-              <a:t>That last clause is doing enormous work and is almost always skipped over. Say it slowly, then make it concrete.</a:t>
-            </a:r>
-          </a:p>
-          <a:p>
-            <a:pPr lvl="0" indent="0" marL="0">
-              <a:buNone/>
-            </a:pPr>
-          </a:p>
-          <a:p>
-            <a:pPr lvl="0" indent="0" marL="0">
-              <a:buNone/>
-            </a:pPr>
-            <a:r>
-              <a:rPr/>
-              <a:t>The coefficient on </a:t>
-            </a:r>
-            <a:r>
-              <a:rPr>
-                <a:latin typeface="Courier"/>
-              </a:rPr>
-              <a:t>bedrooms</a:t>
-            </a:r>
-            <a:r>
-              <a:rPr/>
-              <a:t> is not “what a bedroom is worth”. It is what a bedroom is worth </a:t>
-            </a:r>
-            <a:r>
-              <a:rPr i="1"/>
-              <a:t>to a house whose floor area does not change</a:t>
-            </a:r>
-            <a:r>
-              <a:rPr/>
-              <a:t> - which is a strange object. A house that gains a bedroom without gaining any space has had its existing rooms subdivided, and that is a genuinely different proposition from an extra bedroom in an extra 15 square metres.</a:t>
-            </a:r>
-          </a:p>
-          <a:p>
-            <a:pPr lvl="0" indent="0" marL="0">
-              <a:buNone/>
-            </a:pPr>
-          </a:p>
-          <a:p>
-            <a:pPr lvl="0" indent="0" marL="0">
-              <a:buNone/>
-            </a:pPr>
-            <a:r>
-              <a:rPr/>
-              <a:t>Ask the room what the coefficient on bedrooms ought to be for the subdivision version. Plausibly near zero, or negative. The estimate we get, 7,503, is a blend of that and something else - which is the setup for the next slide.</a:t>
-            </a:r>
-          </a:p>
-          <a:p>
-            <a:pPr lvl="0" indent="0" marL="0">
-              <a:buNone/>
-            </a:pPr>
-          </a:p>
-          <a:p>
-            <a:pPr lvl="0" indent="0" marL="0">
-              <a:buNone/>
-            </a:pPr>
-            <a:r>
-              <a:rPr/>
-              <a:t>This is the reason two honest analysts fit the same data, report different coefficients, and are both right: they included different features, so their “held fixed” clauses differ. Handout section 7.1.</a:t>
+              <a:t>Same dataset, four different random splits. The area coefficient varies by a factor of five, and its duplicate swings the opposite way to compensate.</a:t>
+            </a:r>
+          </a:p>
+          <a:p>
+            <a:pPr lvl="0" indent="0" marL="0">
+              <a:buNone/>
+            </a:pPr>
+          </a:p>
+          <a:p>
+            <a:pPr lvl="0" indent="0" marL="0">
+              <a:buNone/>
+            </a:pPr>
+            <a:r>
+              <a:rPr/>
+              <a:t>Stress what is and is not broken: the PREDICTIONS are fine throughout. What a square metre adds is the metres coefficient plus 10.76 times the feet coefficient, since a square metre is 10.76 square feet, and on every split that sum stays within about 2% of the true 2,400 (the notebook prints 2,424 for its own split). It is the EXPLANATION that is noise.</a:t>
+            </a:r>
+          </a:p>
+          <a:p>
+            <a:pPr lvl="0" indent="0" marL="0">
+              <a:buNone/>
+            </a:pPr>
+          </a:p>
+          <a:p>
+            <a:pPr lvl="0" indent="0" marL="0">
+              <a:buNone/>
+            </a:pPr>
+            <a:r>
+              <a:rPr/>
+              <a:t>Anyone reading these coefficients to learn what drives house prices would draw nonsense, confidently. With ridge at lambda 10 the same four splits give 38,000 to 41,000 on both columns, split evenly. Say the units, or the comparison misleads: ridge runs on scaled features, so these are euros per standard deviation of area, not euros per square metre, and they cannot be set against the table. What matters is that they are stable and equal, because two moderate coefficients cost less under a squared penalty than one huge positive and one huge negative.</a:t>
+            </a:r>
+          </a:p>
+          <a:p>
+            <a:pPr lvl="0" indent="0" marL="0">
+              <a:buNone/>
+            </a:pPr>
+          </a:p>
+          <a:p>
+            <a:pPr lvl="0" indent="0" marL="0">
+              <a:buNone/>
+            </a:pPr>
+            <a:r>
+              <a:rPr/>
+              <a:t>So ridge is not only a cure for overfitting. It is what makes coefficients readable when features overlap - which in real data they always do.</a:t>
             </a:r>
           </a:p>
         </p:txBody>
@@ -6210,49 +6231,67 @@
             </a:pPr>
             <a:r>
               <a:rPr/>
-              <a:t>From notebook 1, and this is the slide of the lesson most useful outside it.</a:t>
-            </a:r>
-          </a:p>
-          <a:p>
-            <a:pPr lvl="0" indent="0" marL="0">
-              <a:buNone/>
-            </a:pPr>
-          </a:p>
-          <a:p>
-            <a:pPr lvl="0" indent="0" marL="0">
-              <a:buNone/>
-            </a:pPr>
-            <a:r>
-              <a:rPr/>
-              <a:t>The x axis is how correlated each feature is with area; the y axis is how far its estimated coefficient landed from the truth. Read it from left to right. Three features are uncorrelated with area. Two of them, distance and age, are recovered to within 1%. The third, garage, is 9.6% out: it is a yes-or-no column, so it varies little, and the noise weighs more on its coefficient. Then the correlated ones: bathrooms, correlated 0.49 with area, is 9% out; bedrooms, correlated 0.77, is 17% out.</a:t>
-            </a:r>
-          </a:p>
-          <a:p>
-            <a:pPr lvl="0" indent="0" marL="0">
-              <a:buNone/>
-            </a:pPr>
-          </a:p>
-          <a:p>
-            <a:pPr lvl="0" indent="0" marL="0">
-              <a:buNone/>
-            </a:pPr>
-            <a:r>
-              <a:rPr/>
-              <a:t>State the rule: a coefficient is only as trustworthy as its feature is independent. And on a real dataset the same wobble is there with nothing to reveal it - you would just have a number.</a:t>
-            </a:r>
-          </a:p>
-          <a:p>
-            <a:pPr lvl="0" indent="0" marL="0">
-              <a:buNone/>
-            </a:pPr>
-          </a:p>
-          <a:p>
-            <a:pPr lvl="0" indent="0" marL="0">
-              <a:buNone/>
-            </a:pPr>
-            <a:r>
-              <a:rPr/>
-              <a:t>Then the harder point, briefly: a coefficient is an association, not a causal effect. If houses near the centre are older and dearer, age and distance divide the effect between them however the sample suggests. Neither number tells you what would happen if you moved a house.</a:t>
+              <a:t>That last clause is doing enormous work and is almost always skipped over. Say it slowly, then make it concrete.</a:t>
+            </a:r>
+          </a:p>
+          <a:p>
+            <a:pPr lvl="0" indent="0" marL="0">
+              <a:buNone/>
+            </a:pPr>
+          </a:p>
+          <a:p>
+            <a:pPr lvl="0" indent="0" marL="0">
+              <a:buNone/>
+            </a:pPr>
+            <a:r>
+              <a:rPr/>
+              <a:t>The coefficient on </a:t>
+            </a:r>
+            <a:r>
+              <a:rPr>
+                <a:latin typeface="Courier"/>
+              </a:rPr>
+              <a:t>bedrooms</a:t>
+            </a:r>
+            <a:r>
+              <a:rPr/>
+              <a:t> is not “what a bedroom is worth”. It is what a bedroom is worth </a:t>
+            </a:r>
+            <a:r>
+              <a:rPr i="1"/>
+              <a:t>to a house whose floor area does not change</a:t>
+            </a:r>
+            <a:r>
+              <a:rPr/>
+              <a:t> - which is a strange object. A house that gains a bedroom without gaining any space has had its existing rooms subdivided, and that is a genuinely different proposition from an extra bedroom in an extra 15 square metres.</a:t>
+            </a:r>
+          </a:p>
+          <a:p>
+            <a:pPr lvl="0" indent="0" marL="0">
+              <a:buNone/>
+            </a:pPr>
+          </a:p>
+          <a:p>
+            <a:pPr lvl="0" indent="0" marL="0">
+              <a:buNone/>
+            </a:pPr>
+            <a:r>
+              <a:rPr/>
+              <a:t>Ask the room what the coefficient on bedrooms ought to be for the subdivision version. Plausibly near zero, or negative. The estimate we get, 7,503, is a blend of that and something else - which is the setup for the next slide.</a:t>
+            </a:r>
+          </a:p>
+          <a:p>
+            <a:pPr lvl="0" indent="0" marL="0">
+              <a:buNone/>
+            </a:pPr>
+          </a:p>
+          <a:p>
+            <a:pPr lvl="0" indent="0" marL="0">
+              <a:buNone/>
+            </a:pPr>
+            <a:r>
+              <a:rPr/>
+              <a:t>This is the reason two honest analysts fit the same data, report different coefficients, and are both right: they included different features, so their “held fixed” clauses differ. Handout section 7.1.</a:t>
             </a:r>
           </a:p>
         </p:txBody>
@@ -6334,21 +6373,49 @@
             </a:pPr>
             <a:r>
               <a:rPr/>
-              <a:t>Ridge on the degree-12 fit, the regularisation paths, and the collinear case. 20 minutes. The collinear section is the one to make sure everyone reaches - it is the argument they will need whenever someone asks what a model says drives the outcome.</a:t>
-            </a:r>
-          </a:p>
-          <a:p>
-            <a:pPr lvl="0" indent="0" marL="0">
-              <a:buNone/>
-            </a:pPr>
-          </a:p>
-          <a:p>
-            <a:pPr lvl="0" indent="0" marL="0">
-              <a:buNone/>
-            </a:pPr>
-            <a:r>
-              <a:rPr/>
-              <a:t>The “try this” swaps Ridge for Lasso on the redundant columns. Ask them to predict which way lasso resolves it before running, then to explain why the two penalties disagree. It is a good check of whether the disc-and-diamond picture landed.</a:t>
+              <a:t>From notebook 1, and this is the slide of the lesson most useful outside it.</a:t>
+            </a:r>
+          </a:p>
+          <a:p>
+            <a:pPr lvl="0" indent="0" marL="0">
+              <a:buNone/>
+            </a:pPr>
+          </a:p>
+          <a:p>
+            <a:pPr lvl="0" indent="0" marL="0">
+              <a:buNone/>
+            </a:pPr>
+            <a:r>
+              <a:rPr/>
+              <a:t>The x axis is how correlated each feature is with area; the y axis is how far its estimated coefficient landed from the truth. Read it from left to right. Three features are uncorrelated with area. Two of them, distance and age, are recovered to within 1%. The third, garage, is 9.6% out: it is a yes-or-no column, so it varies little, and the noise weighs more on its coefficient. Then the correlated ones: bathrooms, correlated 0.49 with area, is 9% out; bedrooms, correlated 0.77, is 17% out.</a:t>
+            </a:r>
+          </a:p>
+          <a:p>
+            <a:pPr lvl="0" indent="0" marL="0">
+              <a:buNone/>
+            </a:pPr>
+          </a:p>
+          <a:p>
+            <a:pPr lvl="0" indent="0" marL="0">
+              <a:buNone/>
+            </a:pPr>
+            <a:r>
+              <a:rPr/>
+              <a:t>State the rule: a coefficient is only as trustworthy as its feature is independent. And on a real dataset the same wobble is there with nothing to reveal it - you would just have a number.</a:t>
+            </a:r>
+          </a:p>
+          <a:p>
+            <a:pPr lvl="0" indent="0" marL="0">
+              <a:buNone/>
+            </a:pPr>
+          </a:p>
+          <a:p>
+            <a:pPr lvl="0" indent="0" marL="0">
+              <a:buNone/>
+            </a:pPr>
+            <a:r>
+              <a:rPr/>
+              <a:t>Then the harder point, briefly: a coefficient is an association, not a causal effect. If houses near the centre are older and dearer, age and distance divide the effect between them however the sample suggests. Neither number tells you what would happen if you moved a house.</a:t>
             </a:r>
           </a:p>
         </p:txBody>
@@ -6430,49 +6497,21 @@
             </a:pPr>
             <a:r>
               <a:rPr/>
-              <a:t>Connect the lessons. Lesson 2 prepared data honestly; today we fitted something to it and found that fitting well and explaining well are different goals.</a:t>
-            </a:r>
-          </a:p>
-          <a:p>
-            <a:pPr lvl="0" indent="0" marL="0">
-              <a:buNone/>
-            </a:pPr>
-          </a:p>
-          <a:p>
-            <a:pPr lvl="0" indent="0" marL="0">
-              <a:buNone/>
-            </a:pPr>
-            <a:r>
-              <a:rPr/>
-              <a:t>The one sentence to leave them with: the model that fits your training data best is usually not the one you want.</a:t>
-            </a:r>
-          </a:p>
-          <a:p>
-            <a:pPr lvl="0" indent="0" marL="0">
-              <a:buNone/>
-            </a:pPr>
-          </a:p>
-          <a:p>
-            <a:pPr lvl="0" indent="0" marL="0">
-              <a:buNone/>
-            </a:pPr>
-            <a:r>
-              <a:rPr/>
-              <a:t>And the number to leave them with, repeated from slide 41: a penalty of one hundredth took the largest coefficient from billions to 365 and the test error from 24,656 to 22.8. One number, chosen well, bought all of that.</a:t>
-            </a:r>
-          </a:p>
-          <a:p>
-            <a:pPr lvl="0" indent="0" marL="0">
-              <a:buNone/>
-            </a:pPr>
-          </a:p>
-          <a:p>
-            <a:pPr lvl="0" indent="0" marL="0">
-              <a:buNone/>
-            </a:pPr>
-            <a:r>
-              <a:rPr/>
-              <a:t>Preview lesson 4 in a sentence: same machinery, but the target becomes a category instead of a number - and that single change turns out to require a different cost function, for a reason lesson 4 derives.</a:t>
+              <a:t>Ridge on the degree-12 fit, the regularisation paths, and the collinear case. 20 minutes. The collinear section is the one to make sure everyone reaches - it is the argument they will need whenever someone asks what a model says drives the outcome.</a:t>
+            </a:r>
+          </a:p>
+          <a:p>
+            <a:pPr lvl="0" indent="0" marL="0">
+              <a:buNone/>
+            </a:pPr>
+          </a:p>
+          <a:p>
+            <a:pPr lvl="0" indent="0" marL="0">
+              <a:buNone/>
+            </a:pPr>
+            <a:r>
+              <a:rPr/>
+              <a:t>The “try this” swaps Ridge for Lasso on the redundant columns. Ask them to predict which way lasso resolves it before running, then to explain why the two penalties disagree. It is a good check of whether the disc-and-diamond picture landed.</a:t>
             </a:r>
           </a:p>
         </p:txBody>
@@ -6554,35 +6593,49 @@
             </a:pPr>
             <a:r>
               <a:rPr/>
-              <a:t>Set it explicitly and say when it is discussed. It uses a new dataset, bike sharing demand, so the exploration is theirs to do.</a:t>
-            </a:r>
-          </a:p>
-          <a:p>
-            <a:pPr lvl="0" indent="0" marL="0">
-              <a:buNone/>
-            </a:pPr>
-          </a:p>
-          <a:p>
-            <a:pPr lvl="0" indent="0" marL="0">
-              <a:buNone/>
-            </a:pPr>
-            <a:r>
-              <a:rPr/>
-              <a:t>Point out the two tasks that carry the most marks. Task 4 asks them to justify a choice of lambda without looking at the test set, which is genuinely awkward before lesson 5 and is meant to be: the point is to feel the need for cross-validation before being handed it. Task 6 asks which coefficients they trust and why, which is section 7 of the handout applied.</a:t>
-            </a:r>
-          </a:p>
-          <a:p>
-            <a:pPr lvl="0" indent="0" marL="0">
-              <a:buNone/>
-            </a:pPr>
-          </a:p>
-          <a:p>
-            <a:pPr lvl="0" indent="0" marL="0">
-              <a:buNone/>
-            </a:pPr>
-            <a:r>
-              <a:rPr/>
-              <a:t>As always: at the exam, accuracy alone earns nothing; the reasoning does.</a:t>
+              <a:t>Connect the lessons. Lesson 2 prepared data honestly; today we fitted something to it and found that fitting well and explaining well are different goals.</a:t>
+            </a:r>
+          </a:p>
+          <a:p>
+            <a:pPr lvl="0" indent="0" marL="0">
+              <a:buNone/>
+            </a:pPr>
+          </a:p>
+          <a:p>
+            <a:pPr lvl="0" indent="0" marL="0">
+              <a:buNone/>
+            </a:pPr>
+            <a:r>
+              <a:rPr/>
+              <a:t>The one sentence to leave them with: the model that fits your training data best is usually not the one you want.</a:t>
+            </a:r>
+          </a:p>
+          <a:p>
+            <a:pPr lvl="0" indent="0" marL="0">
+              <a:buNone/>
+            </a:pPr>
+          </a:p>
+          <a:p>
+            <a:pPr lvl="0" indent="0" marL="0">
+              <a:buNone/>
+            </a:pPr>
+            <a:r>
+              <a:rPr/>
+              <a:t>And the number to leave them with, repeated from slide 42: a penalty of one hundredth took the largest coefficient from billions to 365 and the test error from 24,656 to 22.8. One number, chosen well, bought all of that.</a:t>
+            </a:r>
+          </a:p>
+          <a:p>
+            <a:pPr lvl="0" indent="0" marL="0">
+              <a:buNone/>
+            </a:pPr>
+          </a:p>
+          <a:p>
+            <a:pPr lvl="0" indent="0" marL="0">
+              <a:buNone/>
+            </a:pPr>
+            <a:r>
+              <a:rPr/>
+              <a:t>Preview lesson 4 in a sentence: same machinery, but the target becomes a category instead of a number - and that single change turns out to require a different cost function, for a reason lesson 4 derives.</a:t>
             </a:r>
           </a:p>
         </p:txBody>
@@ -6605,6 +6658,116 @@
             <a:fld id="{18BDFEC3-8487-43E8-A154-7C12CBC1FFF2}" type="slidenum">
               <a:rPr lang="en-US"/>
               <a:t>55</a:t>
+            </a:fld>
+            <a:endParaRPr lang="en-US"/>
+          </a:p>
+        </p:txBody>
+      </p:sp>
+    </p:spTree>
+  </p:cSld>
+</p:notes>
+</file>
+
+<file path=ppt/notesSlides/notesSlide55.xml><?xml version="1.0" encoding="utf-8"?>
+<p:notes xmlns:a="http://schemas.openxmlformats.org/drawingml/2006/main" xmlns:r="http://schemas.openxmlformats.org/officeDocument/2006/relationships" xmlns:p="http://schemas.openxmlformats.org/presentationml/2006/main">
+  <p:cSld>
+    <p:spTree>
+      <p:nvGrpSpPr>
+        <p:cNvPr id="1" name=""/>
+        <p:cNvGrpSpPr/>
+        <p:nvPr/>
+      </p:nvGrpSpPr>
+      <p:grpSpPr>
+        <a:xfrm>
+          <a:off x="0" y="0"/>
+          <a:ext cx="0" cy="0"/>
+          <a:chOff x="0" y="0"/>
+          <a:chExt cx="0" cy="0"/>
+        </a:xfrm>
+      </p:grpSpPr>
+      <p:sp>
+        <p:nvSpPr>
+          <p:cNvPr id="2" name="Slide Image Placeholder 1"/>
+          <p:cNvSpPr>
+            <a:spLocks noGrp="1" noRot="1" noChangeAspect="1"/>
+          </p:cNvSpPr>
+          <p:nvPr>
+            <p:ph type="sldImg"/>
+          </p:nvPr>
+        </p:nvSpPr>
+        <p:spPr/>
+      </p:sp>
+      <p:sp>
+        <p:nvSpPr>
+          <p:cNvPr id="3" name="Notes Placeholder 2"/>
+          <p:cNvSpPr>
+            <a:spLocks noGrp="1"/>
+          </p:cNvSpPr>
+          <p:nvPr>
+            <p:ph type="body" idx="1"/>
+          </p:nvPr>
+        </p:nvSpPr>
+        <p:spPr/>
+        <p:txBody>
+          <a:bodyPr/>
+          <a:lstStyle/>
+          <a:p>
+            <a:pPr lvl="0" indent="0" marL="0">
+              <a:buNone/>
+            </a:pPr>
+            <a:r>
+              <a:rPr/>
+              <a:t>Set it explicitly and say when it is discussed. It uses a new dataset, bike sharing demand, so the exploration is theirs to do.</a:t>
+            </a:r>
+          </a:p>
+          <a:p>
+            <a:pPr lvl="0" indent="0" marL="0">
+              <a:buNone/>
+            </a:pPr>
+          </a:p>
+          <a:p>
+            <a:pPr lvl="0" indent="0" marL="0">
+              <a:buNone/>
+            </a:pPr>
+            <a:r>
+              <a:rPr/>
+              <a:t>Point out the two tasks that carry the most marks. Task 4 asks them to justify a choice of lambda without looking at the test set, which is genuinely awkward before lesson 5 and is meant to be: the point is to feel the need for cross-validation before being handed it. Task 6 asks which coefficients they trust and why, which is section 7 of the handout applied.</a:t>
+            </a:r>
+          </a:p>
+          <a:p>
+            <a:pPr lvl="0" indent="0" marL="0">
+              <a:buNone/>
+            </a:pPr>
+          </a:p>
+          <a:p>
+            <a:pPr lvl="0" indent="0" marL="0">
+              <a:buNone/>
+            </a:pPr>
+            <a:r>
+              <a:rPr/>
+              <a:t>As always: at the exam, accuracy alone earns nothing; the reasoning does.</a:t>
+            </a:r>
+          </a:p>
+        </p:txBody>
+      </p:sp>
+      <p:sp>
+        <p:nvSpPr>
+          <p:cNvPr id="4" name="Slide Number Placeholder 3"/>
+          <p:cNvSpPr>
+            <a:spLocks noGrp="1"/>
+          </p:cNvSpPr>
+          <p:nvPr>
+            <p:ph type="sldNum" sz="quarter" idx="10"/>
+          </p:nvPr>
+        </p:nvSpPr>
+        <p:spPr/>
+        <p:txBody>
+          <a:bodyPr/>
+          <a:lstStyle/>
+          <a:p>
+            <a:fld id="{18BDFEC3-8487-43E8-A154-7C12CBC1FFF2}" type="slidenum">
+              <a:rPr lang="en-US"/>
+              <a:t>56</a:t>
             </a:fld>
             <a:endParaRPr lang="en-US"/>
           </a:p>
@@ -12235,14 +12398,14 @@
             </a:pPr>
             <a:r>
               <a:rPr/>
-              <a:t>The update rule</a:t>
+              <a:t>The gradients: one for w, one for b</a:t>
             </a:r>
           </a:p>
         </p:txBody>
       </p:sp>
       <p:pic>
         <p:nvPicPr>
-          <p:cNvPr descr="eq_5ff8726bde.png" id="0" name="Picture 1"/>
+          <p:cNvPr descr="eq_934188232f.png" id="0" name="Picture 1"/>
           <p:cNvPicPr>
             <a:picLocks noGrp="1" noChangeAspect="1"/>
           </p:cNvPicPr>
@@ -12256,8 +12419,8 @@
         </p:blipFill>
         <p:spPr bwMode="auto">
           <a:xfrm>
-            <a:off x="457200" y="2357239"/>
-            <a:ext cx="8229600" cy="977900"/>
+            <a:off x="457200" y="2414389"/>
+            <a:ext cx="8229600" cy="863600"/>
           </a:xfrm>
           <a:prstGeom prst="rect">
             <a:avLst/>
@@ -12276,6 +12439,124 @@
 </file>
 
 <file path=ppt/slides/slide24.xml><?xml version="1.0" encoding="utf-8"?>
+<p:sld xmlns:a="http://schemas.openxmlformats.org/drawingml/2006/main" xmlns:r="http://schemas.openxmlformats.org/officeDocument/2006/relationships" xmlns:p="http://schemas.openxmlformats.org/presentationml/2006/main">
+  <p:cSld>
+    <p:spTree>
+      <p:nvGrpSpPr>
+        <p:cNvPr id="1" name=""/>
+        <p:cNvGrpSpPr/>
+        <p:nvPr/>
+      </p:nvGrpSpPr>
+      <p:grpSpPr>
+        <a:xfrm>
+          <a:off x="0" y="0"/>
+          <a:ext cx="0" cy="0"/>
+          <a:chOff x="0" y="0"/>
+          <a:chExt cx="0" cy="0"/>
+        </a:xfrm>
+      </p:grpSpPr>
+      <p:sp>
+        <p:nvSpPr>
+          <p:cNvPr id="2" name="Title 1"/>
+          <p:cNvSpPr>
+            <a:spLocks noGrp="1"/>
+          </p:cNvSpPr>
+          <p:nvPr>
+            <p:ph type="title"/>
+          </p:nvPr>
+        </p:nvSpPr>
+        <p:spPr>
+          <a:xfrm>
+            <a:off x="457200" y="205979"/>
+            <a:ext cx="8229600" cy="857250"/>
+          </a:xfrm>
+        </p:spPr>
+        <p:txBody>
+          <a:bodyPr/>
+          <a:lstStyle/>
+          <a:p>
+            <a:pPr lvl="0" indent="0" marL="0">
+              <a:buNone/>
+            </a:pPr>
+            <a:r>
+              <a:rPr/>
+              <a:t>One iteration, then the next</a:t>
+            </a:r>
+          </a:p>
+        </p:txBody>
+      </p:sp>
+      <p:sp>
+        <p:nvSpPr>
+          <p:cNvPr id="3" name="Content Placeholder 2"/>
+          <p:cNvSpPr>
+            <a:spLocks noGrp="1"/>
+          </p:cNvSpPr>
+          <p:nvPr>
+            <p:ph idx="1"/>
+          </p:nvPr>
+        </p:nvSpPr>
+        <p:spPr>
+          <a:xfrm>
+            <a:off x="457200" y="1200151"/>
+            <a:ext cx="8229600" cy="3394472"/>
+          </a:xfrm>
+        </p:spPr>
+        <p:txBody>
+          <a:bodyPr/>
+          <a:lstStyle/>
+          <a:p>
+            <a:pPr lvl="0" indent="-342900" marL="342900">
+              <a:buAutoNum type="arabicPeriod"/>
+            </a:pPr>
+            <a:r>
+              <a:rPr/>
+              <a:t>Predict with the current w and b: ŷ⁽ⁱ⁾ = w·x⁽ⁱ⁾ + b</a:t>
+            </a:r>
+          </a:p>
+          <a:p>
+            <a:pPr lvl="0" indent="-342900" marL="342900">
+              <a:buAutoNum type="arabicPeriod"/>
+            </a:pPr>
+            <a:r>
+              <a:rPr/>
+              <a:t>Measure every error: e⁽ⁱ⁾ = ŷ⁽ⁱ⁾ − y⁽ⁱ⁾</a:t>
+            </a:r>
+          </a:p>
+          <a:p>
+            <a:pPr lvl="0" indent="-342900" marL="342900">
+              <a:buAutoNum type="arabicPeriod"/>
+            </a:pPr>
+            <a:r>
+              <a:rPr/>
+              <a:t>Average them into the two gradients of the previous slide</a:t>
+            </a:r>
+          </a:p>
+          <a:p>
+            <a:pPr lvl="0" indent="-342900" marL="342900">
+              <a:buAutoNum type="arabicPeriod"/>
+            </a:pPr>
+            <a:r>
+              <a:rPr/>
+              <a:t>Step both parameters: w ← w − α·∂J/∂w and b ← b − α·∂J/∂b</a:t>
+            </a:r>
+          </a:p>
+          <a:p>
+            <a:pPr lvl="0" indent="-342900" marL="342900">
+              <a:buAutoNum type="arabicPeriod"/>
+            </a:pPr>
+            <a:r>
+              <a:rPr/>
+              <a:t>Back to 1: new w and b give new predictions, so new errors</a:t>
+            </a:r>
+          </a:p>
+        </p:txBody>
+      </p:sp>
+    </p:spTree>
+  </p:cSld>
+</p:sld>
+</file>
+
+<file path=ppt/slides/slide25.xml><?xml version="1.0" encoding="utf-8"?>
 <p:sld xmlns:a="http://schemas.openxmlformats.org/drawingml/2006/main" xmlns:r="http://schemas.openxmlformats.org/officeDocument/2006/relationships" xmlns:p="http://schemas.openxmlformats.org/presentationml/2006/main">
   <p:cSld>
     <p:spTree>
@@ -12500,7 +12781,7 @@
 </p:sld>
 </file>
 
-<file path=ppt/slides/slide25.xml><?xml version="1.0" encoding="utf-8"?>
+<file path=ppt/slides/slide26.xml><?xml version="1.0" encoding="utf-8"?>
 <p:sld xmlns:a="http://schemas.openxmlformats.org/drawingml/2006/main" xmlns:r="http://schemas.openxmlformats.org/officeDocument/2006/relationships" xmlns:p="http://schemas.openxmlformats.org/presentationml/2006/main">
   <p:cSld>
     <p:spTree>
@@ -12582,7 +12863,7 @@
 </p:sld>
 </file>
 
-<file path=ppt/slides/slide26.xml><?xml version="1.0" encoding="utf-8"?>
+<file path=ppt/slides/slide27.xml><?xml version="1.0" encoding="utf-8"?>
 <p:sld xmlns:a="http://schemas.openxmlformats.org/drawingml/2006/main" xmlns:r="http://schemas.openxmlformats.org/officeDocument/2006/relationships" xmlns:p="http://schemas.openxmlformats.org/presentationml/2006/main">
   <p:cSld>
     <p:spTree>
@@ -12664,7 +12945,7 @@
 </p:sld>
 </file>
 
-<file path=ppt/slides/slide27.xml><?xml version="1.0" encoding="utf-8"?>
+<file path=ppt/slides/slide28.xml><?xml version="1.0" encoding="utf-8"?>
 <p:sld xmlns:a="http://schemas.openxmlformats.org/drawingml/2006/main" xmlns:r="http://schemas.openxmlformats.org/officeDocument/2006/relationships" xmlns:p="http://schemas.openxmlformats.org/presentationml/2006/main">
   <p:cSld>
     <p:spTree>
@@ -12860,7 +13141,7 @@
                       </a:pPr>
                       <a:r>
                         <a:rPr/>
-                        <a:t>the iterative answer, 22-26</a:t>
+                        <a:t>the iterative answer, 22-27</a:t>
                       </a:r>
                     </a:p>
                   </a:txBody>
@@ -12892,7 +13173,7 @@
                       </a:pPr>
                       <a:r>
                         <a:rPr/>
-                        <a:t>all six features, 51-52</a:t>
+                        <a:t>all six features, 52-53</a:t>
                       </a:r>
                     </a:p>
                   </a:txBody>
@@ -12976,58 +13257,6 @@
 </p:sld>
 </file>
 
-<file path=ppt/slides/slide28.xml><?xml version="1.0" encoding="utf-8"?>
-<p:sld xmlns:a="http://schemas.openxmlformats.org/drawingml/2006/main" xmlns:r="http://schemas.openxmlformats.org/officeDocument/2006/relationships" xmlns:p="http://schemas.openxmlformats.org/presentationml/2006/main">
-  <p:cSld>
-    <p:spTree>
-      <p:nvGrpSpPr>
-        <p:cNvPr id="1" name=""/>
-        <p:cNvGrpSpPr/>
-        <p:nvPr/>
-      </p:nvGrpSpPr>
-      <p:grpSpPr>
-        <a:xfrm>
-          <a:off x="0" y="0"/>
-          <a:ext cx="0" cy="0"/>
-          <a:chOff x="0" y="0"/>
-          <a:chExt cx="0" cy="0"/>
-        </a:xfrm>
-      </p:grpSpPr>
-      <p:sp>
-        <p:nvSpPr>
-          <p:cNvPr id="2" name="Title 1"/>
-          <p:cNvSpPr>
-            <a:spLocks noGrp="1"/>
-          </p:cNvSpPr>
-          <p:nvPr>
-            <p:ph type="title"/>
-          </p:nvPr>
-        </p:nvSpPr>
-        <p:spPr>
-          <a:xfrm>
-            <a:off x="457200" y="205979"/>
-            <a:ext cx="8229600" cy="857250"/>
-          </a:xfrm>
-        </p:spPr>
-        <p:txBody>
-          <a:bodyPr/>
-          <a:lstStyle/>
-          <a:p>
-            <a:pPr lvl="0" indent="0" marL="0">
-              <a:buNone/>
-            </a:pPr>
-            <a:r>
-              <a:rPr/>
-              <a:t>Break</a:t>
-            </a:r>
-          </a:p>
-        </p:txBody>
-      </p:sp>
-    </p:spTree>
-  </p:cSld>
-</p:sld>
-</file>
-
 <file path=ppt/slides/slide29.xml><?xml version="1.0" encoding="utf-8"?>
 <p:sld xmlns:a="http://schemas.openxmlformats.org/drawingml/2006/main" xmlns:r="http://schemas.openxmlformats.org/officeDocument/2006/relationships" xmlns:p="http://schemas.openxmlformats.org/presentationml/2006/main">
   <p:cSld>
@@ -13070,65 +13299,7 @@
             </a:pPr>
             <a:r>
               <a:rPr/>
-              <a:t>What if the relationship bends?</a:t>
-            </a:r>
-          </a:p>
-        </p:txBody>
-      </p:sp>
-      <p:sp>
-        <p:nvSpPr>
-          <p:cNvPr id="3" name="Content Placeholder 2"/>
-          <p:cNvSpPr>
-            <a:spLocks noGrp="1"/>
-          </p:cNvSpPr>
-          <p:nvPr>
-            <p:ph idx="1"/>
-          </p:nvPr>
-        </p:nvSpPr>
-        <p:spPr>
-          <a:xfrm>
-            <a:off x="457200" y="1200151"/>
-            <a:ext cx="8229600" cy="3394472"/>
-          </a:xfrm>
-        </p:spPr>
-        <p:txBody>
-          <a:bodyPr/>
-          <a:lstStyle/>
-          <a:p>
-            <a:pPr lvl="0" indent="0" marL="0">
-              <a:buNone/>
-            </a:pPr>
-            <a:r>
-              <a:rPr/>
-              <a:t>Energy consumption against temperature: heating in the cold, cooling in the heat.</a:t>
-            </a:r>
-          </a:p>
-          <a:p>
-            <a:pPr lvl="0" indent="0" marL="0">
-              <a:buNone/>
-            </a:pPr>
-            <a:r>
-              <a:rPr/>
-              <a:t>No straight line follows that.</a:t>
-            </a:r>
-          </a:p>
-          <a:p>
-            <a:pPr lvl="0" indent="0" marL="0">
-              <a:buNone/>
-            </a:pPr>
-            <a:r>
-              <a:rPr/>
-              <a:t>In code: </a:t>
-            </a:r>
-            <a:r>
-              <a:rPr>
-                <a:latin typeface="Courier"/>
-              </a:rPr>
-              <a:t>PolynomialFeatures(degree=2)</a:t>
-            </a:r>
-            <a:r>
-              <a:rPr/>
-              <a:t> adds the squared temperature, t², as a second column.</a:t>
+              <a:t>Break</a:t>
             </a:r>
           </a:p>
         </p:txBody>
@@ -13247,6 +13418,116 @@
 </file>
 
 <file path=ppt/slides/slide30.xml><?xml version="1.0" encoding="utf-8"?>
+<p:sld xmlns:a="http://schemas.openxmlformats.org/drawingml/2006/main" xmlns:r="http://schemas.openxmlformats.org/officeDocument/2006/relationships" xmlns:p="http://schemas.openxmlformats.org/presentationml/2006/main">
+  <p:cSld>
+    <p:spTree>
+      <p:nvGrpSpPr>
+        <p:cNvPr id="1" name=""/>
+        <p:cNvGrpSpPr/>
+        <p:nvPr/>
+      </p:nvGrpSpPr>
+      <p:grpSpPr>
+        <a:xfrm>
+          <a:off x="0" y="0"/>
+          <a:ext cx="0" cy="0"/>
+          <a:chOff x="0" y="0"/>
+          <a:chExt cx="0" cy="0"/>
+        </a:xfrm>
+      </p:grpSpPr>
+      <p:sp>
+        <p:nvSpPr>
+          <p:cNvPr id="2" name="Title 1"/>
+          <p:cNvSpPr>
+            <a:spLocks noGrp="1"/>
+          </p:cNvSpPr>
+          <p:nvPr>
+            <p:ph type="title"/>
+          </p:nvPr>
+        </p:nvSpPr>
+        <p:spPr>
+          <a:xfrm>
+            <a:off x="457200" y="205979"/>
+            <a:ext cx="8229600" cy="857250"/>
+          </a:xfrm>
+        </p:spPr>
+        <p:txBody>
+          <a:bodyPr/>
+          <a:lstStyle/>
+          <a:p>
+            <a:pPr lvl="0" indent="0" marL="0">
+              <a:buNone/>
+            </a:pPr>
+            <a:r>
+              <a:rPr/>
+              <a:t>What if the relationship bends?</a:t>
+            </a:r>
+          </a:p>
+        </p:txBody>
+      </p:sp>
+      <p:sp>
+        <p:nvSpPr>
+          <p:cNvPr id="3" name="Content Placeholder 2"/>
+          <p:cNvSpPr>
+            <a:spLocks noGrp="1"/>
+          </p:cNvSpPr>
+          <p:nvPr>
+            <p:ph idx="1"/>
+          </p:nvPr>
+        </p:nvSpPr>
+        <p:spPr>
+          <a:xfrm>
+            <a:off x="457200" y="1200151"/>
+            <a:ext cx="8229600" cy="3394472"/>
+          </a:xfrm>
+        </p:spPr>
+        <p:txBody>
+          <a:bodyPr/>
+          <a:lstStyle/>
+          <a:p>
+            <a:pPr lvl="0" indent="0" marL="0">
+              <a:buNone/>
+            </a:pPr>
+            <a:r>
+              <a:rPr/>
+              <a:t>Energy consumption against temperature: heating in the cold, cooling in the heat.</a:t>
+            </a:r>
+          </a:p>
+          <a:p>
+            <a:pPr lvl="0" indent="0" marL="0">
+              <a:buNone/>
+            </a:pPr>
+            <a:r>
+              <a:rPr/>
+              <a:t>No straight line follows that.</a:t>
+            </a:r>
+          </a:p>
+          <a:p>
+            <a:pPr lvl="0" indent="0" marL="0">
+              <a:buNone/>
+            </a:pPr>
+            <a:r>
+              <a:rPr/>
+              <a:t>In code: </a:t>
+            </a:r>
+            <a:r>
+              <a:rPr>
+                <a:latin typeface="Courier"/>
+              </a:rPr>
+              <a:t>PolynomialFeatures(degree=2)</a:t>
+            </a:r>
+            <a:r>
+              <a:rPr/>
+              <a:t> adds the squared temperature, t², as a second column.</a:t>
+            </a:r>
+          </a:p>
+        </p:txBody>
+      </p:sp>
+    </p:spTree>
+  </p:cSld>
+</p:sld>
+</file>
+
+<file path=ppt/slides/slide31.xml><?xml version="1.0" encoding="utf-8"?>
 <p:sld xmlns:a="http://schemas.openxmlformats.org/drawingml/2006/main" xmlns:r="http://schemas.openxmlformats.org/officeDocument/2006/relationships" xmlns:p="http://schemas.openxmlformats.org/presentationml/2006/main">
   <p:cSld>
     <p:spTree>
@@ -13328,7 +13609,7 @@
 </p:sld>
 </file>
 
-<file path=ppt/slides/slide31.xml><?xml version="1.0" encoding="utf-8"?>
+<file path=ppt/slides/slide32.xml><?xml version="1.0" encoding="utf-8"?>
 <p:sld xmlns:a="http://schemas.openxmlformats.org/drawingml/2006/main" xmlns:r="http://schemas.openxmlformats.org/officeDocument/2006/relationships" xmlns:p="http://schemas.openxmlformats.org/presentationml/2006/main">
   <p:cSld>
     <p:spTree>
@@ -13410,7 +13691,7 @@
 </p:sld>
 </file>
 
-<file path=ppt/slides/slide32.xml><?xml version="1.0" encoding="utf-8"?>
+<file path=ppt/slides/slide33.xml><?xml version="1.0" encoding="utf-8"?>
 <p:sld xmlns:a="http://schemas.openxmlformats.org/drawingml/2006/main" xmlns:r="http://schemas.openxmlformats.org/officeDocument/2006/relationships" xmlns:p="http://schemas.openxmlformats.org/presentationml/2006/main">
   <p:cSld>
     <p:spTree>
@@ -13492,7 +13773,7 @@
 </p:sld>
 </file>
 
-<file path=ppt/slides/slide33.xml><?xml version="1.0" encoding="utf-8"?>
+<file path=ppt/slides/slide34.xml><?xml version="1.0" encoding="utf-8"?>
 <p:sld xmlns:a="http://schemas.openxmlformats.org/drawingml/2006/main" xmlns:r="http://schemas.openxmlformats.org/officeDocument/2006/relationships" xmlns:p="http://schemas.openxmlformats.org/presentationml/2006/main">
   <p:cSld>
     <p:spTree>
@@ -13574,7 +13855,7 @@
 </p:sld>
 </file>
 
-<file path=ppt/slides/slide34.xml><?xml version="1.0" encoding="utf-8"?>
+<file path=ppt/slides/slide35.xml><?xml version="1.0" encoding="utf-8"?>
 <p:sld xmlns:a="http://schemas.openxmlformats.org/drawingml/2006/main" xmlns:r="http://schemas.openxmlformats.org/officeDocument/2006/relationships" xmlns:p="http://schemas.openxmlformats.org/presentationml/2006/main">
   <p:cSld>
     <p:spTree>
@@ -13656,7 +13937,7 @@
 </p:sld>
 </file>
 
-<file path=ppt/slides/slide35.xml><?xml version="1.0" encoding="utf-8"?>
+<file path=ppt/slides/slide36.xml><?xml version="1.0" encoding="utf-8"?>
 <p:sld xmlns:a="http://schemas.openxmlformats.org/drawingml/2006/main" xmlns:r="http://schemas.openxmlformats.org/officeDocument/2006/relationships" xmlns:p="http://schemas.openxmlformats.org/presentationml/2006/main">
   <p:cSld>
     <p:spTree>
@@ -13975,7 +14256,7 @@
 </p:sld>
 </file>
 
-<file path=ppt/slides/slide36.xml><?xml version="1.0" encoding="utf-8"?>
+<file path=ppt/slides/slide37.xml><?xml version="1.0" encoding="utf-8"?>
 <p:sld xmlns:a="http://schemas.openxmlformats.org/drawingml/2006/main" xmlns:r="http://schemas.openxmlformats.org/officeDocument/2006/relationships" xmlns:p="http://schemas.openxmlformats.org/presentationml/2006/main">
   <p:cSld>
     <p:spTree>
@@ -14057,7 +14338,7 @@
 </p:sld>
 </file>
 
-<file path=ppt/slides/slide37.xml><?xml version="1.0" encoding="utf-8"?>
+<file path=ppt/slides/slide38.xml><?xml version="1.0" encoding="utf-8"?>
 <p:sld xmlns:a="http://schemas.openxmlformats.org/drawingml/2006/main" xmlns:r="http://schemas.openxmlformats.org/officeDocument/2006/relationships" xmlns:p="http://schemas.openxmlformats.org/presentationml/2006/main">
   <p:cSld>
     <p:spTree>
@@ -14173,7 +14454,7 @@
                       </a:pPr>
                       <a:r>
                         <a:rPr/>
-                        <a:t>a relationship that bends, 29-30</a:t>
+                        <a:t>a relationship that bends, 30-31</a:t>
                       </a:r>
                     </a:p>
                   </a:txBody>
@@ -14211,7 +14492,7 @@
                       </a:pPr>
                       <a:r>
                         <a:rPr/>
-                        <a:t>linear in the coefficients, 31-33</a:t>
+                        <a:t>linear in the coefficients, 32-34</a:t>
                       </a:r>
                     </a:p>
                   </a:txBody>
@@ -14275,7 +14556,7 @@
                       </a:pPr>
                       <a:r>
                         <a:rPr/>
-                        <a:t>too much flexibility, 34-36</a:t>
+                        <a:t>too much flexibility, 35-37</a:t>
                       </a:r>
                     </a:p>
                   </a:txBody>
@@ -14313,7 +14594,7 @@
                       </a:pPr>
                       <a:r>
                         <a:rPr/>
-                        <a:t>why the wiggles appear, 38</a:t>
+                        <a:t>why the wiggles appear, 39</a:t>
                       </a:r>
                     </a:p>
                   </a:txBody>
@@ -14343,7 +14624,7 @@
 </p:sld>
 </file>
 
-<file path=ppt/slides/slide38.xml><?xml version="1.0" encoding="utf-8"?>
+<file path=ppt/slides/slide39.xml><?xml version="1.0" encoding="utf-8"?>
 <p:sld xmlns:a="http://schemas.openxmlformats.org/drawingml/2006/main" xmlns:r="http://schemas.openxmlformats.org/officeDocument/2006/relationships" xmlns:p="http://schemas.openxmlformats.org/presentationml/2006/main">
   <p:cSld>
     <p:spTree>
@@ -14442,7 +14723,117 @@
 </p:sld>
 </file>
 
-<file path=ppt/slides/slide39.xml><?xml version="1.0" encoding="utf-8"?>
+<file path=ppt/slides/slide4.xml><?xml version="1.0" encoding="utf-8"?>
+<p:sld xmlns:a="http://schemas.openxmlformats.org/drawingml/2006/main" xmlns:r="http://schemas.openxmlformats.org/officeDocument/2006/relationships" xmlns:p="http://schemas.openxmlformats.org/presentationml/2006/main">
+  <p:cSld>
+    <p:spTree>
+      <p:nvGrpSpPr>
+        <p:cNvPr id="1" name=""/>
+        <p:cNvGrpSpPr/>
+        <p:nvPr/>
+      </p:nvGrpSpPr>
+      <p:grpSpPr>
+        <a:xfrm>
+          <a:off x="0" y="0"/>
+          <a:ext cx="0" cy="0"/>
+          <a:chOff x="0" y="0"/>
+          <a:chExt cx="0" cy="0"/>
+        </a:xfrm>
+      </p:grpSpPr>
+      <p:sp>
+        <p:nvSpPr>
+          <p:cNvPr id="2" name="Title 1"/>
+          <p:cNvSpPr>
+            <a:spLocks noGrp="1"/>
+          </p:cNvSpPr>
+          <p:nvPr>
+            <p:ph type="title"/>
+          </p:nvPr>
+        </p:nvSpPr>
+        <p:spPr>
+          <a:xfrm>
+            <a:off x="457200" y="205979"/>
+            <a:ext cx="8229600" cy="857250"/>
+          </a:xfrm>
+        </p:spPr>
+        <p:txBody>
+          <a:bodyPr/>
+          <a:lstStyle/>
+          <a:p>
+            <a:pPr lvl="0" indent="0" marL="0">
+              <a:buNone/>
+            </a:pPr>
+            <a:r>
+              <a:rPr/>
+              <a:t>One dataset, all lesson</a:t>
+            </a:r>
+          </a:p>
+        </p:txBody>
+      </p:sp>
+      <p:sp>
+        <p:nvSpPr>
+          <p:cNvPr id="3" name="Content Placeholder 2"/>
+          <p:cNvSpPr>
+            <a:spLocks noGrp="1"/>
+          </p:cNvSpPr>
+          <p:nvPr>
+            <p:ph idx="1"/>
+          </p:nvPr>
+        </p:nvSpPr>
+        <p:spPr>
+          <a:xfrm>
+            <a:off x="457200" y="1200151"/>
+            <a:ext cx="8229600" cy="3394472"/>
+          </a:xfrm>
+        </p:spPr>
+        <p:txBody>
+          <a:bodyPr/>
+          <a:lstStyle/>
+          <a:p>
+            <a:pPr lvl="0" indent="0" marL="0">
+              <a:buNone/>
+            </a:pPr>
+            <a:r>
+              <a:rPr/>
+              <a:t>600 houses. Six measurements. A price.</a:t>
+            </a:r>
+          </a:p>
+          <a:p>
+            <a:pPr lvl="0" indent="0" marL="0">
+              <a:buNone/>
+            </a:pPr>
+            <a:r>
+              <a:rPr b="1"/>
+              <a:t>And we know the coefficients that generated it.</a:t>
+            </a:r>
+          </a:p>
+          <a:p>
+            <a:pPr lvl="0" indent="0" marL="0">
+              <a:buNone/>
+            </a:pPr>
+            <a:r>
+              <a:rPr/>
+              <a:t>In code: </a:t>
+            </a:r>
+            <a:r>
+              <a:rPr>
+                <a:latin typeface="Courier"/>
+              </a:rPr>
+              <a:t>train_test_split(X, y, test_size=0.25)</a:t>
+            </a:r>
+            <a:r>
+              <a:rPr/>
+              <a:t> keeps 150 houses for testing.</a:t>
+            </a:r>
+          </a:p>
+        </p:txBody>
+      </p:sp>
+    </p:spTree>
+  </p:cSld>
+</p:sld>
+</file>
+
+<file path=ppt/slides/slide40.xml><?xml version="1.0" encoding="utf-8"?>
 <p:sld xmlns:a="http://schemas.openxmlformats.org/drawingml/2006/main" xmlns:r="http://schemas.openxmlformats.org/officeDocument/2006/relationships" xmlns:p="http://schemas.openxmlformats.org/presentationml/2006/main">
   <p:cSld>
     <p:spTree>
@@ -14524,7 +14915,7 @@
 </p:sld>
 </file>
 
-<file path=ppt/slides/slide4.xml><?xml version="1.0" encoding="utf-8"?>
+<file path=ppt/slides/slide41.xml><?xml version="1.0" encoding="utf-8"?>
 <p:sld xmlns:a="http://schemas.openxmlformats.org/drawingml/2006/main" xmlns:r="http://schemas.openxmlformats.org/officeDocument/2006/relationships" xmlns:p="http://schemas.openxmlformats.org/presentationml/2006/main">
   <p:cSld>
     <p:spTree>
@@ -14566,7 +14957,7 @@
             </a:pPr>
             <a:r>
               <a:rPr/>
-              <a:t>One dataset, all lesson</a:t>
+              <a:t>Two rules that are not optional</a:t>
             </a:r>
           </a:p>
         </p:txBody>
@@ -14591,27 +14982,37 @@
           <a:bodyPr/>
           <a:lstStyle/>
           <a:p>
-            <a:pPr lvl="0" indent="0" marL="0">
-              <a:buNone/>
-            </a:pPr>
-            <a:r>
-              <a:rPr/>
-              <a:t>600 houses. Six measurements. A price.</a:t>
-            </a:r>
-          </a:p>
-          <a:p>
-            <a:pPr lvl="0" indent="0" marL="0">
-              <a:buNone/>
-            </a:pPr>
+            <a:pPr lvl="0"/>
+            <a:r>
+              <a:rPr/>
+              <a:t>The </a:t>
+            </a:r>
             <a:r>
               <a:rPr b="1"/>
-              <a:t>And we know the coefficients that generated it.</a:t>
-            </a:r>
-          </a:p>
-          <a:p>
-            <a:pPr lvl="0" indent="0" marL="0">
-              <a:buNone/>
-            </a:pPr>
+              <a:t>intercept is never penalised</a:t>
+            </a:r>
+            <a:r>
+              <a:rPr/>
+              <a:t>: it is not a claim about any feature</a:t>
+            </a:r>
+          </a:p>
+          <a:p>
+            <a:pPr lvl="0"/>
+            <a:r>
+              <a:rPr/>
+              <a:t>Features </a:t>
+            </a:r>
+            <a:r>
+              <a:rPr b="1"/>
+              <a:t>must be scaled first</a:t>
+            </a:r>
+            <a:r>
+              <a:rPr/>
+              <a:t>, or the penalty is arbitrary</a:t>
+            </a:r>
+          </a:p>
+          <a:p>
+            <a:pPr lvl="0"/>
             <a:r>
               <a:rPr/>
               <a:t>In code: </a:t>
@@ -14620,11 +15021,17 @@
               <a:rPr>
                 <a:latin typeface="Courier"/>
               </a:rPr>
-              <a:t>train_test_split(X, y, test_size=0.25)</a:t>
-            </a:r>
-            <a:r>
-              <a:rPr/>
-              <a:t> keeps 150 houses for testing.</a:t>
+              <a:t>make_pipeline(StandardScaler(), Ridge(alpha=0.01))</a:t>
+            </a:r>
+            <a:r>
+              <a:rPr/>
+              <a:t>; scikit-learn calls λ </a:t>
+            </a:r>
+            <a:r>
+              <a:rPr>
+                <a:latin typeface="Courier"/>
+              </a:rPr>
+              <a:t>alpha</a:t>
             </a:r>
           </a:p>
         </p:txBody>
@@ -14634,133 +15041,7 @@
 </p:sld>
 </file>
 
-<file path=ppt/slides/slide40.xml><?xml version="1.0" encoding="utf-8"?>
-<p:sld xmlns:a="http://schemas.openxmlformats.org/drawingml/2006/main" xmlns:r="http://schemas.openxmlformats.org/officeDocument/2006/relationships" xmlns:p="http://schemas.openxmlformats.org/presentationml/2006/main">
-  <p:cSld>
-    <p:spTree>
-      <p:nvGrpSpPr>
-        <p:cNvPr id="1" name=""/>
-        <p:cNvGrpSpPr/>
-        <p:nvPr/>
-      </p:nvGrpSpPr>
-      <p:grpSpPr>
-        <a:xfrm>
-          <a:off x="0" y="0"/>
-          <a:ext cx="0" cy="0"/>
-          <a:chOff x="0" y="0"/>
-          <a:chExt cx="0" cy="0"/>
-        </a:xfrm>
-      </p:grpSpPr>
-      <p:sp>
-        <p:nvSpPr>
-          <p:cNvPr id="2" name="Title 1"/>
-          <p:cNvSpPr>
-            <a:spLocks noGrp="1"/>
-          </p:cNvSpPr>
-          <p:nvPr>
-            <p:ph type="title"/>
-          </p:nvPr>
-        </p:nvSpPr>
-        <p:spPr>
-          <a:xfrm>
-            <a:off x="457200" y="205979"/>
-            <a:ext cx="8229600" cy="857250"/>
-          </a:xfrm>
-        </p:spPr>
-        <p:txBody>
-          <a:bodyPr/>
-          <a:lstStyle/>
-          <a:p>
-            <a:pPr lvl="0" indent="0" marL="0">
-              <a:buNone/>
-            </a:pPr>
-            <a:r>
-              <a:rPr/>
-              <a:t>Two rules that are not optional</a:t>
-            </a:r>
-          </a:p>
-        </p:txBody>
-      </p:sp>
-      <p:sp>
-        <p:nvSpPr>
-          <p:cNvPr id="3" name="Content Placeholder 2"/>
-          <p:cNvSpPr>
-            <a:spLocks noGrp="1"/>
-          </p:cNvSpPr>
-          <p:nvPr>
-            <p:ph idx="1"/>
-          </p:nvPr>
-        </p:nvSpPr>
-        <p:spPr>
-          <a:xfrm>
-            <a:off x="457200" y="1200151"/>
-            <a:ext cx="8229600" cy="3394472"/>
-          </a:xfrm>
-        </p:spPr>
-        <p:txBody>
-          <a:bodyPr/>
-          <a:lstStyle/>
-          <a:p>
-            <a:pPr lvl="0"/>
-            <a:r>
-              <a:rPr/>
-              <a:t>The </a:t>
-            </a:r>
-            <a:r>
-              <a:rPr b="1"/>
-              <a:t>intercept is never penalised</a:t>
-            </a:r>
-            <a:r>
-              <a:rPr/>
-              <a:t>: it is not a claim about any feature</a:t>
-            </a:r>
-          </a:p>
-          <a:p>
-            <a:pPr lvl="0"/>
-            <a:r>
-              <a:rPr/>
-              <a:t>Features </a:t>
-            </a:r>
-            <a:r>
-              <a:rPr b="1"/>
-              <a:t>must be scaled first</a:t>
-            </a:r>
-            <a:r>
-              <a:rPr/>
-              <a:t>, or the penalty is arbitrary</a:t>
-            </a:r>
-          </a:p>
-          <a:p>
-            <a:pPr lvl="0"/>
-            <a:r>
-              <a:rPr/>
-              <a:t>In code: </a:t>
-            </a:r>
-            <a:r>
-              <a:rPr>
-                <a:latin typeface="Courier"/>
-              </a:rPr>
-              <a:t>make_pipeline(StandardScaler(), Ridge(alpha=0.01))</a:t>
-            </a:r>
-            <a:r>
-              <a:rPr/>
-              <a:t>; scikit-learn calls λ </a:t>
-            </a:r>
-            <a:r>
-              <a:rPr>
-                <a:latin typeface="Courier"/>
-              </a:rPr>
-              <a:t>alpha</a:t>
-            </a:r>
-          </a:p>
-        </p:txBody>
-      </p:sp>
-    </p:spTree>
-  </p:cSld>
-</p:sld>
-</file>
-
-<file path=ppt/slides/slide41.xml><?xml version="1.0" encoding="utf-8"?>
+<file path=ppt/slides/slide42.xml><?xml version="1.0" encoding="utf-8"?>
 <p:sld xmlns:a="http://schemas.openxmlformats.org/drawingml/2006/main" xmlns:r="http://schemas.openxmlformats.org/officeDocument/2006/relationships" xmlns:p="http://schemas.openxmlformats.org/presentationml/2006/main">
   <p:cSld>
     <p:spTree>
@@ -15156,7 +15437,7 @@
 </p:sld>
 </file>
 
-<file path=ppt/slides/slide42.xml><?xml version="1.0" encoding="utf-8"?>
+<file path=ppt/slides/slide43.xml><?xml version="1.0" encoding="utf-8"?>
 <p:sld xmlns:a="http://schemas.openxmlformats.org/drawingml/2006/main" xmlns:r="http://schemas.openxmlformats.org/officeDocument/2006/relationships" xmlns:p="http://schemas.openxmlformats.org/presentationml/2006/main">
   <p:cSld>
     <p:spTree>
@@ -15238,7 +15519,7 @@
 </p:sld>
 </file>
 
-<file path=ppt/slides/slide43.xml><?xml version="1.0" encoding="utf-8"?>
+<file path=ppt/slides/slide44.xml><?xml version="1.0" encoding="utf-8"?>
 <p:sld xmlns:a="http://schemas.openxmlformats.org/drawingml/2006/main" xmlns:r="http://schemas.openxmlformats.org/officeDocument/2006/relationships" xmlns:p="http://schemas.openxmlformats.org/presentationml/2006/main">
   <p:cSld>
     <p:spTree>
@@ -15320,7 +15601,7 @@
 </p:sld>
 </file>
 
-<file path=ppt/slides/slide44.xml><?xml version="1.0" encoding="utf-8"?>
+<file path=ppt/slides/slide45.xml><?xml version="1.0" encoding="utf-8"?>
 <p:sld xmlns:a="http://schemas.openxmlformats.org/drawingml/2006/main" xmlns:r="http://schemas.openxmlformats.org/officeDocument/2006/relationships" xmlns:p="http://schemas.openxmlformats.org/presentationml/2006/main">
   <p:cSld>
     <p:spTree>
@@ -15402,7 +15683,7 @@
 </p:sld>
 </file>
 
-<file path=ppt/slides/slide45.xml><?xml version="1.0" encoding="utf-8"?>
+<file path=ppt/slides/slide46.xml><?xml version="1.0" encoding="utf-8"?>
 <p:sld xmlns:a="http://schemas.openxmlformats.org/drawingml/2006/main" xmlns:r="http://schemas.openxmlformats.org/officeDocument/2006/relationships" xmlns:p="http://schemas.openxmlformats.org/presentationml/2006/main">
   <p:cSld>
     <p:spTree>
@@ -15504,7 +15785,7 @@
 </p:sld>
 </file>
 
-<file path=ppt/slides/slide46.xml><?xml version="1.0" encoding="utf-8"?>
+<file path=ppt/slides/slide47.xml><?xml version="1.0" encoding="utf-8"?>
 <p:sld xmlns:a="http://schemas.openxmlformats.org/drawingml/2006/main" xmlns:r="http://schemas.openxmlformats.org/officeDocument/2006/relationships" xmlns:p="http://schemas.openxmlformats.org/presentationml/2006/main">
   <p:cSld>
     <p:spTree>
@@ -15586,7 +15867,7 @@
 </p:sld>
 </file>
 
-<file path=ppt/slides/slide47.xml><?xml version="1.0" encoding="utf-8"?>
+<file path=ppt/slides/slide48.xml><?xml version="1.0" encoding="utf-8"?>
 <p:sld xmlns:a="http://schemas.openxmlformats.org/drawingml/2006/main" xmlns:r="http://schemas.openxmlformats.org/officeDocument/2006/relationships" xmlns:p="http://schemas.openxmlformats.org/presentationml/2006/main">
   <p:cSld>
     <p:spTree>
@@ -15668,7 +15949,7 @@
 </p:sld>
 </file>
 
-<file path=ppt/slides/slide48.xml><?xml version="1.0" encoding="utf-8"?>
+<file path=ppt/slides/slide49.xml><?xml version="1.0" encoding="utf-8"?>
 <p:sld xmlns:a="http://schemas.openxmlformats.org/drawingml/2006/main" xmlns:r="http://schemas.openxmlformats.org/officeDocument/2006/relationships" xmlns:p="http://schemas.openxmlformats.org/presentationml/2006/main">
   <p:cSld>
     <p:spTree>
@@ -15952,117 +16233,6 @@
 </p:sld>
 </file>
 
-<file path=ppt/slides/slide49.xml><?xml version="1.0" encoding="utf-8"?>
-<p:sld xmlns:a="http://schemas.openxmlformats.org/drawingml/2006/main" xmlns:r="http://schemas.openxmlformats.org/officeDocument/2006/relationships" xmlns:p="http://schemas.openxmlformats.org/presentationml/2006/main">
-  <p:cSld>
-    <p:spTree>
-      <p:nvGrpSpPr>
-        <p:cNvPr id="1" name=""/>
-        <p:cNvGrpSpPr/>
-        <p:nvPr/>
-      </p:nvGrpSpPr>
-      <p:grpSpPr>
-        <a:xfrm>
-          <a:off x="0" y="0"/>
-          <a:ext cx="0" cy="0"/>
-          <a:chOff x="0" y="0"/>
-          <a:chExt cx="0" cy="0"/>
-        </a:xfrm>
-      </p:grpSpPr>
-      <p:sp>
-        <p:nvSpPr>
-          <p:cNvPr id="2" name="Title 1"/>
-          <p:cNvSpPr>
-            <a:spLocks noGrp="1"/>
-          </p:cNvSpPr>
-          <p:nvPr>
-            <p:ph type="title"/>
-          </p:nvPr>
-        </p:nvSpPr>
-        <p:spPr>
-          <a:xfrm>
-            <a:off x="457200" y="205979"/>
-            <a:ext cx="8229600" cy="857250"/>
-          </a:xfrm>
-        </p:spPr>
-        <p:txBody>
-          <a:bodyPr/>
-          <a:lstStyle/>
-          <a:p>
-            <a:pPr lvl="0" indent="0" marL="0">
-              <a:buNone/>
-            </a:pPr>
-            <a:r>
-              <a:rPr/>
-              <a:t>The case Ridge was invented for</a:t>
-            </a:r>
-          </a:p>
-        </p:txBody>
-      </p:sp>
-      <p:sp>
-        <p:nvSpPr>
-          <p:cNvPr id="3" name="Content Placeholder 2"/>
-          <p:cNvSpPr>
-            <a:spLocks noGrp="1"/>
-          </p:cNvSpPr>
-          <p:nvPr>
-            <p:ph idx="1"/>
-          </p:nvPr>
-        </p:nvSpPr>
-        <p:spPr>
-          <a:xfrm>
-            <a:off x="457200" y="1200151"/>
-            <a:ext cx="8229600" cy="3394472"/>
-          </a:xfrm>
-        </p:spPr>
-        <p:txBody>
-          <a:bodyPr/>
-          <a:lstStyle/>
-          <a:p>
-            <a:pPr lvl="0" indent="0" marL="0">
-              <a:buNone/>
-            </a:pPr>
-            <a:r>
-              <a:rPr>
-                <a:latin typeface="Courier"/>
-              </a:rPr>
-              <a:t>area_sqm</a:t>
-            </a:r>
-            <a:r>
-              <a:rPr/>
-              <a:t> and </a:t>
-            </a:r>
-            <a:r>
-              <a:rPr>
-                <a:latin typeface="Courier"/>
-              </a:rPr>
-              <a:t>area_sqft</a:t>
-            </a:r>
-            <a:r>
-              <a:rPr/>
-              <a:t>: the same measurement, two units.</a:t>
-            </a:r>
-          </a:p>
-          <a:p>
-            <a:pPr lvl="0" indent="0" marL="0">
-              <a:buNone/>
-            </a:pPr>
-            <a:r>
-              <a:rPr/>
-              <a:t>Correlation: </a:t>
-            </a:r>
-            <a:r>
-              <a:rPr b="1"/>
-              <a:t>0.999999</a:t>
-            </a:r>
-          </a:p>
-        </p:txBody>
-      </p:sp>
-    </p:spTree>
-  </p:cSld>
-</p:sld>
-</file>
-
 <file path=ppt/slides/slide5.xml><?xml version="1.0" encoding="utf-8"?>
 <p:sld xmlns:a="http://schemas.openxmlformats.org/drawingml/2006/main" xmlns:r="http://schemas.openxmlformats.org/officeDocument/2006/relationships" xmlns:p="http://schemas.openxmlformats.org/presentationml/2006/main">
   <p:cSld>
@@ -16146,6 +16316,117 @@
 </file>
 
 <file path=ppt/slides/slide50.xml><?xml version="1.0" encoding="utf-8"?>
+<p:sld xmlns:a="http://schemas.openxmlformats.org/drawingml/2006/main" xmlns:r="http://schemas.openxmlformats.org/officeDocument/2006/relationships" xmlns:p="http://schemas.openxmlformats.org/presentationml/2006/main">
+  <p:cSld>
+    <p:spTree>
+      <p:nvGrpSpPr>
+        <p:cNvPr id="1" name=""/>
+        <p:cNvGrpSpPr/>
+        <p:nvPr/>
+      </p:nvGrpSpPr>
+      <p:grpSpPr>
+        <a:xfrm>
+          <a:off x="0" y="0"/>
+          <a:ext cx="0" cy="0"/>
+          <a:chOff x="0" y="0"/>
+          <a:chExt cx="0" cy="0"/>
+        </a:xfrm>
+      </p:grpSpPr>
+      <p:sp>
+        <p:nvSpPr>
+          <p:cNvPr id="2" name="Title 1"/>
+          <p:cNvSpPr>
+            <a:spLocks noGrp="1"/>
+          </p:cNvSpPr>
+          <p:nvPr>
+            <p:ph type="title"/>
+          </p:nvPr>
+        </p:nvSpPr>
+        <p:spPr>
+          <a:xfrm>
+            <a:off x="457200" y="205979"/>
+            <a:ext cx="8229600" cy="857250"/>
+          </a:xfrm>
+        </p:spPr>
+        <p:txBody>
+          <a:bodyPr/>
+          <a:lstStyle/>
+          <a:p>
+            <a:pPr lvl="0" indent="0" marL="0">
+              <a:buNone/>
+            </a:pPr>
+            <a:r>
+              <a:rPr/>
+              <a:t>The case Ridge was invented for</a:t>
+            </a:r>
+          </a:p>
+        </p:txBody>
+      </p:sp>
+      <p:sp>
+        <p:nvSpPr>
+          <p:cNvPr id="3" name="Content Placeholder 2"/>
+          <p:cNvSpPr>
+            <a:spLocks noGrp="1"/>
+          </p:cNvSpPr>
+          <p:nvPr>
+            <p:ph idx="1"/>
+          </p:nvPr>
+        </p:nvSpPr>
+        <p:spPr>
+          <a:xfrm>
+            <a:off x="457200" y="1200151"/>
+            <a:ext cx="8229600" cy="3394472"/>
+          </a:xfrm>
+        </p:spPr>
+        <p:txBody>
+          <a:bodyPr/>
+          <a:lstStyle/>
+          <a:p>
+            <a:pPr lvl="0" indent="0" marL="0">
+              <a:buNone/>
+            </a:pPr>
+            <a:r>
+              <a:rPr>
+                <a:latin typeface="Courier"/>
+              </a:rPr>
+              <a:t>area_sqm</a:t>
+            </a:r>
+            <a:r>
+              <a:rPr/>
+              <a:t> and </a:t>
+            </a:r>
+            <a:r>
+              <a:rPr>
+                <a:latin typeface="Courier"/>
+              </a:rPr>
+              <a:t>area_sqft</a:t>
+            </a:r>
+            <a:r>
+              <a:rPr/>
+              <a:t>: the same measurement, two units.</a:t>
+            </a:r>
+          </a:p>
+          <a:p>
+            <a:pPr lvl="0" indent="0" marL="0">
+              <a:buNone/>
+            </a:pPr>
+            <a:r>
+              <a:rPr/>
+              <a:t>Correlation: </a:t>
+            </a:r>
+            <a:r>
+              <a:rPr b="1"/>
+              <a:t>0.999999</a:t>
+            </a:r>
+          </a:p>
+        </p:txBody>
+      </p:sp>
+    </p:spTree>
+  </p:cSld>
+</p:sld>
+</file>
+
+<file path=ppt/slides/slide51.xml><?xml version="1.0" encoding="utf-8"?>
 <p:sld xmlns:a="http://schemas.openxmlformats.org/drawingml/2006/main" xmlns:r="http://schemas.openxmlformats.org/officeDocument/2006/relationships" xmlns:p="http://schemas.openxmlformats.org/presentationml/2006/main">
   <p:cSld>
     <p:spTree>
@@ -16464,7 +16745,7 @@
 </p:sld>
 </file>
 
-<file path=ppt/slides/slide51.xml><?xml version="1.0" encoding="utf-8"?>
+<file path=ppt/slides/slide52.xml><?xml version="1.0" encoding="utf-8"?>
 <p:sld xmlns:a="http://schemas.openxmlformats.org/drawingml/2006/main" xmlns:r="http://schemas.openxmlformats.org/officeDocument/2006/relationships" xmlns:p="http://schemas.openxmlformats.org/presentationml/2006/main">
   <p:cSld>
     <p:spTree>
@@ -16554,7 +16835,7 @@
 </p:sld>
 </file>
 
-<file path=ppt/slides/slide52.xml><?xml version="1.0" encoding="utf-8"?>
+<file path=ppt/slides/slide53.xml><?xml version="1.0" encoding="utf-8"?>
 <p:sld xmlns:a="http://schemas.openxmlformats.org/drawingml/2006/main" xmlns:r="http://schemas.openxmlformats.org/officeDocument/2006/relationships" xmlns:p="http://schemas.openxmlformats.org/presentationml/2006/main">
   <p:cSld>
     <p:spTree>
@@ -16636,7 +16917,7 @@
 </p:sld>
 </file>
 
-<file path=ppt/slides/slide53.xml><?xml version="1.0" encoding="utf-8"?>
+<file path=ppt/slides/slide54.xml><?xml version="1.0" encoding="utf-8"?>
 <p:sld xmlns:a="http://schemas.openxmlformats.org/drawingml/2006/main" xmlns:r="http://schemas.openxmlformats.org/officeDocument/2006/relationships" xmlns:p="http://schemas.openxmlformats.org/presentationml/2006/main">
   <p:cSld>
     <p:spTree>
@@ -16752,7 +17033,7 @@
                       </a:pPr>
                       <a:r>
                         <a:rPr/>
-                        <a:t>Ridge on the degree-12 fit, 39-43</a:t>
+                        <a:t>Ridge on the degree-12 fit, 40-44</a:t>
                       </a:r>
                     </a:p>
                   </a:txBody>
@@ -16810,7 +17091,7 @@
                       </a:pPr>
                       <a:r>
                         <a:rPr/>
-                        <a:t>regularisation paths, 46-48</a:t>
+                        <a:t>regularisation paths, 47-49</a:t>
                       </a:r>
                     </a:p>
                   </a:txBody>
@@ -16858,7 +17139,7 @@
                       </a:pPr>
                       <a:r>
                         <a:rPr/>
-                        <a:t>the collinear case, 49-50</a:t>
+                        <a:t>the collinear case, 50-51</a:t>
                       </a:r>
                     </a:p>
                   </a:txBody>
@@ -16904,7 +17185,7 @@
 </p:sld>
 </file>
 
-<file path=ppt/slides/slide54.xml><?xml version="1.0" encoding="utf-8"?>
+<file path=ppt/slides/slide55.xml><?xml version="1.0" encoding="utf-8"?>
 <p:sld xmlns:a="http://schemas.openxmlformats.org/drawingml/2006/main" xmlns:r="http://schemas.openxmlformats.org/officeDocument/2006/relationships" xmlns:p="http://schemas.openxmlformats.org/presentationml/2006/main">
   <p:cSld>
     <p:spTree>
@@ -17023,7 +17304,7 @@
 </p:sld>
 </file>
 
-<file path=ppt/slides/slide55.xml><?xml version="1.0" encoding="utf-8"?>
+<file path=ppt/slides/slide56.xml><?xml version="1.0" encoding="utf-8"?>
 <p:sld xmlns:a="http://schemas.openxmlformats.org/drawingml/2006/main" xmlns:r="http://schemas.openxmlformats.org/officeDocument/2006/relationships" xmlns:p="http://schemas.openxmlformats.org/presentationml/2006/main">
   <p:cSld>
     <p:spTree>

</xml_diff>